<commit_message>
Keep prediction prompt clear in bilingual teacher slides
</commit_message>
<xml_diff>
--- a/teacher-slides.pptx
+++ b/teacher-slides.pptx
@@ -2,22 +2,22 @@
 <file path=ppt/presentation.xml><?xml version="1.0" encoding="utf-8"?>
 <p:presentation xmlns:p="http://schemas.openxmlformats.org/presentationml/2006/main">
   <p:sldMasterIdLst>
-    <p:sldMasterId xmlns:r="http://schemas.openxmlformats.org/officeDocument/2006/relationships" id="2147483648" r:id="R345bc7fda9774395"/>
+    <p:sldMasterId xmlns:r="http://schemas.openxmlformats.org/officeDocument/2006/relationships" id="2147483648" r:id="Rd4942d0f4c974a87"/>
   </p:sldMasterIdLst>
   <p:notesMasterIdLst>
-    <p:notesMasterId xmlns:r="http://schemas.openxmlformats.org/officeDocument/2006/relationships" r:id="Ra68363e850854760"/>
+    <p:notesMasterId xmlns:r="http://schemas.openxmlformats.org/officeDocument/2006/relationships" r:id="Rf08cb87359924918"/>
   </p:notesMasterIdLst>
   <p:sldIdLst>
-    <p:sldId xmlns:r="http://schemas.openxmlformats.org/officeDocument/2006/relationships" id="256" r:id="Ra57b540e49d24c80"/>
-    <p:sldId xmlns:r="http://schemas.openxmlformats.org/officeDocument/2006/relationships" id="257" r:id="R635c43cf1fae4f47"/>
-    <p:sldId xmlns:r="http://schemas.openxmlformats.org/officeDocument/2006/relationships" id="258" r:id="Radec4cad9c5d4804"/>
-    <p:sldId xmlns:r="http://schemas.openxmlformats.org/officeDocument/2006/relationships" id="259" r:id="R280f9cf4ef754caf"/>
-    <p:sldId xmlns:r="http://schemas.openxmlformats.org/officeDocument/2006/relationships" id="260" r:id="Rdfd13d3316d84334"/>
-    <p:sldId xmlns:r="http://schemas.openxmlformats.org/officeDocument/2006/relationships" id="261" r:id="Rd5a384a06311437d"/>
-    <p:sldId xmlns:r="http://schemas.openxmlformats.org/officeDocument/2006/relationships" id="262" r:id="Rbd8d78b75aad4589"/>
-    <p:sldId xmlns:r="http://schemas.openxmlformats.org/officeDocument/2006/relationships" id="263" r:id="Rec3b51cdf0c947d8"/>
-    <p:sldId xmlns:r="http://schemas.openxmlformats.org/officeDocument/2006/relationships" id="264" r:id="Rb42a5096b30f4cb0"/>
-    <p:sldId xmlns:r="http://schemas.openxmlformats.org/officeDocument/2006/relationships" id="265" r:id="R0725482784e04ea4"/>
+    <p:sldId xmlns:r="http://schemas.openxmlformats.org/officeDocument/2006/relationships" id="256" r:id="R9cdbae44b19b4525"/>
+    <p:sldId xmlns:r="http://schemas.openxmlformats.org/officeDocument/2006/relationships" id="257" r:id="R76d1fb241c644356"/>
+    <p:sldId xmlns:r="http://schemas.openxmlformats.org/officeDocument/2006/relationships" id="258" r:id="Rfcefa56cb3ab40f2"/>
+    <p:sldId xmlns:r="http://schemas.openxmlformats.org/officeDocument/2006/relationships" id="259" r:id="Rbd5f05a04d8d48d6"/>
+    <p:sldId xmlns:r="http://schemas.openxmlformats.org/officeDocument/2006/relationships" id="260" r:id="R80e49bfccffa462e"/>
+    <p:sldId xmlns:r="http://schemas.openxmlformats.org/officeDocument/2006/relationships" id="261" r:id="R117f843f2da24639"/>
+    <p:sldId xmlns:r="http://schemas.openxmlformats.org/officeDocument/2006/relationships" id="262" r:id="R6e21e9e45b32432f"/>
+    <p:sldId xmlns:r="http://schemas.openxmlformats.org/officeDocument/2006/relationships" id="263" r:id="R5757ae864a1745fb"/>
+    <p:sldId xmlns:r="http://schemas.openxmlformats.org/officeDocument/2006/relationships" id="264" r:id="R3e89ff359f614de0"/>
+    <p:sldId xmlns:r="http://schemas.openxmlformats.org/officeDocument/2006/relationships" id="265" r:id="Re1ed38ce6ef84b4b"/>
   </p:sldIdLst>
   <p:sldSz cx="12192000" cy="6858000"/>
   <p:notesSz cx="6858000" cy="9144000"/>
@@ -1149,7 +1149,7 @@
   </p:cSld>
   <p:clrMap bg1="lt1" tx1="dk1" bg2="lt2" tx2="dk2" accent1="accent1" accent2="accent2" accent3="accent3" accent4="accent4" accent5="accent5" accent6="accent6" hlink="hlink" folHlink="folHlink"/>
   <p:sldLayoutIdLst>
-    <p:sldLayoutId xmlns:r="http://schemas.openxmlformats.org/officeDocument/2006/relationships" id="2147483649" r:id="Rc3a5b03d59e04292"/>
+    <p:sldLayoutId xmlns:r="http://schemas.openxmlformats.org/officeDocument/2006/relationships" id="2147483649" r:id="R9f7779e98b1a46ba"/>
   </p:sldLayoutIdLst>
   <p:txStyles>
     <p:titleStyle>
@@ -4202,7 +4202,7 @@
           <p:cNvPr id="13" name="">
             <a:extLst xmlns:a="http://schemas.openxmlformats.org/drawingml/2006/main">
               <a:ext uri="{FF2B5EF4-FFF2-40B4-BE49-F238E27FC236}">
-                <a16:creationId xmlns:a16="http://schemas.microsoft.com/office/drawing/2014/main" id="{D9DA5AE9-1306-4369-BA5A-835F54851820}"/>
+                <a16:creationId xmlns:a16="http://schemas.microsoft.com/office/drawing/2014/main" id="{41E934F9-657C-4C1F-93DD-E73102B52DAC}"/>
               </a:ext>
             </a:extLst>
           </p:cNvPr>
@@ -4259,7 +4259,7 @@
           <p:cNvPr id="2" name="">
             <a:extLst xmlns:a="http://schemas.openxmlformats.org/drawingml/2006/main">
               <a:ext uri="{FF2B5EF4-FFF2-40B4-BE49-F238E27FC236}">
-                <a16:creationId xmlns:a16="http://schemas.microsoft.com/office/drawing/2014/main" id="{B0F33200-4CC0-4CD0-BEAC-4458B1360E24}"/>
+                <a16:creationId xmlns:a16="http://schemas.microsoft.com/office/drawing/2014/main" id="{2DBDC221-675F-4247-A29E-907F4A2564ED}"/>
               </a:ext>
             </a:extLst>
           </p:cNvPr>
@@ -4316,7 +4316,7 @@
           <p:cNvPr id="3" name="">
             <a:extLst xmlns:a="http://schemas.openxmlformats.org/drawingml/2006/main">
               <a:ext uri="{FF2B5EF4-FFF2-40B4-BE49-F238E27FC236}">
-                <a16:creationId xmlns:a16="http://schemas.microsoft.com/office/drawing/2014/main" id="{0C537609-C2F3-4239-8FC5-4F04F4CBFF11}"/>
+                <a16:creationId xmlns:a16="http://schemas.microsoft.com/office/drawing/2014/main" id="{03F8928A-2D14-4F7D-A877-175CC14103B3}"/>
               </a:ext>
             </a:extLst>
           </p:cNvPr>
@@ -4373,7 +4373,7 @@
           <p:cNvPr id="4" name="">
             <a:extLst xmlns:a="http://schemas.openxmlformats.org/drawingml/2006/main">
               <a:ext uri="{FF2B5EF4-FFF2-40B4-BE49-F238E27FC236}">
-                <a16:creationId xmlns:a16="http://schemas.microsoft.com/office/drawing/2014/main" id="{D4A85D9B-4557-4A4D-9BE6-682ED2C6B5E8}"/>
+                <a16:creationId xmlns:a16="http://schemas.microsoft.com/office/drawing/2014/main" id="{72E7F11E-A19B-46AA-AF73-6DBC9CE95131}"/>
               </a:ext>
             </a:extLst>
           </p:cNvPr>
@@ -4430,7 +4430,7 @@
           <p:cNvPr id="5" name="">
             <a:extLst xmlns:a="http://schemas.openxmlformats.org/drawingml/2006/main">
               <a:ext uri="{FF2B5EF4-FFF2-40B4-BE49-F238E27FC236}">
-                <a16:creationId xmlns:a16="http://schemas.microsoft.com/office/drawing/2014/main" id="{7B178B21-51C1-4BF3-AF28-09D23BAA6BD2}"/>
+                <a16:creationId xmlns:a16="http://schemas.microsoft.com/office/drawing/2014/main" id="{BD58C7D1-3981-45BD-BB70-8BB9DEC49A7C}"/>
               </a:ext>
             </a:extLst>
           </p:cNvPr>
@@ -4487,7 +4487,7 @@
           <p:cNvPr id="6" name="">
             <a:extLst xmlns:a="http://schemas.openxmlformats.org/drawingml/2006/main">
               <a:ext uri="{FF2B5EF4-FFF2-40B4-BE49-F238E27FC236}">
-                <a16:creationId xmlns:a16="http://schemas.microsoft.com/office/drawing/2014/main" id="{ECBB9D60-3C6B-4ACC-A3A8-8CD46467808C}"/>
+                <a16:creationId xmlns:a16="http://schemas.microsoft.com/office/drawing/2014/main" id="{4A595CF4-8016-4F4C-8F3F-905E30A2D60D}"/>
               </a:ext>
             </a:extLst>
           </p:cNvPr>
@@ -4544,7 +4544,7 @@
           <p:cNvPr id="7" name="">
             <a:extLst xmlns:a="http://schemas.openxmlformats.org/drawingml/2006/main">
               <a:ext uri="{FF2B5EF4-FFF2-40B4-BE49-F238E27FC236}">
-                <a16:creationId xmlns:a16="http://schemas.microsoft.com/office/drawing/2014/main" id="{6F42236A-E0C2-426B-93AC-495ECFAC23C6}"/>
+                <a16:creationId xmlns:a16="http://schemas.microsoft.com/office/drawing/2014/main" id="{CE08725A-85D3-4C9C-AAF6-9C00D5C314E6}"/>
               </a:ext>
             </a:extLst>
           </p:cNvPr>
@@ -4601,7 +4601,7 @@
           <p:cNvPr id="8" name="">
             <a:extLst xmlns:a="http://schemas.openxmlformats.org/drawingml/2006/main">
               <a:ext uri="{FF2B5EF4-FFF2-40B4-BE49-F238E27FC236}">
-                <a16:creationId xmlns:a16="http://schemas.microsoft.com/office/drawing/2014/main" id="{CECE8457-8F79-46CF-9747-EE2A4983D441}"/>
+                <a16:creationId xmlns:a16="http://schemas.microsoft.com/office/drawing/2014/main" id="{DE216E70-A202-4D24-8BDD-32CC2FF51969}"/>
               </a:ext>
             </a:extLst>
           </p:cNvPr>
@@ -4658,7 +4658,7 @@
           <p:cNvPr id="9" name="">
             <a:extLst xmlns:a="http://schemas.openxmlformats.org/drawingml/2006/main">
               <a:ext uri="{FF2B5EF4-FFF2-40B4-BE49-F238E27FC236}">
-                <a16:creationId xmlns:a16="http://schemas.microsoft.com/office/drawing/2014/main" id="{872DBA53-20FC-4D38-8178-8A7641C16AAC}"/>
+                <a16:creationId xmlns:a16="http://schemas.microsoft.com/office/drawing/2014/main" id="{C214F267-D08A-4C22-BB27-68F616F86BC6}"/>
               </a:ext>
             </a:extLst>
           </p:cNvPr>
@@ -4715,7 +4715,7 @@
           <p:cNvPr id="10" name="">
             <a:extLst xmlns:a="http://schemas.openxmlformats.org/drawingml/2006/main">
               <a:ext uri="{FF2B5EF4-FFF2-40B4-BE49-F238E27FC236}">
-                <a16:creationId xmlns:a16="http://schemas.microsoft.com/office/drawing/2014/main" id="{C4C4D311-5FCE-4DCB-AB89-A4DD22CC9B89}"/>
+                <a16:creationId xmlns:a16="http://schemas.microsoft.com/office/drawing/2014/main" id="{51D05EC2-4127-4797-9288-C6D86DA3B328}"/>
               </a:ext>
             </a:extLst>
           </p:cNvPr>
@@ -4772,7 +4772,7 @@
           <p:cNvPr id="11" name="">
             <a:extLst xmlns:a="http://schemas.openxmlformats.org/drawingml/2006/main">
               <a:ext uri="{FF2B5EF4-FFF2-40B4-BE49-F238E27FC236}">
-                <a16:creationId xmlns:a16="http://schemas.microsoft.com/office/drawing/2014/main" id="{F8CAC5A2-CCB5-4482-944B-5A5EF26D230A}"/>
+                <a16:creationId xmlns:a16="http://schemas.microsoft.com/office/drawing/2014/main" id="{D572F2DB-D615-41ED-98F2-4F089592E008}"/>
               </a:ext>
             </a:extLst>
           </p:cNvPr>
@@ -4829,7 +4829,7 @@
           <p:cNvPr id="12" name="">
             <a:extLst xmlns:a="http://schemas.openxmlformats.org/drawingml/2006/main">
               <a:ext uri="{FF2B5EF4-FFF2-40B4-BE49-F238E27FC236}">
-                <a16:creationId xmlns:a16="http://schemas.microsoft.com/office/drawing/2014/main" id="{5A48BA69-DADA-486A-AD37-C9C220A8386F}"/>
+                <a16:creationId xmlns:a16="http://schemas.microsoft.com/office/drawing/2014/main" id="{96C5B384-6176-4EFF-B01B-1313AA613492}"/>
               </a:ext>
             </a:extLst>
           </p:cNvPr>
@@ -4884,7 +4884,7 @@
     </p:spTree>
     <p:extLst>
       <p:ext uri="{BB962C8B-B14F-4D97-AF65-F5344CB8AC3E}">
-        <p14:creationId xmlns:p14="http://schemas.microsoft.com/office/powerpoint/2010/main" val="1898609954"/>
+        <p14:creationId xmlns:p14="http://schemas.microsoft.com/office/powerpoint/2010/main" val="550628515"/>
       </p:ext>
     </p:extLst>
   </p:cSld>
@@ -4915,7 +4915,7 @@
           <p:cNvPr id="11" name="">
             <a:extLst xmlns:a="http://schemas.openxmlformats.org/drawingml/2006/main">
               <a:ext uri="{FF2B5EF4-FFF2-40B4-BE49-F238E27FC236}">
-                <a16:creationId xmlns:a16="http://schemas.microsoft.com/office/drawing/2014/main" id="{23720CBE-4F3C-4DAD-BD94-F8B82B08A25F}"/>
+                <a16:creationId xmlns:a16="http://schemas.microsoft.com/office/drawing/2014/main" id="{7CFF15A6-6782-4C06-AD37-B92DAEEFFAD0}"/>
               </a:ext>
             </a:extLst>
           </p:cNvPr>
@@ -4972,7 +4972,7 @@
           <p:cNvPr id="2" name="">
             <a:extLst xmlns:a="http://schemas.openxmlformats.org/drawingml/2006/main">
               <a:ext uri="{FF2B5EF4-FFF2-40B4-BE49-F238E27FC236}">
-                <a16:creationId xmlns:a16="http://schemas.microsoft.com/office/drawing/2014/main" id="{A26449D4-C8D5-4DE9-BA22-2E2B83EAA211}"/>
+                <a16:creationId xmlns:a16="http://schemas.microsoft.com/office/drawing/2014/main" id="{CC2705E1-0F61-423B-B6D4-F2FC1C01FDEE}"/>
               </a:ext>
             </a:extLst>
           </p:cNvPr>
@@ -5029,7 +5029,7 @@
           <p:cNvPr id="3" name="">
             <a:extLst xmlns:a="http://schemas.openxmlformats.org/drawingml/2006/main">
               <a:ext uri="{FF2B5EF4-FFF2-40B4-BE49-F238E27FC236}">
-                <a16:creationId xmlns:a16="http://schemas.microsoft.com/office/drawing/2014/main" id="{A1F41E85-2920-428A-AB50-A505C59FC95A}"/>
+                <a16:creationId xmlns:a16="http://schemas.microsoft.com/office/drawing/2014/main" id="{F31B8BD1-F98A-4FDC-94E5-2817122A2BA1}"/>
               </a:ext>
             </a:extLst>
           </p:cNvPr>
@@ -5086,7 +5086,7 @@
           <p:cNvPr id="4" name="">
             <a:extLst xmlns:a="http://schemas.openxmlformats.org/drawingml/2006/main">
               <a:ext uri="{FF2B5EF4-FFF2-40B4-BE49-F238E27FC236}">
-                <a16:creationId xmlns:a16="http://schemas.microsoft.com/office/drawing/2014/main" id="{8F6591FC-AF0D-4696-924D-92FA4FA46350}"/>
+                <a16:creationId xmlns:a16="http://schemas.microsoft.com/office/drawing/2014/main" id="{5595922B-0BB6-4E93-B204-CACC835061CF}"/>
               </a:ext>
             </a:extLst>
           </p:cNvPr>
@@ -5143,7 +5143,7 @@
           <p:cNvPr id="5" name="">
             <a:extLst xmlns:a="http://schemas.openxmlformats.org/drawingml/2006/main">
               <a:ext uri="{FF2B5EF4-FFF2-40B4-BE49-F238E27FC236}">
-                <a16:creationId xmlns:a16="http://schemas.microsoft.com/office/drawing/2014/main" id="{0BCB142B-8199-4E77-97C3-280BAAC00861}"/>
+                <a16:creationId xmlns:a16="http://schemas.microsoft.com/office/drawing/2014/main" id="{323FEAF1-D787-4ADA-8148-DDBA65DCD0D5}"/>
               </a:ext>
             </a:extLst>
           </p:cNvPr>
@@ -5200,7 +5200,7 @@
           <p:cNvPr id="6" name="">
             <a:extLst xmlns:a="http://schemas.openxmlformats.org/drawingml/2006/main">
               <a:ext uri="{FF2B5EF4-FFF2-40B4-BE49-F238E27FC236}">
-                <a16:creationId xmlns:a16="http://schemas.microsoft.com/office/drawing/2014/main" id="{31D5FFC6-EBD6-4F82-AEEA-43D8067A28D4}"/>
+                <a16:creationId xmlns:a16="http://schemas.microsoft.com/office/drawing/2014/main" id="{6B0A6FF9-D8F3-40E2-8444-6C5F454E3190}"/>
               </a:ext>
             </a:extLst>
           </p:cNvPr>
@@ -5257,7 +5257,7 @@
           <p:cNvPr id="7" name="">
             <a:extLst xmlns:a="http://schemas.openxmlformats.org/drawingml/2006/main">
               <a:ext uri="{FF2B5EF4-FFF2-40B4-BE49-F238E27FC236}">
-                <a16:creationId xmlns:a16="http://schemas.microsoft.com/office/drawing/2014/main" id="{BF445499-4C3C-491C-8B4F-841483122FE9}"/>
+                <a16:creationId xmlns:a16="http://schemas.microsoft.com/office/drawing/2014/main" id="{7339E20A-67B1-47EA-9BC3-DFF7B2169108}"/>
               </a:ext>
             </a:extLst>
           </p:cNvPr>
@@ -5314,7 +5314,7 @@
           <p:cNvPr id="8" name="">
             <a:extLst xmlns:a="http://schemas.openxmlformats.org/drawingml/2006/main">
               <a:ext uri="{FF2B5EF4-FFF2-40B4-BE49-F238E27FC236}">
-                <a16:creationId xmlns:a16="http://schemas.microsoft.com/office/drawing/2014/main" id="{4D20F10B-22FF-413F-A190-6E7C50ED73DF}"/>
+                <a16:creationId xmlns:a16="http://schemas.microsoft.com/office/drawing/2014/main" id="{63D7F877-13A1-4609-A33A-603100BBD0CA}"/>
               </a:ext>
             </a:extLst>
           </p:cNvPr>
@@ -5371,7 +5371,7 @@
           <p:cNvPr id="9" name="">
             <a:extLst xmlns:a="http://schemas.openxmlformats.org/drawingml/2006/main">
               <a:ext uri="{FF2B5EF4-FFF2-40B4-BE49-F238E27FC236}">
-                <a16:creationId xmlns:a16="http://schemas.microsoft.com/office/drawing/2014/main" id="{170AC07D-BCFE-4B0F-9A91-CAF8DDE62D65}"/>
+                <a16:creationId xmlns:a16="http://schemas.microsoft.com/office/drawing/2014/main" id="{0C6201D8-79AC-4D35-A30D-4F152DE3C7A7}"/>
               </a:ext>
             </a:extLst>
           </p:cNvPr>
@@ -5428,7 +5428,7 @@
           <p:cNvPr id="10" name="">
             <a:extLst xmlns:a="http://schemas.openxmlformats.org/drawingml/2006/main">
               <a:ext uri="{FF2B5EF4-FFF2-40B4-BE49-F238E27FC236}">
-                <a16:creationId xmlns:a16="http://schemas.microsoft.com/office/drawing/2014/main" id="{2248BD1D-676E-48FB-A580-B42CA6B03CD4}"/>
+                <a16:creationId xmlns:a16="http://schemas.microsoft.com/office/drawing/2014/main" id="{2639638D-016D-4E89-B887-0791CE4181B6}"/>
               </a:ext>
             </a:extLst>
           </p:cNvPr>
@@ -5483,7 +5483,7 @@
     </p:spTree>
     <p:extLst>
       <p:ext uri="{BB962C8B-B14F-4D97-AF65-F5344CB8AC3E}">
-        <p14:creationId xmlns:p14="http://schemas.microsoft.com/office/powerpoint/2010/main" val="1449629441"/>
+        <p14:creationId xmlns:p14="http://schemas.microsoft.com/office/powerpoint/2010/main" val="1553370169"/>
       </p:ext>
     </p:extLst>
   </p:cSld>
@@ -5514,7 +5514,7 @@
           <p:cNvPr id="12" name="">
             <a:extLst xmlns:a="http://schemas.openxmlformats.org/drawingml/2006/main">
               <a:ext uri="{FF2B5EF4-FFF2-40B4-BE49-F238E27FC236}">
-                <a16:creationId xmlns:a16="http://schemas.microsoft.com/office/drawing/2014/main" id="{EFE248AE-EACF-4AEE-B4AC-4A98F9F2942D}"/>
+                <a16:creationId xmlns:a16="http://schemas.microsoft.com/office/drawing/2014/main" id="{9A62C264-96BF-444F-892F-97CFBC4054F3}"/>
               </a:ext>
             </a:extLst>
           </p:cNvPr>
@@ -5571,7 +5571,7 @@
           <p:cNvPr id="2" name="">
             <a:extLst xmlns:a="http://schemas.openxmlformats.org/drawingml/2006/main">
               <a:ext uri="{FF2B5EF4-FFF2-40B4-BE49-F238E27FC236}">
-                <a16:creationId xmlns:a16="http://schemas.microsoft.com/office/drawing/2014/main" id="{B37C468B-6176-4264-B357-701C2B71203F}"/>
+                <a16:creationId xmlns:a16="http://schemas.microsoft.com/office/drawing/2014/main" id="{114987BC-631C-4815-AEFD-86BB5D83E84F}"/>
               </a:ext>
             </a:extLst>
           </p:cNvPr>
@@ -5628,7 +5628,7 @@
           <p:cNvPr id="3" name="">
             <a:extLst xmlns:a="http://schemas.openxmlformats.org/drawingml/2006/main">
               <a:ext uri="{FF2B5EF4-FFF2-40B4-BE49-F238E27FC236}">
-                <a16:creationId xmlns:a16="http://schemas.microsoft.com/office/drawing/2014/main" id="{DCD8F2D0-F200-4E74-BA97-395FD8194899}"/>
+                <a16:creationId xmlns:a16="http://schemas.microsoft.com/office/drawing/2014/main" id="{FC580F22-9058-41CE-8CB4-1F36B0D8815F}"/>
               </a:ext>
             </a:extLst>
           </p:cNvPr>
@@ -5685,7 +5685,7 @@
           <p:cNvPr id="4" name="">
             <a:extLst xmlns:a="http://schemas.openxmlformats.org/drawingml/2006/main">
               <a:ext uri="{FF2B5EF4-FFF2-40B4-BE49-F238E27FC236}">
-                <a16:creationId xmlns:a16="http://schemas.microsoft.com/office/drawing/2014/main" id="{AADB7EA6-9956-40FF-8D60-C79B97135CAF}"/>
+                <a16:creationId xmlns:a16="http://schemas.microsoft.com/office/drawing/2014/main" id="{5C0232D3-146B-466E-B3DC-790604095414}"/>
               </a:ext>
             </a:extLst>
           </p:cNvPr>
@@ -5742,7 +5742,7 @@
           <p:cNvPr id="5" name="">
             <a:extLst xmlns:a="http://schemas.openxmlformats.org/drawingml/2006/main">
               <a:ext uri="{FF2B5EF4-FFF2-40B4-BE49-F238E27FC236}">
-                <a16:creationId xmlns:a16="http://schemas.microsoft.com/office/drawing/2014/main" id="{6DECB924-B2DA-4933-A15A-0D7AD0F4BA34}"/>
+                <a16:creationId xmlns:a16="http://schemas.microsoft.com/office/drawing/2014/main" id="{F0A6CF7C-B636-4C0A-9D7F-A19A1E0BFFC7}"/>
               </a:ext>
             </a:extLst>
           </p:cNvPr>
@@ -5799,7 +5799,7 @@
           <p:cNvPr id="6" name="">
             <a:extLst xmlns:a="http://schemas.openxmlformats.org/drawingml/2006/main">
               <a:ext uri="{FF2B5EF4-FFF2-40B4-BE49-F238E27FC236}">
-                <a16:creationId xmlns:a16="http://schemas.microsoft.com/office/drawing/2014/main" id="{82AB3CFC-3DB8-4405-8761-1F0F266BE39F}"/>
+                <a16:creationId xmlns:a16="http://schemas.microsoft.com/office/drawing/2014/main" id="{E1DA19AE-1366-43F8-9D7A-0EACF26CA115}"/>
               </a:ext>
             </a:extLst>
           </p:cNvPr>
@@ -5856,7 +5856,7 @@
           <p:cNvPr id="7" name="">
             <a:extLst xmlns:a="http://schemas.openxmlformats.org/drawingml/2006/main">
               <a:ext uri="{FF2B5EF4-FFF2-40B4-BE49-F238E27FC236}">
-                <a16:creationId xmlns:a16="http://schemas.microsoft.com/office/drawing/2014/main" id="{367233E1-AFEC-4B14-AC86-5ED30F1D56B8}"/>
+                <a16:creationId xmlns:a16="http://schemas.microsoft.com/office/drawing/2014/main" id="{BC5B56E1-BF26-49AC-97DB-CAD4EAF0E79C}"/>
               </a:ext>
             </a:extLst>
           </p:cNvPr>
@@ -5913,7 +5913,7 @@
           <p:cNvPr id="8" name="">
             <a:extLst xmlns:a="http://schemas.openxmlformats.org/drawingml/2006/main">
               <a:ext uri="{FF2B5EF4-FFF2-40B4-BE49-F238E27FC236}">
-                <a16:creationId xmlns:a16="http://schemas.microsoft.com/office/drawing/2014/main" id="{A7FBC031-2F89-4109-980F-1A9BF19E985E}"/>
+                <a16:creationId xmlns:a16="http://schemas.microsoft.com/office/drawing/2014/main" id="{FF40B637-2B4B-4DB7-B72F-323BBED02F2B}"/>
               </a:ext>
             </a:extLst>
           </p:cNvPr>
@@ -5970,7 +5970,7 @@
           <p:cNvPr id="9" name="">
             <a:extLst xmlns:a="http://schemas.openxmlformats.org/drawingml/2006/main">
               <a:ext uri="{FF2B5EF4-FFF2-40B4-BE49-F238E27FC236}">
-                <a16:creationId xmlns:a16="http://schemas.microsoft.com/office/drawing/2014/main" id="{86A21B45-DA2B-4A05-8512-C4665902C5BE}"/>
+                <a16:creationId xmlns:a16="http://schemas.microsoft.com/office/drawing/2014/main" id="{6918C0E1-9F7B-4959-ABE6-13DFFEAFB704}"/>
               </a:ext>
             </a:extLst>
           </p:cNvPr>
@@ -6027,7 +6027,7 @@
           <p:cNvPr id="10" name="">
             <a:extLst xmlns:a="http://schemas.openxmlformats.org/drawingml/2006/main">
               <a:ext uri="{FF2B5EF4-FFF2-40B4-BE49-F238E27FC236}">
-                <a16:creationId xmlns:a16="http://schemas.microsoft.com/office/drawing/2014/main" id="{3307EB67-A0DB-4CB4-96BD-8AE17BE9C995}"/>
+                <a16:creationId xmlns:a16="http://schemas.microsoft.com/office/drawing/2014/main" id="{85E30C8B-9143-4470-8ACD-CED0DD60BACB}"/>
               </a:ext>
             </a:extLst>
           </p:cNvPr>
@@ -6091,14 +6091,14 @@
         </p:xfrm>
         <a:graphic xmlns:a="http://schemas.openxmlformats.org/drawingml/2006/main">
           <a:graphicData uri="http://schemas.openxmlformats.org/drawingml/2006/chart">
-            <c:chart xmlns:r="http://schemas.openxmlformats.org/officeDocument/2006/relationships" xmlns:c="http://schemas.openxmlformats.org/drawingml/2006/chart" r:id="R5d14749742a04fbc"/>
+            <c:chart xmlns:r="http://schemas.openxmlformats.org/officeDocument/2006/relationships" xmlns:c="http://schemas.openxmlformats.org/drawingml/2006/chart" r:id="R37ceb5f49c104b76"/>
           </a:graphicData>
         </a:graphic>
       </p:graphicFrame>
     </p:spTree>
     <p:extLst>
       <p:ext uri="{BB962C8B-B14F-4D97-AF65-F5344CB8AC3E}">
-        <p14:creationId xmlns:p14="http://schemas.microsoft.com/office/powerpoint/2010/main" val="423376332"/>
+        <p14:creationId xmlns:p14="http://schemas.microsoft.com/office/powerpoint/2010/main" val="1338848109"/>
       </p:ext>
     </p:extLst>
   </p:cSld>
@@ -6129,7 +6129,7 @@
           <p:cNvPr id="12" name="">
             <a:extLst xmlns:a="http://schemas.openxmlformats.org/drawingml/2006/main">
               <a:ext uri="{FF2B5EF4-FFF2-40B4-BE49-F238E27FC236}">
-                <a16:creationId xmlns:a16="http://schemas.microsoft.com/office/drawing/2014/main" id="{173C3BB7-D3DE-4E9A-BB44-B9199796EBE0}"/>
+                <a16:creationId xmlns:a16="http://schemas.microsoft.com/office/drawing/2014/main" id="{F3A8DEED-BD12-4C9A-8745-F7B640625638}"/>
               </a:ext>
             </a:extLst>
           </p:cNvPr>
@@ -6186,7 +6186,7 @@
           <p:cNvPr id="2" name="">
             <a:extLst xmlns:a="http://schemas.openxmlformats.org/drawingml/2006/main">
               <a:ext uri="{FF2B5EF4-FFF2-40B4-BE49-F238E27FC236}">
-                <a16:creationId xmlns:a16="http://schemas.microsoft.com/office/drawing/2014/main" id="{73F5AD7A-5170-4C69-9648-FC9BC1552003}"/>
+                <a16:creationId xmlns:a16="http://schemas.microsoft.com/office/drawing/2014/main" id="{C025F403-E545-4914-BA45-A2A4A08FB5BC}"/>
               </a:ext>
             </a:extLst>
           </p:cNvPr>
@@ -6243,7 +6243,7 @@
           <p:cNvPr id="3" name="">
             <a:extLst xmlns:a="http://schemas.openxmlformats.org/drawingml/2006/main">
               <a:ext uri="{FF2B5EF4-FFF2-40B4-BE49-F238E27FC236}">
-                <a16:creationId xmlns:a16="http://schemas.microsoft.com/office/drawing/2014/main" id="{56AE9BE7-8B7D-4D4A-AC03-5D3EB3D1D296}"/>
+                <a16:creationId xmlns:a16="http://schemas.microsoft.com/office/drawing/2014/main" id="{77D1DC8C-80C6-4639-A913-E792D04FF421}"/>
               </a:ext>
             </a:extLst>
           </p:cNvPr>
@@ -6300,7 +6300,7 @@
           <p:cNvPr id="4" name="">
             <a:extLst xmlns:a="http://schemas.openxmlformats.org/drawingml/2006/main">
               <a:ext uri="{FF2B5EF4-FFF2-40B4-BE49-F238E27FC236}">
-                <a16:creationId xmlns:a16="http://schemas.microsoft.com/office/drawing/2014/main" id="{2E9F90CB-54C4-4CDD-B594-58E018ACD99F}"/>
+                <a16:creationId xmlns:a16="http://schemas.microsoft.com/office/drawing/2014/main" id="{A2358405-3FBA-4F6B-BC89-4D3368CB1C94}"/>
               </a:ext>
             </a:extLst>
           </p:cNvPr>
@@ -6357,7 +6357,7 @@
           <p:cNvPr id="5" name="">
             <a:extLst xmlns:a="http://schemas.openxmlformats.org/drawingml/2006/main">
               <a:ext uri="{FF2B5EF4-FFF2-40B4-BE49-F238E27FC236}">
-                <a16:creationId xmlns:a16="http://schemas.microsoft.com/office/drawing/2014/main" id="{44EF82F6-CD3A-4AB0-BDFA-DAD859503E2F}"/>
+                <a16:creationId xmlns:a16="http://schemas.microsoft.com/office/drawing/2014/main" id="{62CD501F-A748-4B34-9A8E-E34BE76B98CD}"/>
               </a:ext>
             </a:extLst>
           </p:cNvPr>
@@ -6414,7 +6414,7 @@
           <p:cNvPr id="6" name="">
             <a:extLst xmlns:a="http://schemas.openxmlformats.org/drawingml/2006/main">
               <a:ext uri="{FF2B5EF4-FFF2-40B4-BE49-F238E27FC236}">
-                <a16:creationId xmlns:a16="http://schemas.microsoft.com/office/drawing/2014/main" id="{BA78CCF8-323B-41B2-8ADD-16E43720D6A8}"/>
+                <a16:creationId xmlns:a16="http://schemas.microsoft.com/office/drawing/2014/main" id="{039BD591-5AF6-41CC-8BA8-63EBA0FFD545}"/>
               </a:ext>
             </a:extLst>
           </p:cNvPr>
@@ -6471,7 +6471,7 @@
           <p:cNvPr id="7" name="">
             <a:extLst xmlns:a="http://schemas.openxmlformats.org/drawingml/2006/main">
               <a:ext uri="{FF2B5EF4-FFF2-40B4-BE49-F238E27FC236}">
-                <a16:creationId xmlns:a16="http://schemas.microsoft.com/office/drawing/2014/main" id="{5D83F286-450A-4252-ADE4-12BF82B1F937}"/>
+                <a16:creationId xmlns:a16="http://schemas.microsoft.com/office/drawing/2014/main" id="{2A721B98-7ECB-4503-AD38-6AC2E89BC33D}"/>
               </a:ext>
             </a:extLst>
           </p:cNvPr>
@@ -6528,7 +6528,7 @@
           <p:cNvPr id="8" name="">
             <a:extLst xmlns:a="http://schemas.openxmlformats.org/drawingml/2006/main">
               <a:ext uri="{FF2B5EF4-FFF2-40B4-BE49-F238E27FC236}">
-                <a16:creationId xmlns:a16="http://schemas.microsoft.com/office/drawing/2014/main" id="{DA0B3B4D-6DAE-4CF7-A3A6-790FBC69EB64}"/>
+                <a16:creationId xmlns:a16="http://schemas.microsoft.com/office/drawing/2014/main" id="{65BAEF5F-CC52-4C98-9B50-F7658228EFF5}"/>
               </a:ext>
             </a:extLst>
           </p:cNvPr>
@@ -6585,7 +6585,7 @@
           <p:cNvPr id="9" name="">
             <a:extLst xmlns:a="http://schemas.openxmlformats.org/drawingml/2006/main">
               <a:ext uri="{FF2B5EF4-FFF2-40B4-BE49-F238E27FC236}">
-                <a16:creationId xmlns:a16="http://schemas.microsoft.com/office/drawing/2014/main" id="{72E0B0F5-1DAE-4BA1-AE7E-6745CF64B8E9}"/>
+                <a16:creationId xmlns:a16="http://schemas.microsoft.com/office/drawing/2014/main" id="{07CFE872-A7E2-4836-851F-86448F32B4FF}"/>
               </a:ext>
             </a:extLst>
           </p:cNvPr>
@@ -6642,7 +6642,7 @@
           <p:cNvPr id="10" name="">
             <a:extLst xmlns:a="http://schemas.openxmlformats.org/drawingml/2006/main">
               <a:ext uri="{FF2B5EF4-FFF2-40B4-BE49-F238E27FC236}">
-                <a16:creationId xmlns:a16="http://schemas.microsoft.com/office/drawing/2014/main" id="{B71EB740-F9F0-4B36-A7AA-45BF838685E7}"/>
+                <a16:creationId xmlns:a16="http://schemas.microsoft.com/office/drawing/2014/main" id="{40471AAE-E2FC-4854-8585-AAD4C2E5E2E1}"/>
               </a:ext>
             </a:extLst>
           </p:cNvPr>
@@ -6706,14 +6706,14 @@
         </p:xfrm>
         <a:graphic xmlns:a="http://schemas.openxmlformats.org/drawingml/2006/main">
           <a:graphicData uri="http://schemas.openxmlformats.org/drawingml/2006/chart">
-            <c:chart xmlns:r="http://schemas.openxmlformats.org/officeDocument/2006/relationships" xmlns:c="http://schemas.openxmlformats.org/drawingml/2006/chart" r:id="R2e0f8a61df914296"/>
+            <c:chart xmlns:r="http://schemas.openxmlformats.org/officeDocument/2006/relationships" xmlns:c="http://schemas.openxmlformats.org/drawingml/2006/chart" r:id="R1a69f635333746d9"/>
           </a:graphicData>
         </a:graphic>
       </p:graphicFrame>
     </p:spTree>
     <p:extLst>
       <p:ext uri="{BB962C8B-B14F-4D97-AF65-F5344CB8AC3E}">
-        <p14:creationId xmlns:p14="http://schemas.microsoft.com/office/powerpoint/2010/main" val="1362397809"/>
+        <p14:creationId xmlns:p14="http://schemas.microsoft.com/office/powerpoint/2010/main" val="1309713473"/>
       </p:ext>
     </p:extLst>
   </p:cSld>
@@ -6744,7 +6744,7 @@
           <p:cNvPr id="16" name="">
             <a:extLst xmlns:a="http://schemas.openxmlformats.org/drawingml/2006/main">
               <a:ext uri="{FF2B5EF4-FFF2-40B4-BE49-F238E27FC236}">
-                <a16:creationId xmlns:a16="http://schemas.microsoft.com/office/drawing/2014/main" id="{F2A4AD52-7D3F-42C4-86EA-366DC14EF2BF}"/>
+                <a16:creationId xmlns:a16="http://schemas.microsoft.com/office/drawing/2014/main" id="{8AA00A01-01BB-4829-A1AB-B18B33FB007B}"/>
               </a:ext>
             </a:extLst>
           </p:cNvPr>
@@ -6801,7 +6801,7 @@
           <p:cNvPr id="2" name="">
             <a:extLst xmlns:a="http://schemas.openxmlformats.org/drawingml/2006/main">
               <a:ext uri="{FF2B5EF4-FFF2-40B4-BE49-F238E27FC236}">
-                <a16:creationId xmlns:a16="http://schemas.microsoft.com/office/drawing/2014/main" id="{5FEEDEEF-0738-4484-97E0-60A0C2807617}"/>
+                <a16:creationId xmlns:a16="http://schemas.microsoft.com/office/drawing/2014/main" id="{DCC5465B-B220-4565-8EA4-D6709802153A}"/>
               </a:ext>
             </a:extLst>
           </p:cNvPr>
@@ -6858,7 +6858,7 @@
           <p:cNvPr id="3" name="">
             <a:extLst xmlns:a="http://schemas.openxmlformats.org/drawingml/2006/main">
               <a:ext uri="{FF2B5EF4-FFF2-40B4-BE49-F238E27FC236}">
-                <a16:creationId xmlns:a16="http://schemas.microsoft.com/office/drawing/2014/main" id="{811A728C-1FB6-4BFE-8E12-CE1E1B0C2BD7}"/>
+                <a16:creationId xmlns:a16="http://schemas.microsoft.com/office/drawing/2014/main" id="{661E1955-CBE0-4F0A-BF75-110CAE92A6CC}"/>
               </a:ext>
             </a:extLst>
           </p:cNvPr>
@@ -6915,7 +6915,7 @@
           <p:cNvPr id="4" name="">
             <a:extLst xmlns:a="http://schemas.openxmlformats.org/drawingml/2006/main">
               <a:ext uri="{FF2B5EF4-FFF2-40B4-BE49-F238E27FC236}">
-                <a16:creationId xmlns:a16="http://schemas.microsoft.com/office/drawing/2014/main" id="{B65EF667-B9E1-4E83-9AEE-1A42845AA050}"/>
+                <a16:creationId xmlns:a16="http://schemas.microsoft.com/office/drawing/2014/main" id="{802CCF00-D97A-42A6-B763-009F83BCB6D5}"/>
               </a:ext>
             </a:extLst>
           </p:cNvPr>
@@ -6979,7 +6979,7 @@
         </p:xfrm>
         <a:graphic xmlns:a="http://schemas.openxmlformats.org/drawingml/2006/main">
           <a:graphicData uri="http://schemas.openxmlformats.org/drawingml/2006/chart">
-            <c:chart xmlns:r="http://schemas.openxmlformats.org/officeDocument/2006/relationships" xmlns:c="http://schemas.openxmlformats.org/drawingml/2006/chart" r:id="R78f84691b7764b91"/>
+            <c:chart xmlns:r="http://schemas.openxmlformats.org/officeDocument/2006/relationships" xmlns:c="http://schemas.openxmlformats.org/drawingml/2006/chart" r:id="Rba1b6b0ada254076"/>
           </a:graphicData>
         </a:graphic>
       </p:graphicFrame>
@@ -6988,7 +6988,7 @@
           <p:cNvPr id="6" name="">
             <a:extLst xmlns:a="http://schemas.openxmlformats.org/drawingml/2006/main">
               <a:ext uri="{FF2B5EF4-FFF2-40B4-BE49-F238E27FC236}">
-                <a16:creationId xmlns:a16="http://schemas.microsoft.com/office/drawing/2014/main" id="{E78EB316-73CF-4AD0-9516-B74AB2500FAC}"/>
+                <a16:creationId xmlns:a16="http://schemas.microsoft.com/office/drawing/2014/main" id="{8B1A41CA-3497-40EB-BFE5-729A17CDF9D5}"/>
               </a:ext>
             </a:extLst>
           </p:cNvPr>
@@ -7045,7 +7045,7 @@
           <p:cNvPr id="7" name="">
             <a:extLst xmlns:a="http://schemas.openxmlformats.org/drawingml/2006/main">
               <a:ext uri="{FF2B5EF4-FFF2-40B4-BE49-F238E27FC236}">
-                <a16:creationId xmlns:a16="http://schemas.microsoft.com/office/drawing/2014/main" id="{7DACA6AC-6C53-4BA3-B69C-A0418AD34CEB}"/>
+                <a16:creationId xmlns:a16="http://schemas.microsoft.com/office/drawing/2014/main" id="{3BC524F4-1BE3-4EF0-904C-17DECEFFCFEF}"/>
               </a:ext>
             </a:extLst>
           </p:cNvPr>
@@ -7102,7 +7102,7 @@
           <p:cNvPr id="8" name="">
             <a:extLst xmlns:a="http://schemas.openxmlformats.org/drawingml/2006/main">
               <a:ext uri="{FF2B5EF4-FFF2-40B4-BE49-F238E27FC236}">
-                <a16:creationId xmlns:a16="http://schemas.microsoft.com/office/drawing/2014/main" id="{95B25C2C-3AA6-4AC8-BD32-69A676B2904A}"/>
+                <a16:creationId xmlns:a16="http://schemas.microsoft.com/office/drawing/2014/main" id="{64F535BE-4C01-4C9C-BEE9-A822DE1331AB}"/>
               </a:ext>
             </a:extLst>
           </p:cNvPr>
@@ -7166,7 +7166,7 @@
         </p:xfrm>
         <a:graphic xmlns:a="http://schemas.openxmlformats.org/drawingml/2006/main">
           <a:graphicData uri="http://schemas.openxmlformats.org/drawingml/2006/chart">
-            <c:chart xmlns:r="http://schemas.openxmlformats.org/officeDocument/2006/relationships" xmlns:c="http://schemas.openxmlformats.org/drawingml/2006/chart" r:id="Rbae6ccb3b4624575"/>
+            <c:chart xmlns:r="http://schemas.openxmlformats.org/officeDocument/2006/relationships" xmlns:c="http://schemas.openxmlformats.org/drawingml/2006/chart" r:id="Rce54a3b770a94dfa"/>
           </a:graphicData>
         </a:graphic>
       </p:graphicFrame>
@@ -7175,7 +7175,7 @@
           <p:cNvPr id="10" name="">
             <a:extLst xmlns:a="http://schemas.openxmlformats.org/drawingml/2006/main">
               <a:ext uri="{FF2B5EF4-FFF2-40B4-BE49-F238E27FC236}">
-                <a16:creationId xmlns:a16="http://schemas.microsoft.com/office/drawing/2014/main" id="{E0FFBA5A-62A1-4119-9846-B78F724D7688}"/>
+                <a16:creationId xmlns:a16="http://schemas.microsoft.com/office/drawing/2014/main" id="{CFC993D7-4513-4B2B-BAA5-78F21B0BCAF5}"/>
               </a:ext>
             </a:extLst>
           </p:cNvPr>
@@ -7232,7 +7232,7 @@
           <p:cNvPr id="11" name="">
             <a:extLst xmlns:a="http://schemas.openxmlformats.org/drawingml/2006/main">
               <a:ext uri="{FF2B5EF4-FFF2-40B4-BE49-F238E27FC236}">
-                <a16:creationId xmlns:a16="http://schemas.microsoft.com/office/drawing/2014/main" id="{F1D70BA3-E006-4750-A92B-6DA9BC181E0B}"/>
+                <a16:creationId xmlns:a16="http://schemas.microsoft.com/office/drawing/2014/main" id="{397478C6-FE63-434A-A36A-0694948005F7}"/>
               </a:ext>
             </a:extLst>
           </p:cNvPr>
@@ -7289,7 +7289,7 @@
           <p:cNvPr id="12" name="">
             <a:extLst xmlns:a="http://schemas.openxmlformats.org/drawingml/2006/main">
               <a:ext uri="{FF2B5EF4-FFF2-40B4-BE49-F238E27FC236}">
-                <a16:creationId xmlns:a16="http://schemas.microsoft.com/office/drawing/2014/main" id="{A21ADEB7-AC12-4E14-B8B2-6AFAE8B23663}"/>
+                <a16:creationId xmlns:a16="http://schemas.microsoft.com/office/drawing/2014/main" id="{4367C293-1732-43BA-B7FA-08893BEA8E7B}"/>
               </a:ext>
             </a:extLst>
           </p:cNvPr>
@@ -7353,7 +7353,7 @@
         </p:xfrm>
         <a:graphic xmlns:a="http://schemas.openxmlformats.org/drawingml/2006/main">
           <a:graphicData uri="http://schemas.openxmlformats.org/drawingml/2006/chart">
-            <c:chart xmlns:r="http://schemas.openxmlformats.org/officeDocument/2006/relationships" xmlns:c="http://schemas.openxmlformats.org/drawingml/2006/chart" r:id="Rf06a2c4f8c644812"/>
+            <c:chart xmlns:r="http://schemas.openxmlformats.org/officeDocument/2006/relationships" xmlns:c="http://schemas.openxmlformats.org/drawingml/2006/chart" r:id="R3c1be84effc64bb8"/>
           </a:graphicData>
         </a:graphic>
       </p:graphicFrame>
@@ -7362,7 +7362,7 @@
           <p:cNvPr id="14" name="">
             <a:extLst xmlns:a="http://schemas.openxmlformats.org/drawingml/2006/main">
               <a:ext uri="{FF2B5EF4-FFF2-40B4-BE49-F238E27FC236}">
-                <a16:creationId xmlns:a16="http://schemas.microsoft.com/office/drawing/2014/main" id="{F3CA492C-95D1-44C7-A7DE-EA6019FBC463}"/>
+                <a16:creationId xmlns:a16="http://schemas.microsoft.com/office/drawing/2014/main" id="{E0A0C67E-867C-4C40-B52B-F9B9B5A0F2AA}"/>
               </a:ext>
             </a:extLst>
           </p:cNvPr>
@@ -7419,7 +7419,7 @@
           <p:cNvPr id="15" name="">
             <a:extLst xmlns:a="http://schemas.openxmlformats.org/drawingml/2006/main">
               <a:ext uri="{FF2B5EF4-FFF2-40B4-BE49-F238E27FC236}">
-                <a16:creationId xmlns:a16="http://schemas.microsoft.com/office/drawing/2014/main" id="{5FD6F093-CE41-4088-8FC8-4A133B0FCF78}"/>
+                <a16:creationId xmlns:a16="http://schemas.microsoft.com/office/drawing/2014/main" id="{C4E4A3B4-0329-42A8-A90C-7B0E46943853}"/>
               </a:ext>
             </a:extLst>
           </p:cNvPr>
@@ -7474,7 +7474,7 @@
     </p:spTree>
     <p:extLst>
       <p:ext uri="{BB962C8B-B14F-4D97-AF65-F5344CB8AC3E}">
-        <p14:creationId xmlns:p14="http://schemas.microsoft.com/office/powerpoint/2010/main" val="386402493"/>
+        <p14:creationId xmlns:p14="http://schemas.microsoft.com/office/powerpoint/2010/main" val="311173158"/>
       </p:ext>
     </p:extLst>
   </p:cSld>
@@ -7505,7 +7505,7 @@
           <p:cNvPr id="12" name="">
             <a:extLst xmlns:a="http://schemas.openxmlformats.org/drawingml/2006/main">
               <a:ext uri="{FF2B5EF4-FFF2-40B4-BE49-F238E27FC236}">
-                <a16:creationId xmlns:a16="http://schemas.microsoft.com/office/drawing/2014/main" id="{9435968F-5EC4-4417-A744-7AB4FE56E4D4}"/>
+                <a16:creationId xmlns:a16="http://schemas.microsoft.com/office/drawing/2014/main" id="{1D10444A-FCDC-4490-9E45-4D02A59F77FF}"/>
               </a:ext>
             </a:extLst>
           </p:cNvPr>
@@ -7562,7 +7562,7 @@
           <p:cNvPr id="2" name="">
             <a:extLst xmlns:a="http://schemas.openxmlformats.org/drawingml/2006/main">
               <a:ext uri="{FF2B5EF4-FFF2-40B4-BE49-F238E27FC236}">
-                <a16:creationId xmlns:a16="http://schemas.microsoft.com/office/drawing/2014/main" id="{2A448978-4B9B-41D3-9EBF-EE801592FF64}"/>
+                <a16:creationId xmlns:a16="http://schemas.microsoft.com/office/drawing/2014/main" id="{5EEF78F9-D106-42D9-93E4-065C870AF465}"/>
               </a:ext>
             </a:extLst>
           </p:cNvPr>
@@ -7619,7 +7619,7 @@
           <p:cNvPr id="3" name="">
             <a:extLst xmlns:a="http://schemas.openxmlformats.org/drawingml/2006/main">
               <a:ext uri="{FF2B5EF4-FFF2-40B4-BE49-F238E27FC236}">
-                <a16:creationId xmlns:a16="http://schemas.microsoft.com/office/drawing/2014/main" id="{BF1C97B5-134A-4AB9-A9C1-10A294E33991}"/>
+                <a16:creationId xmlns:a16="http://schemas.microsoft.com/office/drawing/2014/main" id="{8DAE67E9-8816-4CA8-9F51-7CD253831067}"/>
               </a:ext>
             </a:extLst>
           </p:cNvPr>
@@ -7683,7 +7683,7 @@
         </p:xfrm>
         <a:graphic xmlns:a="http://schemas.openxmlformats.org/drawingml/2006/main">
           <a:graphicData uri="http://schemas.openxmlformats.org/drawingml/2006/chart">
-            <c:chart xmlns:r="http://schemas.openxmlformats.org/officeDocument/2006/relationships" xmlns:c="http://schemas.openxmlformats.org/drawingml/2006/chart" r:id="R52a0bdaba48545bd"/>
+            <c:chart xmlns:r="http://schemas.openxmlformats.org/officeDocument/2006/relationships" xmlns:c="http://schemas.openxmlformats.org/drawingml/2006/chart" r:id="Rdfa5f142fa994233"/>
           </a:graphicData>
         </a:graphic>
       </p:graphicFrame>
@@ -7692,7 +7692,7 @@
           <p:cNvPr id="5" name="">
             <a:extLst xmlns:a="http://schemas.openxmlformats.org/drawingml/2006/main">
               <a:ext uri="{FF2B5EF4-FFF2-40B4-BE49-F238E27FC236}">
-                <a16:creationId xmlns:a16="http://schemas.microsoft.com/office/drawing/2014/main" id="{9875074C-79D6-4C8B-B12D-3284120ECC12}"/>
+                <a16:creationId xmlns:a16="http://schemas.microsoft.com/office/drawing/2014/main" id="{7EBF0986-7C0F-4062-A581-38068E7BB87F}"/>
               </a:ext>
             </a:extLst>
           </p:cNvPr>
@@ -7749,7 +7749,7 @@
           <p:cNvPr id="6" name="">
             <a:extLst xmlns:a="http://schemas.openxmlformats.org/drawingml/2006/main">
               <a:ext uri="{FF2B5EF4-FFF2-40B4-BE49-F238E27FC236}">
-                <a16:creationId xmlns:a16="http://schemas.microsoft.com/office/drawing/2014/main" id="{24E882D4-5EA2-490C-969A-ADEE3EA1E884}"/>
+                <a16:creationId xmlns:a16="http://schemas.microsoft.com/office/drawing/2014/main" id="{F08832E8-BB97-464D-8CBC-084758FDA159}"/>
               </a:ext>
             </a:extLst>
           </p:cNvPr>
@@ -7806,7 +7806,7 @@
           <p:cNvPr id="7" name="">
             <a:extLst xmlns:a="http://schemas.openxmlformats.org/drawingml/2006/main">
               <a:ext uri="{FF2B5EF4-FFF2-40B4-BE49-F238E27FC236}">
-                <a16:creationId xmlns:a16="http://schemas.microsoft.com/office/drawing/2014/main" id="{7B164F82-D417-4163-9FD7-44595E9DDB02}"/>
+                <a16:creationId xmlns:a16="http://schemas.microsoft.com/office/drawing/2014/main" id="{D3A20DA5-4F7A-4CA2-BD13-30D8431DA87B}"/>
               </a:ext>
             </a:extLst>
           </p:cNvPr>
@@ -7863,7 +7863,7 @@
           <p:cNvPr id="8" name="">
             <a:extLst xmlns:a="http://schemas.openxmlformats.org/drawingml/2006/main">
               <a:ext uri="{FF2B5EF4-FFF2-40B4-BE49-F238E27FC236}">
-                <a16:creationId xmlns:a16="http://schemas.microsoft.com/office/drawing/2014/main" id="{C4107FD5-1CD8-4FBF-814C-55CE43A432FC}"/>
+                <a16:creationId xmlns:a16="http://schemas.microsoft.com/office/drawing/2014/main" id="{3462A3D3-D76E-4CE3-B2B9-C14F9DA7B8F6}"/>
               </a:ext>
             </a:extLst>
           </p:cNvPr>
@@ -7920,7 +7920,7 @@
           <p:cNvPr id="9" name="">
             <a:extLst xmlns:a="http://schemas.openxmlformats.org/drawingml/2006/main">
               <a:ext uri="{FF2B5EF4-FFF2-40B4-BE49-F238E27FC236}">
-                <a16:creationId xmlns:a16="http://schemas.microsoft.com/office/drawing/2014/main" id="{6933E046-86F6-4B03-90E6-E5D208DD7C13}"/>
+                <a16:creationId xmlns:a16="http://schemas.microsoft.com/office/drawing/2014/main" id="{BB74431D-2E7D-45FC-875E-9FCC23A13D98}"/>
               </a:ext>
             </a:extLst>
           </p:cNvPr>
@@ -7977,7 +7977,7 @@
           <p:cNvPr id="10" name="">
             <a:extLst xmlns:a="http://schemas.openxmlformats.org/drawingml/2006/main">
               <a:ext uri="{FF2B5EF4-FFF2-40B4-BE49-F238E27FC236}">
-                <a16:creationId xmlns:a16="http://schemas.microsoft.com/office/drawing/2014/main" id="{656E242B-F794-4936-B540-214CFFA6A787}"/>
+                <a16:creationId xmlns:a16="http://schemas.microsoft.com/office/drawing/2014/main" id="{46F60C17-5AA2-49B7-A6A5-600E14C9E470}"/>
               </a:ext>
             </a:extLst>
           </p:cNvPr>
@@ -8034,7 +8034,7 @@
           <p:cNvPr id="11" name="">
             <a:extLst xmlns:a="http://schemas.openxmlformats.org/drawingml/2006/main">
               <a:ext uri="{FF2B5EF4-FFF2-40B4-BE49-F238E27FC236}">
-                <a16:creationId xmlns:a16="http://schemas.microsoft.com/office/drawing/2014/main" id="{C80D1403-F6DA-45FB-9BF0-6DE9ABBDFD0B}"/>
+                <a16:creationId xmlns:a16="http://schemas.microsoft.com/office/drawing/2014/main" id="{74657DF4-DE1F-465B-BF64-97E25D329F6E}"/>
               </a:ext>
             </a:extLst>
           </p:cNvPr>
@@ -8089,7 +8089,7 @@
     </p:spTree>
     <p:extLst>
       <p:ext uri="{BB962C8B-B14F-4D97-AF65-F5344CB8AC3E}">
-        <p14:creationId xmlns:p14="http://schemas.microsoft.com/office/powerpoint/2010/main" val="486428853"/>
+        <p14:creationId xmlns:p14="http://schemas.microsoft.com/office/powerpoint/2010/main" val="1928617563"/>
       </p:ext>
     </p:extLst>
   </p:cSld>
@@ -8120,7 +8120,7 @@
           <p:cNvPr id="12" name="">
             <a:extLst xmlns:a="http://schemas.openxmlformats.org/drawingml/2006/main">
               <a:ext uri="{FF2B5EF4-FFF2-40B4-BE49-F238E27FC236}">
-                <a16:creationId xmlns:a16="http://schemas.microsoft.com/office/drawing/2014/main" id="{46A3D470-4AA2-4710-8FA0-DCB12CACB345}"/>
+                <a16:creationId xmlns:a16="http://schemas.microsoft.com/office/drawing/2014/main" id="{09CB534B-B04E-4C3A-8CE1-EAF6D298660E}"/>
               </a:ext>
             </a:extLst>
           </p:cNvPr>
@@ -8177,7 +8177,7 @@
           <p:cNvPr id="2" name="">
             <a:extLst xmlns:a="http://schemas.openxmlformats.org/drawingml/2006/main">
               <a:ext uri="{FF2B5EF4-FFF2-40B4-BE49-F238E27FC236}">
-                <a16:creationId xmlns:a16="http://schemas.microsoft.com/office/drawing/2014/main" id="{96A6A305-5647-4FA2-9F33-B0D79360E50A}"/>
+                <a16:creationId xmlns:a16="http://schemas.microsoft.com/office/drawing/2014/main" id="{2039C4E4-D058-4F3E-B985-30FF2C385E0D}"/>
               </a:ext>
             </a:extLst>
           </p:cNvPr>
@@ -8234,7 +8234,7 @@
           <p:cNvPr id="3" name="">
             <a:extLst xmlns:a="http://schemas.openxmlformats.org/drawingml/2006/main">
               <a:ext uri="{FF2B5EF4-FFF2-40B4-BE49-F238E27FC236}">
-                <a16:creationId xmlns:a16="http://schemas.microsoft.com/office/drawing/2014/main" id="{D8997151-F3DC-4F23-8BA6-88FB4FF64708}"/>
+                <a16:creationId xmlns:a16="http://schemas.microsoft.com/office/drawing/2014/main" id="{EC522A75-81C8-4284-BFA8-4253945E9A8A}"/>
               </a:ext>
             </a:extLst>
           </p:cNvPr>
@@ -8298,7 +8298,7 @@
         </p:xfrm>
         <a:graphic xmlns:a="http://schemas.openxmlformats.org/drawingml/2006/main">
           <a:graphicData uri="http://schemas.openxmlformats.org/drawingml/2006/chart">
-            <c:chart xmlns:r="http://schemas.openxmlformats.org/officeDocument/2006/relationships" xmlns:c="http://schemas.openxmlformats.org/drawingml/2006/chart" r:id="Rdf97942adbdc40c1"/>
+            <c:chart xmlns:r="http://schemas.openxmlformats.org/officeDocument/2006/relationships" xmlns:c="http://schemas.openxmlformats.org/drawingml/2006/chart" r:id="Re37d6a3b5b31485d"/>
           </a:graphicData>
         </a:graphic>
       </p:graphicFrame>
@@ -8307,7 +8307,7 @@
           <p:cNvPr id="5" name="">
             <a:extLst xmlns:a="http://schemas.openxmlformats.org/drawingml/2006/main">
               <a:ext uri="{FF2B5EF4-FFF2-40B4-BE49-F238E27FC236}">
-                <a16:creationId xmlns:a16="http://schemas.microsoft.com/office/drawing/2014/main" id="{ED6809C4-D1DE-40B6-A24E-EF1B8213BDB1}"/>
+                <a16:creationId xmlns:a16="http://schemas.microsoft.com/office/drawing/2014/main" id="{F23B7E77-5D6F-47CF-AAA6-ECB89B916FFF}"/>
               </a:ext>
             </a:extLst>
           </p:cNvPr>
@@ -8364,7 +8364,7 @@
           <p:cNvPr id="6" name="">
             <a:extLst xmlns:a="http://schemas.openxmlformats.org/drawingml/2006/main">
               <a:ext uri="{FF2B5EF4-FFF2-40B4-BE49-F238E27FC236}">
-                <a16:creationId xmlns:a16="http://schemas.microsoft.com/office/drawing/2014/main" id="{82410CBB-660F-4272-A8FB-BAD9AA97B54D}"/>
+                <a16:creationId xmlns:a16="http://schemas.microsoft.com/office/drawing/2014/main" id="{60E0167C-C886-4177-B9E8-784E31C6A382}"/>
               </a:ext>
             </a:extLst>
           </p:cNvPr>
@@ -8421,7 +8421,7 @@
           <p:cNvPr id="7" name="">
             <a:extLst xmlns:a="http://schemas.openxmlformats.org/drawingml/2006/main">
               <a:ext uri="{FF2B5EF4-FFF2-40B4-BE49-F238E27FC236}">
-                <a16:creationId xmlns:a16="http://schemas.microsoft.com/office/drawing/2014/main" id="{DFE89C11-BD90-49D0-AD68-331ECE819CC5}"/>
+                <a16:creationId xmlns:a16="http://schemas.microsoft.com/office/drawing/2014/main" id="{FB300BD5-2618-4F72-ADCF-CF950685B097}"/>
               </a:ext>
             </a:extLst>
           </p:cNvPr>
@@ -8478,7 +8478,7 @@
           <p:cNvPr id="8" name="">
             <a:extLst xmlns:a="http://schemas.openxmlformats.org/drawingml/2006/main">
               <a:ext uri="{FF2B5EF4-FFF2-40B4-BE49-F238E27FC236}">
-                <a16:creationId xmlns:a16="http://schemas.microsoft.com/office/drawing/2014/main" id="{772635BA-E3E6-4F3D-8C1F-E8BA876951F9}"/>
+                <a16:creationId xmlns:a16="http://schemas.microsoft.com/office/drawing/2014/main" id="{58C6CC3D-F150-4B05-B98E-884D0BB091F9}"/>
               </a:ext>
             </a:extLst>
           </p:cNvPr>
@@ -8535,7 +8535,7 @@
           <p:cNvPr id="9" name="">
             <a:extLst xmlns:a="http://schemas.openxmlformats.org/drawingml/2006/main">
               <a:ext uri="{FF2B5EF4-FFF2-40B4-BE49-F238E27FC236}">
-                <a16:creationId xmlns:a16="http://schemas.microsoft.com/office/drawing/2014/main" id="{9A52C3D3-655E-43E0-80CD-D073C723F0FF}"/>
+                <a16:creationId xmlns:a16="http://schemas.microsoft.com/office/drawing/2014/main" id="{3A7434D4-FAB2-4531-ABDF-1698020366B1}"/>
               </a:ext>
             </a:extLst>
           </p:cNvPr>
@@ -8592,7 +8592,7 @@
           <p:cNvPr id="10" name="">
             <a:extLst xmlns:a="http://schemas.openxmlformats.org/drawingml/2006/main">
               <a:ext uri="{FF2B5EF4-FFF2-40B4-BE49-F238E27FC236}">
-                <a16:creationId xmlns:a16="http://schemas.microsoft.com/office/drawing/2014/main" id="{B2C1B0CF-211A-4099-8830-884086EAE3EC}"/>
+                <a16:creationId xmlns:a16="http://schemas.microsoft.com/office/drawing/2014/main" id="{7ACC8045-5496-463C-9771-0FF24E8BBE98}"/>
               </a:ext>
             </a:extLst>
           </p:cNvPr>
@@ -8649,7 +8649,7 @@
           <p:cNvPr id="11" name="">
             <a:extLst xmlns:a="http://schemas.openxmlformats.org/drawingml/2006/main">
               <a:ext uri="{FF2B5EF4-FFF2-40B4-BE49-F238E27FC236}">
-                <a16:creationId xmlns:a16="http://schemas.microsoft.com/office/drawing/2014/main" id="{1B188DC8-4A9A-493C-B477-9937848B94AC}"/>
+                <a16:creationId xmlns:a16="http://schemas.microsoft.com/office/drawing/2014/main" id="{650D2CB8-DCD5-4766-A5CA-3F13902918C0}"/>
               </a:ext>
             </a:extLst>
           </p:cNvPr>
@@ -8704,7 +8704,7 @@
     </p:spTree>
     <p:extLst>
       <p:ext uri="{BB962C8B-B14F-4D97-AF65-F5344CB8AC3E}">
-        <p14:creationId xmlns:p14="http://schemas.microsoft.com/office/powerpoint/2010/main" val="813713526"/>
+        <p14:creationId xmlns:p14="http://schemas.microsoft.com/office/powerpoint/2010/main" val="925143214"/>
       </p:ext>
     </p:extLst>
   </p:cSld>
@@ -8735,7 +8735,7 @@
           <p:cNvPr id="12" name="">
             <a:extLst xmlns:a="http://schemas.openxmlformats.org/drawingml/2006/main">
               <a:ext uri="{FF2B5EF4-FFF2-40B4-BE49-F238E27FC236}">
-                <a16:creationId xmlns:a16="http://schemas.microsoft.com/office/drawing/2014/main" id="{CA213240-B3E3-46BE-AB49-782966FD6009}"/>
+                <a16:creationId xmlns:a16="http://schemas.microsoft.com/office/drawing/2014/main" id="{199939C6-976C-4A06-B8CE-665C990443CC}"/>
               </a:ext>
             </a:extLst>
           </p:cNvPr>
@@ -8792,7 +8792,7 @@
           <p:cNvPr id="2" name="">
             <a:extLst xmlns:a="http://schemas.openxmlformats.org/drawingml/2006/main">
               <a:ext uri="{FF2B5EF4-FFF2-40B4-BE49-F238E27FC236}">
-                <a16:creationId xmlns:a16="http://schemas.microsoft.com/office/drawing/2014/main" id="{6E1E075D-9D5D-4324-AF04-2A8454D2BFF0}"/>
+                <a16:creationId xmlns:a16="http://schemas.microsoft.com/office/drawing/2014/main" id="{A1E91328-0CCA-4531-B19A-D146F9FE46F2}"/>
               </a:ext>
             </a:extLst>
           </p:cNvPr>
@@ -8849,7 +8849,7 @@
           <p:cNvPr id="3" name="">
             <a:extLst xmlns:a="http://schemas.openxmlformats.org/drawingml/2006/main">
               <a:ext uri="{FF2B5EF4-FFF2-40B4-BE49-F238E27FC236}">
-                <a16:creationId xmlns:a16="http://schemas.microsoft.com/office/drawing/2014/main" id="{AB2D07DB-EDB5-427D-BD2C-424D512C5783}"/>
+                <a16:creationId xmlns:a16="http://schemas.microsoft.com/office/drawing/2014/main" id="{FFE5467F-A551-4803-9CDE-18E447549B96}"/>
               </a:ext>
             </a:extLst>
           </p:cNvPr>
@@ -8906,7 +8906,7 @@
           <p:cNvPr id="4" name="">
             <a:extLst xmlns:a="http://schemas.openxmlformats.org/drawingml/2006/main">
               <a:ext uri="{FF2B5EF4-FFF2-40B4-BE49-F238E27FC236}">
-                <a16:creationId xmlns:a16="http://schemas.microsoft.com/office/drawing/2014/main" id="{916708B5-BC48-4113-B89A-2886BF86FB3A}"/>
+                <a16:creationId xmlns:a16="http://schemas.microsoft.com/office/drawing/2014/main" id="{A8691F85-6EE9-4E10-BCBC-144DC48D932C}"/>
               </a:ext>
             </a:extLst>
           </p:cNvPr>
@@ -8963,7 +8963,7 @@
           <p:cNvPr id="5" name="">
             <a:extLst xmlns:a="http://schemas.openxmlformats.org/drawingml/2006/main">
               <a:ext uri="{FF2B5EF4-FFF2-40B4-BE49-F238E27FC236}">
-                <a16:creationId xmlns:a16="http://schemas.microsoft.com/office/drawing/2014/main" id="{276B84E5-99BE-42E0-BC20-53E17563EFBD}"/>
+                <a16:creationId xmlns:a16="http://schemas.microsoft.com/office/drawing/2014/main" id="{45C2439B-E3D5-4A0A-BD94-26C40AA8AE69}"/>
               </a:ext>
             </a:extLst>
           </p:cNvPr>
@@ -9020,7 +9020,7 @@
           <p:cNvPr id="6" name="">
             <a:extLst xmlns:a="http://schemas.openxmlformats.org/drawingml/2006/main">
               <a:ext uri="{FF2B5EF4-FFF2-40B4-BE49-F238E27FC236}">
-                <a16:creationId xmlns:a16="http://schemas.microsoft.com/office/drawing/2014/main" id="{734E5A2F-EE94-4499-894F-4EA536558D9E}"/>
+                <a16:creationId xmlns:a16="http://schemas.microsoft.com/office/drawing/2014/main" id="{8E6207BE-9F7E-4561-842F-6BBEE06F0966}"/>
               </a:ext>
             </a:extLst>
           </p:cNvPr>
@@ -9077,7 +9077,7 @@
           <p:cNvPr id="7" name="">
             <a:extLst xmlns:a="http://schemas.openxmlformats.org/drawingml/2006/main">
               <a:ext uri="{FF2B5EF4-FFF2-40B4-BE49-F238E27FC236}">
-                <a16:creationId xmlns:a16="http://schemas.microsoft.com/office/drawing/2014/main" id="{955C764B-1679-400B-A6A9-C201C4292CF4}"/>
+                <a16:creationId xmlns:a16="http://schemas.microsoft.com/office/drawing/2014/main" id="{A015BF3B-F485-4E40-AA5E-50E2E129BE29}"/>
               </a:ext>
             </a:extLst>
           </p:cNvPr>
@@ -9134,7 +9134,7 @@
           <p:cNvPr id="8" name="">
             <a:extLst xmlns:a="http://schemas.openxmlformats.org/drawingml/2006/main">
               <a:ext uri="{FF2B5EF4-FFF2-40B4-BE49-F238E27FC236}">
-                <a16:creationId xmlns:a16="http://schemas.microsoft.com/office/drawing/2014/main" id="{7A7DF0DE-2157-43D3-BEBE-330B77F60D78}"/>
+                <a16:creationId xmlns:a16="http://schemas.microsoft.com/office/drawing/2014/main" id="{70B1AF5B-FB9A-45A1-917E-AD8C91EC51E5}"/>
               </a:ext>
             </a:extLst>
           </p:cNvPr>
@@ -9191,7 +9191,7 @@
           <p:cNvPr id="9" name="">
             <a:extLst xmlns:a="http://schemas.openxmlformats.org/drawingml/2006/main">
               <a:ext uri="{FF2B5EF4-FFF2-40B4-BE49-F238E27FC236}">
-                <a16:creationId xmlns:a16="http://schemas.microsoft.com/office/drawing/2014/main" id="{253107F8-CDD2-40A9-8B74-6F9D7CFEC2FC}"/>
+                <a16:creationId xmlns:a16="http://schemas.microsoft.com/office/drawing/2014/main" id="{055A1E31-DF30-45F6-B041-A7D035DE03DD}"/>
               </a:ext>
             </a:extLst>
           </p:cNvPr>
@@ -9248,7 +9248,7 @@
           <p:cNvPr id="10" name="">
             <a:extLst xmlns:a="http://schemas.openxmlformats.org/drawingml/2006/main">
               <a:ext uri="{FF2B5EF4-FFF2-40B4-BE49-F238E27FC236}">
-                <a16:creationId xmlns:a16="http://schemas.microsoft.com/office/drawing/2014/main" id="{4C1E4176-5CF9-4E56-BB12-C9F814197A20}"/>
+                <a16:creationId xmlns:a16="http://schemas.microsoft.com/office/drawing/2014/main" id="{E31F10DE-C9A2-48CF-88D0-3530E83C9136}"/>
               </a:ext>
             </a:extLst>
           </p:cNvPr>
@@ -9305,7 +9305,7 @@
           <p:cNvPr id="11" name="">
             <a:extLst xmlns:a="http://schemas.openxmlformats.org/drawingml/2006/main">
               <a:ext uri="{FF2B5EF4-FFF2-40B4-BE49-F238E27FC236}">
-                <a16:creationId xmlns:a16="http://schemas.microsoft.com/office/drawing/2014/main" id="{7D480393-D3C8-4A02-AB32-048C19118A26}"/>
+                <a16:creationId xmlns:a16="http://schemas.microsoft.com/office/drawing/2014/main" id="{2D792161-6C08-49B1-91DD-369FC13504DC}"/>
               </a:ext>
             </a:extLst>
           </p:cNvPr>
@@ -9360,7 +9360,7 @@
     </p:spTree>
     <p:extLst>
       <p:ext uri="{BB962C8B-B14F-4D97-AF65-F5344CB8AC3E}">
-        <p14:creationId xmlns:p14="http://schemas.microsoft.com/office/powerpoint/2010/main" val="729210637"/>
+        <p14:creationId xmlns:p14="http://schemas.microsoft.com/office/powerpoint/2010/main" val="2102989168"/>
       </p:ext>
     </p:extLst>
   </p:cSld>
@@ -9391,7 +9391,7 @@
           <p:cNvPr id="12" name="">
             <a:extLst xmlns:a="http://schemas.openxmlformats.org/drawingml/2006/main">
               <a:ext uri="{FF2B5EF4-FFF2-40B4-BE49-F238E27FC236}">
-                <a16:creationId xmlns:a16="http://schemas.microsoft.com/office/drawing/2014/main" id="{9628DE86-91AE-43A5-85F6-11E6629E8B89}"/>
+                <a16:creationId xmlns:a16="http://schemas.microsoft.com/office/drawing/2014/main" id="{78342080-21FB-43A9-8A1F-74A2D608A3F5}"/>
               </a:ext>
             </a:extLst>
           </p:cNvPr>
@@ -9448,7 +9448,7 @@
           <p:cNvPr id="2" name="">
             <a:extLst xmlns:a="http://schemas.openxmlformats.org/drawingml/2006/main">
               <a:ext uri="{FF2B5EF4-FFF2-40B4-BE49-F238E27FC236}">
-                <a16:creationId xmlns:a16="http://schemas.microsoft.com/office/drawing/2014/main" id="{8F26F9D5-659B-4A19-9FEF-258E5D5E763E}"/>
+                <a16:creationId xmlns:a16="http://schemas.microsoft.com/office/drawing/2014/main" id="{7D9BEAE6-BBC5-4819-8000-EDC45149B177}"/>
               </a:ext>
             </a:extLst>
           </p:cNvPr>
@@ -9505,7 +9505,7 @@
           <p:cNvPr id="3" name="">
             <a:extLst xmlns:a="http://schemas.openxmlformats.org/drawingml/2006/main">
               <a:ext uri="{FF2B5EF4-FFF2-40B4-BE49-F238E27FC236}">
-                <a16:creationId xmlns:a16="http://schemas.microsoft.com/office/drawing/2014/main" id="{405FE0F5-C070-43A8-97F1-4092CE7318B8}"/>
+                <a16:creationId xmlns:a16="http://schemas.microsoft.com/office/drawing/2014/main" id="{C22A5DB5-B7FD-4025-9EDB-E4F3544EAEEC}"/>
               </a:ext>
             </a:extLst>
           </p:cNvPr>
@@ -9569,7 +9569,7 @@
         </p:xfrm>
         <a:graphic xmlns:a="http://schemas.openxmlformats.org/drawingml/2006/main">
           <a:graphicData uri="http://schemas.openxmlformats.org/drawingml/2006/chart">
-            <c:chart xmlns:r="http://schemas.openxmlformats.org/officeDocument/2006/relationships" xmlns:c="http://schemas.openxmlformats.org/drawingml/2006/chart" r:id="Rc415e283d68e4231"/>
+            <c:chart xmlns:r="http://schemas.openxmlformats.org/officeDocument/2006/relationships" xmlns:c="http://schemas.openxmlformats.org/drawingml/2006/chart" r:id="R21a1f1b88a6843b5"/>
           </a:graphicData>
         </a:graphic>
       </p:graphicFrame>
@@ -9578,7 +9578,7 @@
           <p:cNvPr id="5" name="">
             <a:extLst xmlns:a="http://schemas.openxmlformats.org/drawingml/2006/main">
               <a:ext uri="{FF2B5EF4-FFF2-40B4-BE49-F238E27FC236}">
-                <a16:creationId xmlns:a16="http://schemas.microsoft.com/office/drawing/2014/main" id="{A7716CB1-156D-4A2B-9123-B864EFE964B8}"/>
+                <a16:creationId xmlns:a16="http://schemas.microsoft.com/office/drawing/2014/main" id="{5F4C934A-EAC4-4364-9386-ADB095732954}"/>
               </a:ext>
             </a:extLst>
           </p:cNvPr>
@@ -9625,7 +9625,7 @@
                 <a:ea typeface="Heiti TC"/>
                 <a:cs typeface="Heiti TC"/>
               </a:rPr>
-              <a:t>每天 3.5 小時，約得多少分？</a:t>
+              <a:t>3.5 小時的預測成績？</a:t>
             </a:r>
           </a:p>
         </p:txBody>
@@ -9635,7 +9635,7 @@
           <p:cNvPr id="6" name="">
             <a:extLst xmlns:a="http://schemas.openxmlformats.org/drawingml/2006/main">
               <a:ext uri="{FF2B5EF4-FFF2-40B4-BE49-F238E27FC236}">
-                <a16:creationId xmlns:a16="http://schemas.microsoft.com/office/drawing/2014/main" id="{04D32596-6C08-4CA1-A122-01061292C972}"/>
+                <a16:creationId xmlns:a16="http://schemas.microsoft.com/office/drawing/2014/main" id="{E09EC24C-1D60-4F65-9F84-73D376F8DC98}"/>
               </a:ext>
             </a:extLst>
           </p:cNvPr>
@@ -9682,7 +9682,7 @@
                 <a:ea typeface="Arial"/>
                 <a:cs typeface="Arial"/>
               </a:rPr>
-              <a:t>About what score for 3.5 hours a day?</a:t>
+              <a:t>Score for 3.5 hours a day?</a:t>
             </a:r>
           </a:p>
         </p:txBody>
@@ -9692,7 +9692,7 @@
           <p:cNvPr id="7" name="">
             <a:extLst xmlns:a="http://schemas.openxmlformats.org/drawingml/2006/main">
               <a:ext uri="{FF2B5EF4-FFF2-40B4-BE49-F238E27FC236}">
-                <a16:creationId xmlns:a16="http://schemas.microsoft.com/office/drawing/2014/main" id="{74F9C04D-64D1-475E-B365-F72F056960BA}"/>
+                <a16:creationId xmlns:a16="http://schemas.microsoft.com/office/drawing/2014/main" id="{0D8C0AF0-54B0-44F3-A8F7-CBF64DD3EDC9}"/>
               </a:ext>
             </a:extLst>
           </p:cNvPr>
@@ -9749,7 +9749,7 @@
           <p:cNvPr id="8" name="">
             <a:extLst xmlns:a="http://schemas.openxmlformats.org/drawingml/2006/main">
               <a:ext uri="{FF2B5EF4-FFF2-40B4-BE49-F238E27FC236}">
-                <a16:creationId xmlns:a16="http://schemas.microsoft.com/office/drawing/2014/main" id="{F9F85428-197A-48EC-9C9B-8C48329BA773}"/>
+                <a16:creationId xmlns:a16="http://schemas.microsoft.com/office/drawing/2014/main" id="{CAD22AD1-1F71-48F3-8473-0C6000D11DCC}"/>
               </a:ext>
             </a:extLst>
           </p:cNvPr>
@@ -9806,7 +9806,7 @@
           <p:cNvPr id="9" name="">
             <a:extLst xmlns:a="http://schemas.openxmlformats.org/drawingml/2006/main">
               <a:ext uri="{FF2B5EF4-FFF2-40B4-BE49-F238E27FC236}">
-                <a16:creationId xmlns:a16="http://schemas.microsoft.com/office/drawing/2014/main" id="{888C94A4-510D-4A81-84DA-5715045B0C2D}"/>
+                <a16:creationId xmlns:a16="http://schemas.microsoft.com/office/drawing/2014/main" id="{26CA0E76-B698-4722-8C21-41ABC9ADBFEF}"/>
               </a:ext>
             </a:extLst>
           </p:cNvPr>
@@ -9863,7 +9863,7 @@
           <p:cNvPr id="10" name="">
             <a:extLst xmlns:a="http://schemas.openxmlformats.org/drawingml/2006/main">
               <a:ext uri="{FF2B5EF4-FFF2-40B4-BE49-F238E27FC236}">
-                <a16:creationId xmlns:a16="http://schemas.microsoft.com/office/drawing/2014/main" id="{FC72290C-892E-4A33-93E3-DDFDD6802902}"/>
+                <a16:creationId xmlns:a16="http://schemas.microsoft.com/office/drawing/2014/main" id="{D091F5C5-9138-45AF-B3D0-03DFDF19B829}"/>
               </a:ext>
             </a:extLst>
           </p:cNvPr>
@@ -9920,7 +9920,7 @@
           <p:cNvPr id="11" name="">
             <a:extLst xmlns:a="http://schemas.openxmlformats.org/drawingml/2006/main">
               <a:ext uri="{FF2B5EF4-FFF2-40B4-BE49-F238E27FC236}">
-                <a16:creationId xmlns:a16="http://schemas.microsoft.com/office/drawing/2014/main" id="{FA23A155-0D5C-4850-A78C-468D2C483A34}"/>
+                <a16:creationId xmlns:a16="http://schemas.microsoft.com/office/drawing/2014/main" id="{A8F22401-AD61-4293-A1AF-731B7861115B}"/>
               </a:ext>
             </a:extLst>
           </p:cNvPr>
@@ -9975,7 +9975,7 @@
     </p:spTree>
     <p:extLst>
       <p:ext uri="{BB962C8B-B14F-4D97-AF65-F5344CB8AC3E}">
-        <p14:creationId xmlns:p14="http://schemas.microsoft.com/office/powerpoint/2010/main" val="1033701196"/>
+        <p14:creationId xmlns:p14="http://schemas.microsoft.com/office/powerpoint/2010/main" val="788462280"/>
       </p:ext>
     </p:extLst>
   </p:cSld>
@@ -10006,7 +10006,7 @@
           <p:cNvPr id="15" name="">
             <a:extLst xmlns:a="http://schemas.openxmlformats.org/drawingml/2006/main">
               <a:ext uri="{FF2B5EF4-FFF2-40B4-BE49-F238E27FC236}">
-                <a16:creationId xmlns:a16="http://schemas.microsoft.com/office/drawing/2014/main" id="{136ADC5B-D198-4BD7-B0A9-B13E41EE23DF}"/>
+                <a16:creationId xmlns:a16="http://schemas.microsoft.com/office/drawing/2014/main" id="{3EAC87F3-17A3-4262-9139-25574F8740D5}"/>
               </a:ext>
             </a:extLst>
           </p:cNvPr>
@@ -10063,7 +10063,7 @@
           <p:cNvPr id="2" name="">
             <a:extLst xmlns:a="http://schemas.openxmlformats.org/drawingml/2006/main">
               <a:ext uri="{FF2B5EF4-FFF2-40B4-BE49-F238E27FC236}">
-                <a16:creationId xmlns:a16="http://schemas.microsoft.com/office/drawing/2014/main" id="{EC180893-B93C-4A2A-AD5F-A6BDF70ED71D}"/>
+                <a16:creationId xmlns:a16="http://schemas.microsoft.com/office/drawing/2014/main" id="{EC32A996-F461-467C-A6F9-EDE92BD6DC8E}"/>
               </a:ext>
             </a:extLst>
           </p:cNvPr>
@@ -10120,7 +10120,7 @@
           <p:cNvPr id="3" name="">
             <a:extLst xmlns:a="http://schemas.openxmlformats.org/drawingml/2006/main">
               <a:ext uri="{FF2B5EF4-FFF2-40B4-BE49-F238E27FC236}">
-                <a16:creationId xmlns:a16="http://schemas.microsoft.com/office/drawing/2014/main" id="{1378A81C-528E-41C5-9645-7DCD12472330}"/>
+                <a16:creationId xmlns:a16="http://schemas.microsoft.com/office/drawing/2014/main" id="{829C64E5-4611-4FA7-A7E4-4B5B7FCE8E40}"/>
               </a:ext>
             </a:extLst>
           </p:cNvPr>
@@ -10177,7 +10177,7 @@
           <p:cNvPr id="4" name="">
             <a:extLst xmlns:a="http://schemas.openxmlformats.org/drawingml/2006/main">
               <a:ext uri="{FF2B5EF4-FFF2-40B4-BE49-F238E27FC236}">
-                <a16:creationId xmlns:a16="http://schemas.microsoft.com/office/drawing/2014/main" id="{43A69288-6F4D-4753-BC41-D77945469299}"/>
+                <a16:creationId xmlns:a16="http://schemas.microsoft.com/office/drawing/2014/main" id="{D10E744C-606C-4AD8-8CBA-C0DEF5CE21E1}"/>
               </a:ext>
             </a:extLst>
           </p:cNvPr>
@@ -10234,7 +10234,7 @@
           <p:cNvPr id="5" name="">
             <a:extLst xmlns:a="http://schemas.openxmlformats.org/drawingml/2006/main">
               <a:ext uri="{FF2B5EF4-FFF2-40B4-BE49-F238E27FC236}">
-                <a16:creationId xmlns:a16="http://schemas.microsoft.com/office/drawing/2014/main" id="{A1E45746-8567-4677-A457-98642FB7CF30}"/>
+                <a16:creationId xmlns:a16="http://schemas.microsoft.com/office/drawing/2014/main" id="{92D368E6-2882-498C-A42F-C339875D4070}"/>
               </a:ext>
             </a:extLst>
           </p:cNvPr>
@@ -10291,7 +10291,7 @@
           <p:cNvPr id="6" name="">
             <a:extLst xmlns:a="http://schemas.openxmlformats.org/drawingml/2006/main">
               <a:ext uri="{FF2B5EF4-FFF2-40B4-BE49-F238E27FC236}">
-                <a16:creationId xmlns:a16="http://schemas.microsoft.com/office/drawing/2014/main" id="{B479947D-44C8-40B7-AF36-19F4D773FD4A}"/>
+                <a16:creationId xmlns:a16="http://schemas.microsoft.com/office/drawing/2014/main" id="{FCE77090-F89A-44D0-8EA8-A5C95401D16A}"/>
               </a:ext>
             </a:extLst>
           </p:cNvPr>
@@ -10348,7 +10348,7 @@
           <p:cNvPr id="7" name="">
             <a:extLst xmlns:a="http://schemas.openxmlformats.org/drawingml/2006/main">
               <a:ext uri="{FF2B5EF4-FFF2-40B4-BE49-F238E27FC236}">
-                <a16:creationId xmlns:a16="http://schemas.microsoft.com/office/drawing/2014/main" id="{4B75E1C9-5A9E-42CF-9703-34D8B975ACAC}"/>
+                <a16:creationId xmlns:a16="http://schemas.microsoft.com/office/drawing/2014/main" id="{6884F604-4620-484D-9A6C-D395BE784B65}"/>
               </a:ext>
             </a:extLst>
           </p:cNvPr>
@@ -10405,7 +10405,7 @@
           <p:cNvPr id="8" name="">
             <a:extLst xmlns:a="http://schemas.openxmlformats.org/drawingml/2006/main">
               <a:ext uri="{FF2B5EF4-FFF2-40B4-BE49-F238E27FC236}">
-                <a16:creationId xmlns:a16="http://schemas.microsoft.com/office/drawing/2014/main" id="{4BCE816D-10CD-4963-91FF-944EA280C19A}"/>
+                <a16:creationId xmlns:a16="http://schemas.microsoft.com/office/drawing/2014/main" id="{E8D4BB63-C1C4-42C3-A555-9055BBE5EB2B}"/>
               </a:ext>
             </a:extLst>
           </p:cNvPr>
@@ -10462,7 +10462,7 @@
           <p:cNvPr id="9" name="">
             <a:extLst xmlns:a="http://schemas.openxmlformats.org/drawingml/2006/main">
               <a:ext uri="{FF2B5EF4-FFF2-40B4-BE49-F238E27FC236}">
-                <a16:creationId xmlns:a16="http://schemas.microsoft.com/office/drawing/2014/main" id="{56B394EF-CAA9-4EFF-85E5-D8BC7EE051E4}"/>
+                <a16:creationId xmlns:a16="http://schemas.microsoft.com/office/drawing/2014/main" id="{F60ED57F-3969-4A7F-AF86-1AAC6C86DB68}"/>
               </a:ext>
             </a:extLst>
           </p:cNvPr>
@@ -10519,7 +10519,7 @@
           <p:cNvPr id="10" name="">
             <a:extLst xmlns:a="http://schemas.openxmlformats.org/drawingml/2006/main">
               <a:ext uri="{FF2B5EF4-FFF2-40B4-BE49-F238E27FC236}">
-                <a16:creationId xmlns:a16="http://schemas.microsoft.com/office/drawing/2014/main" id="{1692F209-438E-4A6D-B27F-FF388A1ACB4C}"/>
+                <a16:creationId xmlns:a16="http://schemas.microsoft.com/office/drawing/2014/main" id="{99CC448C-A01C-4A27-B434-BBFAF8DF3880}"/>
               </a:ext>
             </a:extLst>
           </p:cNvPr>
@@ -10576,7 +10576,7 @@
           <p:cNvPr id="11" name="">
             <a:extLst xmlns:a="http://schemas.openxmlformats.org/drawingml/2006/main">
               <a:ext uri="{FF2B5EF4-FFF2-40B4-BE49-F238E27FC236}">
-                <a16:creationId xmlns:a16="http://schemas.microsoft.com/office/drawing/2014/main" id="{81CF90FA-1079-46EE-80A8-EBBA93AB1FEF}"/>
+                <a16:creationId xmlns:a16="http://schemas.microsoft.com/office/drawing/2014/main" id="{21CA48EA-F921-4D0B-9E4C-5F55BC7230BC}"/>
               </a:ext>
             </a:extLst>
           </p:cNvPr>
@@ -10633,7 +10633,7 @@
           <p:cNvPr id="12" name="">
             <a:extLst xmlns:a="http://schemas.openxmlformats.org/drawingml/2006/main">
               <a:ext uri="{FF2B5EF4-FFF2-40B4-BE49-F238E27FC236}">
-                <a16:creationId xmlns:a16="http://schemas.microsoft.com/office/drawing/2014/main" id="{385F1C61-D90C-425B-AA4E-5D5D238173B8}"/>
+                <a16:creationId xmlns:a16="http://schemas.microsoft.com/office/drawing/2014/main" id="{4EAF6218-D012-4B1E-B65E-637C2BBD9849}"/>
               </a:ext>
             </a:extLst>
           </p:cNvPr>
@@ -10690,7 +10690,7 @@
           <p:cNvPr id="13" name="">
             <a:extLst xmlns:a="http://schemas.openxmlformats.org/drawingml/2006/main">
               <a:ext uri="{FF2B5EF4-FFF2-40B4-BE49-F238E27FC236}">
-                <a16:creationId xmlns:a16="http://schemas.microsoft.com/office/drawing/2014/main" id="{849843D8-DC30-4FD3-9669-312A5481ABC5}"/>
+                <a16:creationId xmlns:a16="http://schemas.microsoft.com/office/drawing/2014/main" id="{7801DF10-1C05-4565-B505-8E5FD391D854}"/>
               </a:ext>
             </a:extLst>
           </p:cNvPr>
@@ -10747,7 +10747,7 @@
           <p:cNvPr id="14" name="">
             <a:extLst xmlns:a="http://schemas.openxmlformats.org/drawingml/2006/main">
               <a:ext uri="{FF2B5EF4-FFF2-40B4-BE49-F238E27FC236}">
-                <a16:creationId xmlns:a16="http://schemas.microsoft.com/office/drawing/2014/main" id="{15797FF8-4837-4787-AEF1-5E073D4E3918}"/>
+                <a16:creationId xmlns:a16="http://schemas.microsoft.com/office/drawing/2014/main" id="{EED38E19-6F88-49C3-966F-A216BAE232F5}"/>
               </a:ext>
             </a:extLst>
           </p:cNvPr>
@@ -10802,7 +10802,7 @@
     </p:spTree>
     <p:extLst>
       <p:ext uri="{BB962C8B-B14F-4D97-AF65-F5344CB8AC3E}">
-        <p14:creationId xmlns:p14="http://schemas.microsoft.com/office/powerpoint/2010/main" val="1794675191"/>
+        <p14:creationId xmlns:p14="http://schemas.microsoft.com/office/powerpoint/2010/main" val="1855809145"/>
       </p:ext>
     </p:extLst>
   </p:cSld>

</xml_diff>

<commit_message>
Let students draw an intuitive line and simplify worksheet reflection
</commit_message>
<xml_diff>
--- a/teacher-slides.pptx
+++ b/teacher-slides.pptx
@@ -2,22 +2,22 @@
 <file path=ppt/presentation.xml><?xml version="1.0" encoding="utf-8"?>
 <p:presentation xmlns:p="http://schemas.openxmlformats.org/presentationml/2006/main">
   <p:sldMasterIdLst>
-    <p:sldMasterId xmlns:r="http://schemas.openxmlformats.org/officeDocument/2006/relationships" id="2147483648" r:id="Rd4942d0f4c974a87"/>
+    <p:sldMasterId xmlns:r="http://schemas.openxmlformats.org/officeDocument/2006/relationships" id="2147483648" r:id="Rb87840c133ba45a1"/>
   </p:sldMasterIdLst>
   <p:notesMasterIdLst>
-    <p:notesMasterId xmlns:r="http://schemas.openxmlformats.org/officeDocument/2006/relationships" r:id="Rf08cb87359924918"/>
+    <p:notesMasterId xmlns:r="http://schemas.openxmlformats.org/officeDocument/2006/relationships" r:id="R37cede2ce28f43a5"/>
   </p:notesMasterIdLst>
   <p:sldIdLst>
-    <p:sldId xmlns:r="http://schemas.openxmlformats.org/officeDocument/2006/relationships" id="256" r:id="R9cdbae44b19b4525"/>
-    <p:sldId xmlns:r="http://schemas.openxmlformats.org/officeDocument/2006/relationships" id="257" r:id="R76d1fb241c644356"/>
-    <p:sldId xmlns:r="http://schemas.openxmlformats.org/officeDocument/2006/relationships" id="258" r:id="Rfcefa56cb3ab40f2"/>
-    <p:sldId xmlns:r="http://schemas.openxmlformats.org/officeDocument/2006/relationships" id="259" r:id="Rbd5f05a04d8d48d6"/>
-    <p:sldId xmlns:r="http://schemas.openxmlformats.org/officeDocument/2006/relationships" id="260" r:id="R80e49bfccffa462e"/>
-    <p:sldId xmlns:r="http://schemas.openxmlformats.org/officeDocument/2006/relationships" id="261" r:id="R117f843f2da24639"/>
-    <p:sldId xmlns:r="http://schemas.openxmlformats.org/officeDocument/2006/relationships" id="262" r:id="R6e21e9e45b32432f"/>
-    <p:sldId xmlns:r="http://schemas.openxmlformats.org/officeDocument/2006/relationships" id="263" r:id="R5757ae864a1745fb"/>
-    <p:sldId xmlns:r="http://schemas.openxmlformats.org/officeDocument/2006/relationships" id="264" r:id="R3e89ff359f614de0"/>
-    <p:sldId xmlns:r="http://schemas.openxmlformats.org/officeDocument/2006/relationships" id="265" r:id="Re1ed38ce6ef84b4b"/>
+    <p:sldId xmlns:r="http://schemas.openxmlformats.org/officeDocument/2006/relationships" id="256" r:id="R599e0dd3894f4f37"/>
+    <p:sldId xmlns:r="http://schemas.openxmlformats.org/officeDocument/2006/relationships" id="257" r:id="R7203345ec06f410c"/>
+    <p:sldId xmlns:r="http://schemas.openxmlformats.org/officeDocument/2006/relationships" id="258" r:id="R037bb063dc234d8b"/>
+    <p:sldId xmlns:r="http://schemas.openxmlformats.org/officeDocument/2006/relationships" id="259" r:id="R215a9184593740b0"/>
+    <p:sldId xmlns:r="http://schemas.openxmlformats.org/officeDocument/2006/relationships" id="260" r:id="Rdfe5fd761c4d4fa1"/>
+    <p:sldId xmlns:r="http://schemas.openxmlformats.org/officeDocument/2006/relationships" id="261" r:id="R27224f16267c404b"/>
+    <p:sldId xmlns:r="http://schemas.openxmlformats.org/officeDocument/2006/relationships" id="262" r:id="R92b5fbdef10b4215"/>
+    <p:sldId xmlns:r="http://schemas.openxmlformats.org/officeDocument/2006/relationships" id="263" r:id="Rbcc7a505791d4fda"/>
+    <p:sldId xmlns:r="http://schemas.openxmlformats.org/officeDocument/2006/relationships" id="264" r:id="Rb253c47e278c44cf"/>
+    <p:sldId xmlns:r="http://schemas.openxmlformats.org/officeDocument/2006/relationships" id="265" r:id="Rea90da2126d24bfd"/>
   </p:sldIdLst>
   <p:sldSz cx="12192000" cy="6858000"/>
   <p:notesSz cx="6858000" cy="9144000"/>
@@ -1011,7 +1011,7 @@
           <a:lstStyle xmlns:a="http://schemas.openxmlformats.org/drawingml/2006/main"/>
           <a:p xmlns:a="http://schemas.openxmlformats.org/drawingml/2006/main">
             <a:r>
-              <a:t>Start Step 3. Each dot represents simulated observations from a different student. Students estimate the score for 3.5 hours per day and record it before checking the page. Axes are fixed at 0–24 hours and 0–100 marks. A trend does not prove that more study guarantees a score.</a:t>
+              <a:t>Start Step 3. Each dot represents simulated observations from a different student. Students first draw an intuitive straight line on the worksheet, then estimate the score for 3.5 hours per day and record it before checking the page. Axes are fixed at 0–24 hours and 0–100 marks. A trend does not prove that more study guarantees a score.</a:t>
             </a:r>
           </a:p>
         </p:txBody>
@@ -1149,7 +1149,7 @@
   </p:cSld>
   <p:clrMap bg1="lt1" tx1="dk1" bg2="lt2" tx2="dk2" accent1="accent1" accent2="accent2" accent3="accent3" accent4="accent4" accent5="accent5" accent6="accent6" hlink="hlink" folHlink="folHlink"/>
   <p:sldLayoutIdLst>
-    <p:sldLayoutId xmlns:r="http://schemas.openxmlformats.org/officeDocument/2006/relationships" id="2147483649" r:id="R9f7779e98b1a46ba"/>
+    <p:sldLayoutId xmlns:r="http://schemas.openxmlformats.org/officeDocument/2006/relationships" id="2147483649" r:id="R2f9807e8ffac4deb"/>
   </p:sldLayoutIdLst>
   <p:txStyles>
     <p:titleStyle>
@@ -3915,50 +3915,6 @@
             </c:numLit>
           </c:yVal>
         </c:ser>
-        <c:ser>
-          <c:idx val="1"/>
-          <c:order val="1"/>
-          <c:tx>
-            <c:v>模型 / Model</c:v>
-          </c:tx>
-          <c:spPr>
-            <a:solidFill xmlns:a="http://schemas.openxmlformats.org/drawingml/2006/main">
-              <a:srgbClr val="B65320"/>
-            </a:solidFill>
-            <a:ln xmlns:a="http://schemas.openxmlformats.org/drawingml/2006/main" w="28575">
-              <a:solidFill>
-                <a:srgbClr val="B65320"/>
-              </a:solidFill>
-            </a:ln>
-          </c:spPr>
-          <c:marker>
-            <c:symbol val="none"/>
-          </c:marker>
-          <c:xVal>
-            <c:numLit>
-              <c:formatCode>General</c:formatCode>
-              <c:ptCount val="2"/>
-              <c:pt idx="0">
-                <c:v>0</c:v>
-              </c:pt>
-              <c:pt idx="1">
-                <c:v>24</c:v>
-              </c:pt>
-            </c:numLit>
-          </c:xVal>
-          <c:yVal>
-            <c:numLit>
-              <c:formatCode>0</c:formatCode>
-              <c:ptCount val="2"/>
-              <c:pt idx="0">
-                <c:v>50</c:v>
-              </c:pt>
-              <c:pt idx="1">
-                <c:v>98</c:v>
-              </c:pt>
-            </c:numLit>
-          </c:yVal>
-        </c:ser>
         <c:dLbls>
           <c:txPr>
             <a:bodyPr xmlns:a="http://schemas.openxmlformats.org/drawingml/2006/main" anchorCtr="1"/>
@@ -4202,7 +4158,7 @@
           <p:cNvPr id="13" name="">
             <a:extLst xmlns:a="http://schemas.openxmlformats.org/drawingml/2006/main">
               <a:ext uri="{FF2B5EF4-FFF2-40B4-BE49-F238E27FC236}">
-                <a16:creationId xmlns:a16="http://schemas.microsoft.com/office/drawing/2014/main" id="{41E934F9-657C-4C1F-93DD-E73102B52DAC}"/>
+                <a16:creationId xmlns:a16="http://schemas.microsoft.com/office/drawing/2014/main" id="{5897EECA-374A-4A31-97DF-AF32DC266E8D}"/>
               </a:ext>
             </a:extLst>
           </p:cNvPr>
@@ -4259,7 +4215,7 @@
           <p:cNvPr id="2" name="">
             <a:extLst xmlns:a="http://schemas.openxmlformats.org/drawingml/2006/main">
               <a:ext uri="{FF2B5EF4-FFF2-40B4-BE49-F238E27FC236}">
-                <a16:creationId xmlns:a16="http://schemas.microsoft.com/office/drawing/2014/main" id="{2DBDC221-675F-4247-A29E-907F4A2564ED}"/>
+                <a16:creationId xmlns:a16="http://schemas.microsoft.com/office/drawing/2014/main" id="{06CDE012-56F7-4434-8E15-4E32392C9FE3}"/>
               </a:ext>
             </a:extLst>
           </p:cNvPr>
@@ -4316,7 +4272,7 @@
           <p:cNvPr id="3" name="">
             <a:extLst xmlns:a="http://schemas.openxmlformats.org/drawingml/2006/main">
               <a:ext uri="{FF2B5EF4-FFF2-40B4-BE49-F238E27FC236}">
-                <a16:creationId xmlns:a16="http://schemas.microsoft.com/office/drawing/2014/main" id="{03F8928A-2D14-4F7D-A877-175CC14103B3}"/>
+                <a16:creationId xmlns:a16="http://schemas.microsoft.com/office/drawing/2014/main" id="{C21323CE-8927-4D86-91C9-4764C7BC7608}"/>
               </a:ext>
             </a:extLst>
           </p:cNvPr>
@@ -4373,7 +4329,7 @@
           <p:cNvPr id="4" name="">
             <a:extLst xmlns:a="http://schemas.openxmlformats.org/drawingml/2006/main">
               <a:ext uri="{FF2B5EF4-FFF2-40B4-BE49-F238E27FC236}">
-                <a16:creationId xmlns:a16="http://schemas.microsoft.com/office/drawing/2014/main" id="{72E7F11E-A19B-46AA-AF73-6DBC9CE95131}"/>
+                <a16:creationId xmlns:a16="http://schemas.microsoft.com/office/drawing/2014/main" id="{518065A3-512F-4F87-9BEF-FB50E7D5D714}"/>
               </a:ext>
             </a:extLst>
           </p:cNvPr>
@@ -4430,7 +4386,7 @@
           <p:cNvPr id="5" name="">
             <a:extLst xmlns:a="http://schemas.openxmlformats.org/drawingml/2006/main">
               <a:ext uri="{FF2B5EF4-FFF2-40B4-BE49-F238E27FC236}">
-                <a16:creationId xmlns:a16="http://schemas.microsoft.com/office/drawing/2014/main" id="{BD58C7D1-3981-45BD-BB70-8BB9DEC49A7C}"/>
+                <a16:creationId xmlns:a16="http://schemas.microsoft.com/office/drawing/2014/main" id="{760AF1C8-CCC0-4F68-A13A-0D87F42B82A8}"/>
               </a:ext>
             </a:extLst>
           </p:cNvPr>
@@ -4487,7 +4443,7 @@
           <p:cNvPr id="6" name="">
             <a:extLst xmlns:a="http://schemas.openxmlformats.org/drawingml/2006/main">
               <a:ext uri="{FF2B5EF4-FFF2-40B4-BE49-F238E27FC236}">
-                <a16:creationId xmlns:a16="http://schemas.microsoft.com/office/drawing/2014/main" id="{4A595CF4-8016-4F4C-8F3F-905E30A2D60D}"/>
+                <a16:creationId xmlns:a16="http://schemas.microsoft.com/office/drawing/2014/main" id="{CBE5DE0A-14CF-4FFA-AA41-10FD3131BEC4}"/>
               </a:ext>
             </a:extLst>
           </p:cNvPr>
@@ -4544,7 +4500,7 @@
           <p:cNvPr id="7" name="">
             <a:extLst xmlns:a="http://schemas.openxmlformats.org/drawingml/2006/main">
               <a:ext uri="{FF2B5EF4-FFF2-40B4-BE49-F238E27FC236}">
-                <a16:creationId xmlns:a16="http://schemas.microsoft.com/office/drawing/2014/main" id="{CE08725A-85D3-4C9C-AAF6-9C00D5C314E6}"/>
+                <a16:creationId xmlns:a16="http://schemas.microsoft.com/office/drawing/2014/main" id="{AFE7DF78-4739-4D51-B4AE-B1C94D25A009}"/>
               </a:ext>
             </a:extLst>
           </p:cNvPr>
@@ -4601,7 +4557,7 @@
           <p:cNvPr id="8" name="">
             <a:extLst xmlns:a="http://schemas.openxmlformats.org/drawingml/2006/main">
               <a:ext uri="{FF2B5EF4-FFF2-40B4-BE49-F238E27FC236}">
-                <a16:creationId xmlns:a16="http://schemas.microsoft.com/office/drawing/2014/main" id="{DE216E70-A202-4D24-8BDD-32CC2FF51969}"/>
+                <a16:creationId xmlns:a16="http://schemas.microsoft.com/office/drawing/2014/main" id="{7B617BEF-41DA-4182-BB61-56C0770B6029}"/>
               </a:ext>
             </a:extLst>
           </p:cNvPr>
@@ -4658,7 +4614,7 @@
           <p:cNvPr id="9" name="">
             <a:extLst xmlns:a="http://schemas.openxmlformats.org/drawingml/2006/main">
               <a:ext uri="{FF2B5EF4-FFF2-40B4-BE49-F238E27FC236}">
-                <a16:creationId xmlns:a16="http://schemas.microsoft.com/office/drawing/2014/main" id="{C214F267-D08A-4C22-BB27-68F616F86BC6}"/>
+                <a16:creationId xmlns:a16="http://schemas.microsoft.com/office/drawing/2014/main" id="{F16C0329-8039-4434-AA27-DBBA3BEC7C43}"/>
               </a:ext>
             </a:extLst>
           </p:cNvPr>
@@ -4715,7 +4671,7 @@
           <p:cNvPr id="10" name="">
             <a:extLst xmlns:a="http://schemas.openxmlformats.org/drawingml/2006/main">
               <a:ext uri="{FF2B5EF4-FFF2-40B4-BE49-F238E27FC236}">
-                <a16:creationId xmlns:a16="http://schemas.microsoft.com/office/drawing/2014/main" id="{51D05EC2-4127-4797-9288-C6D86DA3B328}"/>
+                <a16:creationId xmlns:a16="http://schemas.microsoft.com/office/drawing/2014/main" id="{FBDC2F93-ECDB-419C-B1F6-99ADF33B6E51}"/>
               </a:ext>
             </a:extLst>
           </p:cNvPr>
@@ -4772,7 +4728,7 @@
           <p:cNvPr id="11" name="">
             <a:extLst xmlns:a="http://schemas.openxmlformats.org/drawingml/2006/main">
               <a:ext uri="{FF2B5EF4-FFF2-40B4-BE49-F238E27FC236}">
-                <a16:creationId xmlns:a16="http://schemas.microsoft.com/office/drawing/2014/main" id="{D572F2DB-D615-41ED-98F2-4F089592E008}"/>
+                <a16:creationId xmlns:a16="http://schemas.microsoft.com/office/drawing/2014/main" id="{C1DD1E23-A2F6-48BE-94BF-C841C23FA752}"/>
               </a:ext>
             </a:extLst>
           </p:cNvPr>
@@ -4829,7 +4785,7 @@
           <p:cNvPr id="12" name="">
             <a:extLst xmlns:a="http://schemas.openxmlformats.org/drawingml/2006/main">
               <a:ext uri="{FF2B5EF4-FFF2-40B4-BE49-F238E27FC236}">
-                <a16:creationId xmlns:a16="http://schemas.microsoft.com/office/drawing/2014/main" id="{96C5B384-6176-4EFF-B01B-1313AA613492}"/>
+                <a16:creationId xmlns:a16="http://schemas.microsoft.com/office/drawing/2014/main" id="{3FBAC7DF-4AF5-4CED-A840-3BC99036F2D0}"/>
               </a:ext>
             </a:extLst>
           </p:cNvPr>
@@ -4884,7 +4840,7 @@
     </p:spTree>
     <p:extLst>
       <p:ext uri="{BB962C8B-B14F-4D97-AF65-F5344CB8AC3E}">
-        <p14:creationId xmlns:p14="http://schemas.microsoft.com/office/powerpoint/2010/main" val="550628515"/>
+        <p14:creationId xmlns:p14="http://schemas.microsoft.com/office/powerpoint/2010/main" val="1269116003"/>
       </p:ext>
     </p:extLst>
   </p:cSld>
@@ -4915,7 +4871,7 @@
           <p:cNvPr id="11" name="">
             <a:extLst xmlns:a="http://schemas.openxmlformats.org/drawingml/2006/main">
               <a:ext uri="{FF2B5EF4-FFF2-40B4-BE49-F238E27FC236}">
-                <a16:creationId xmlns:a16="http://schemas.microsoft.com/office/drawing/2014/main" id="{7CFF15A6-6782-4C06-AD37-B92DAEEFFAD0}"/>
+                <a16:creationId xmlns:a16="http://schemas.microsoft.com/office/drawing/2014/main" id="{A2996034-6E87-4A92-980D-D429D9BE7741}"/>
               </a:ext>
             </a:extLst>
           </p:cNvPr>
@@ -4972,7 +4928,7 @@
           <p:cNvPr id="2" name="">
             <a:extLst xmlns:a="http://schemas.openxmlformats.org/drawingml/2006/main">
               <a:ext uri="{FF2B5EF4-FFF2-40B4-BE49-F238E27FC236}">
-                <a16:creationId xmlns:a16="http://schemas.microsoft.com/office/drawing/2014/main" id="{CC2705E1-0F61-423B-B6D4-F2FC1C01FDEE}"/>
+                <a16:creationId xmlns:a16="http://schemas.microsoft.com/office/drawing/2014/main" id="{E7E86C5B-48A0-4C63-857B-8C6016F741F5}"/>
               </a:ext>
             </a:extLst>
           </p:cNvPr>
@@ -5029,7 +4985,7 @@
           <p:cNvPr id="3" name="">
             <a:extLst xmlns:a="http://schemas.openxmlformats.org/drawingml/2006/main">
               <a:ext uri="{FF2B5EF4-FFF2-40B4-BE49-F238E27FC236}">
-                <a16:creationId xmlns:a16="http://schemas.microsoft.com/office/drawing/2014/main" id="{F31B8BD1-F98A-4FDC-94E5-2817122A2BA1}"/>
+                <a16:creationId xmlns:a16="http://schemas.microsoft.com/office/drawing/2014/main" id="{61FFC652-1DD2-4426-B9A9-8722389E8576}"/>
               </a:ext>
             </a:extLst>
           </p:cNvPr>
@@ -5086,7 +5042,7 @@
           <p:cNvPr id="4" name="">
             <a:extLst xmlns:a="http://schemas.openxmlformats.org/drawingml/2006/main">
               <a:ext uri="{FF2B5EF4-FFF2-40B4-BE49-F238E27FC236}">
-                <a16:creationId xmlns:a16="http://schemas.microsoft.com/office/drawing/2014/main" id="{5595922B-0BB6-4E93-B204-CACC835061CF}"/>
+                <a16:creationId xmlns:a16="http://schemas.microsoft.com/office/drawing/2014/main" id="{3D404ADD-F5B9-4E4C-8C1F-E4B019DD2B1C}"/>
               </a:ext>
             </a:extLst>
           </p:cNvPr>
@@ -5143,7 +5099,7 @@
           <p:cNvPr id="5" name="">
             <a:extLst xmlns:a="http://schemas.openxmlformats.org/drawingml/2006/main">
               <a:ext uri="{FF2B5EF4-FFF2-40B4-BE49-F238E27FC236}">
-                <a16:creationId xmlns:a16="http://schemas.microsoft.com/office/drawing/2014/main" id="{323FEAF1-D787-4ADA-8148-DDBA65DCD0D5}"/>
+                <a16:creationId xmlns:a16="http://schemas.microsoft.com/office/drawing/2014/main" id="{8A8690FC-1806-4FB4-9154-CADC0AC16765}"/>
               </a:ext>
             </a:extLst>
           </p:cNvPr>
@@ -5200,7 +5156,7 @@
           <p:cNvPr id="6" name="">
             <a:extLst xmlns:a="http://schemas.openxmlformats.org/drawingml/2006/main">
               <a:ext uri="{FF2B5EF4-FFF2-40B4-BE49-F238E27FC236}">
-                <a16:creationId xmlns:a16="http://schemas.microsoft.com/office/drawing/2014/main" id="{6B0A6FF9-D8F3-40E2-8444-6C5F454E3190}"/>
+                <a16:creationId xmlns:a16="http://schemas.microsoft.com/office/drawing/2014/main" id="{CD6A190E-3374-4EC6-895F-5EA0FC2773B3}"/>
               </a:ext>
             </a:extLst>
           </p:cNvPr>
@@ -5247,7 +5203,7 @@
                 <a:ea typeface="Heiti TC"/>
                 <a:cs typeface="Heiti TC"/>
               </a:rPr>
-              <a:t>加入新點後，m 和 c 有甚麼改變？</a:t>
+              <a:t>你畫的直線與網頁的直線有甚麼分別？</a:t>
             </a:r>
           </a:p>
         </p:txBody>
@@ -5257,7 +5213,7 @@
           <p:cNvPr id="7" name="">
             <a:extLst xmlns:a="http://schemas.openxmlformats.org/drawingml/2006/main">
               <a:ext uri="{FF2B5EF4-FFF2-40B4-BE49-F238E27FC236}">
-                <a16:creationId xmlns:a16="http://schemas.microsoft.com/office/drawing/2014/main" id="{7339E20A-67B1-47EA-9BC3-DFF7B2169108}"/>
+                <a16:creationId xmlns:a16="http://schemas.microsoft.com/office/drawing/2014/main" id="{EEDB9BF3-8760-4993-804A-2A115DB43883}"/>
               </a:ext>
             </a:extLst>
           </p:cNvPr>
@@ -5304,7 +5260,7 @@
                 <a:ea typeface="Arial"/>
                 <a:cs typeface="Arial"/>
               </a:rPr>
-              <a:t>How did m and c change after you added a point?</a:t>
+              <a:t>How does your own line compare with the line on the page?</a:t>
             </a:r>
           </a:p>
         </p:txBody>
@@ -5314,7 +5270,7 @@
           <p:cNvPr id="8" name="">
             <a:extLst xmlns:a="http://schemas.openxmlformats.org/drawingml/2006/main">
               <a:ext uri="{FF2B5EF4-FFF2-40B4-BE49-F238E27FC236}">
-                <a16:creationId xmlns:a16="http://schemas.microsoft.com/office/drawing/2014/main" id="{63D7F877-13A1-4609-A33A-603100BBD0CA}"/>
+                <a16:creationId xmlns:a16="http://schemas.microsoft.com/office/drawing/2014/main" id="{0864FC08-762C-4452-BB39-1E9AEF436EB7}"/>
               </a:ext>
             </a:extLst>
           </p:cNvPr>
@@ -5371,7 +5327,7 @@
           <p:cNvPr id="9" name="">
             <a:extLst xmlns:a="http://schemas.openxmlformats.org/drawingml/2006/main">
               <a:ext uri="{FF2B5EF4-FFF2-40B4-BE49-F238E27FC236}">
-                <a16:creationId xmlns:a16="http://schemas.microsoft.com/office/drawing/2014/main" id="{0C6201D8-79AC-4D35-A30D-4F152DE3C7A7}"/>
+                <a16:creationId xmlns:a16="http://schemas.microsoft.com/office/drawing/2014/main" id="{22B05EFB-B38B-4851-97C4-264A4914485A}"/>
               </a:ext>
             </a:extLst>
           </p:cNvPr>
@@ -5428,7 +5384,7 @@
           <p:cNvPr id="10" name="">
             <a:extLst xmlns:a="http://schemas.openxmlformats.org/drawingml/2006/main">
               <a:ext uri="{FF2B5EF4-FFF2-40B4-BE49-F238E27FC236}">
-                <a16:creationId xmlns:a16="http://schemas.microsoft.com/office/drawing/2014/main" id="{2639638D-016D-4E89-B887-0791CE4181B6}"/>
+                <a16:creationId xmlns:a16="http://schemas.microsoft.com/office/drawing/2014/main" id="{D3558A86-051B-4B28-B8FA-9C5F58C1CE10}"/>
               </a:ext>
             </a:extLst>
           </p:cNvPr>
@@ -5483,7 +5439,7 @@
     </p:spTree>
     <p:extLst>
       <p:ext uri="{BB962C8B-B14F-4D97-AF65-F5344CB8AC3E}">
-        <p14:creationId xmlns:p14="http://schemas.microsoft.com/office/powerpoint/2010/main" val="1553370169"/>
+        <p14:creationId xmlns:p14="http://schemas.microsoft.com/office/powerpoint/2010/main" val="1376900396"/>
       </p:ext>
     </p:extLst>
   </p:cSld>
@@ -5514,7 +5470,7 @@
           <p:cNvPr id="12" name="">
             <a:extLst xmlns:a="http://schemas.openxmlformats.org/drawingml/2006/main">
               <a:ext uri="{FF2B5EF4-FFF2-40B4-BE49-F238E27FC236}">
-                <a16:creationId xmlns:a16="http://schemas.microsoft.com/office/drawing/2014/main" id="{9A62C264-96BF-444F-892F-97CFBC4054F3}"/>
+                <a16:creationId xmlns:a16="http://schemas.microsoft.com/office/drawing/2014/main" id="{A17A74F3-8C44-419A-B833-B8BEF9101349}"/>
               </a:ext>
             </a:extLst>
           </p:cNvPr>
@@ -5571,7 +5527,7 @@
           <p:cNvPr id="2" name="">
             <a:extLst xmlns:a="http://schemas.openxmlformats.org/drawingml/2006/main">
               <a:ext uri="{FF2B5EF4-FFF2-40B4-BE49-F238E27FC236}">
-                <a16:creationId xmlns:a16="http://schemas.microsoft.com/office/drawing/2014/main" id="{114987BC-631C-4815-AEFD-86BB5D83E84F}"/>
+                <a16:creationId xmlns:a16="http://schemas.microsoft.com/office/drawing/2014/main" id="{C46085C3-9D0D-40DE-ACF0-3F9D713BD4C7}"/>
               </a:ext>
             </a:extLst>
           </p:cNvPr>
@@ -5628,7 +5584,7 @@
           <p:cNvPr id="3" name="">
             <a:extLst xmlns:a="http://schemas.openxmlformats.org/drawingml/2006/main">
               <a:ext uri="{FF2B5EF4-FFF2-40B4-BE49-F238E27FC236}">
-                <a16:creationId xmlns:a16="http://schemas.microsoft.com/office/drawing/2014/main" id="{FC580F22-9058-41CE-8CB4-1F36B0D8815F}"/>
+                <a16:creationId xmlns:a16="http://schemas.microsoft.com/office/drawing/2014/main" id="{E9FFF018-8215-45BD-A19B-1C20A94BC78C}"/>
               </a:ext>
             </a:extLst>
           </p:cNvPr>
@@ -5685,7 +5641,7 @@
           <p:cNvPr id="4" name="">
             <a:extLst xmlns:a="http://schemas.openxmlformats.org/drawingml/2006/main">
               <a:ext uri="{FF2B5EF4-FFF2-40B4-BE49-F238E27FC236}">
-                <a16:creationId xmlns:a16="http://schemas.microsoft.com/office/drawing/2014/main" id="{5C0232D3-146B-466E-B3DC-790604095414}"/>
+                <a16:creationId xmlns:a16="http://schemas.microsoft.com/office/drawing/2014/main" id="{EAF490FD-8705-429C-97B7-400D92F26008}"/>
               </a:ext>
             </a:extLst>
           </p:cNvPr>
@@ -5742,7 +5698,7 @@
           <p:cNvPr id="5" name="">
             <a:extLst xmlns:a="http://schemas.openxmlformats.org/drawingml/2006/main">
               <a:ext uri="{FF2B5EF4-FFF2-40B4-BE49-F238E27FC236}">
-                <a16:creationId xmlns:a16="http://schemas.microsoft.com/office/drawing/2014/main" id="{F0A6CF7C-B636-4C0A-9D7F-A19A1E0BFFC7}"/>
+                <a16:creationId xmlns:a16="http://schemas.microsoft.com/office/drawing/2014/main" id="{898B3100-EDE1-4804-9E96-D905D48D8B9F}"/>
               </a:ext>
             </a:extLst>
           </p:cNvPr>
@@ -5799,7 +5755,7 @@
           <p:cNvPr id="6" name="">
             <a:extLst xmlns:a="http://schemas.openxmlformats.org/drawingml/2006/main">
               <a:ext uri="{FF2B5EF4-FFF2-40B4-BE49-F238E27FC236}">
-                <a16:creationId xmlns:a16="http://schemas.microsoft.com/office/drawing/2014/main" id="{E1DA19AE-1366-43F8-9D7A-0EACF26CA115}"/>
+                <a16:creationId xmlns:a16="http://schemas.microsoft.com/office/drawing/2014/main" id="{6DF407AB-CF66-4656-B07C-D787F33E22B9}"/>
               </a:ext>
             </a:extLst>
           </p:cNvPr>
@@ -5856,7 +5812,7 @@
           <p:cNvPr id="7" name="">
             <a:extLst xmlns:a="http://schemas.openxmlformats.org/drawingml/2006/main">
               <a:ext uri="{FF2B5EF4-FFF2-40B4-BE49-F238E27FC236}">
-                <a16:creationId xmlns:a16="http://schemas.microsoft.com/office/drawing/2014/main" id="{BC5B56E1-BF26-49AC-97DB-CAD4EAF0E79C}"/>
+                <a16:creationId xmlns:a16="http://schemas.microsoft.com/office/drawing/2014/main" id="{299F87C8-E620-4313-9A19-9C3B37562809}"/>
               </a:ext>
             </a:extLst>
           </p:cNvPr>
@@ -5913,7 +5869,7 @@
           <p:cNvPr id="8" name="">
             <a:extLst xmlns:a="http://schemas.openxmlformats.org/drawingml/2006/main">
               <a:ext uri="{FF2B5EF4-FFF2-40B4-BE49-F238E27FC236}">
-                <a16:creationId xmlns:a16="http://schemas.microsoft.com/office/drawing/2014/main" id="{FF40B637-2B4B-4DB7-B72F-323BBED02F2B}"/>
+                <a16:creationId xmlns:a16="http://schemas.microsoft.com/office/drawing/2014/main" id="{25A0AA19-0E47-4968-9656-0D23ADB8885A}"/>
               </a:ext>
             </a:extLst>
           </p:cNvPr>
@@ -5970,7 +5926,7 @@
           <p:cNvPr id="9" name="">
             <a:extLst xmlns:a="http://schemas.openxmlformats.org/drawingml/2006/main">
               <a:ext uri="{FF2B5EF4-FFF2-40B4-BE49-F238E27FC236}">
-                <a16:creationId xmlns:a16="http://schemas.microsoft.com/office/drawing/2014/main" id="{6918C0E1-9F7B-4959-ABE6-13DFFEAFB704}"/>
+                <a16:creationId xmlns:a16="http://schemas.microsoft.com/office/drawing/2014/main" id="{99C40FA6-432B-406D-BDD5-DFFB74E64694}"/>
               </a:ext>
             </a:extLst>
           </p:cNvPr>
@@ -6027,7 +5983,7 @@
           <p:cNvPr id="10" name="">
             <a:extLst xmlns:a="http://schemas.openxmlformats.org/drawingml/2006/main">
               <a:ext uri="{FF2B5EF4-FFF2-40B4-BE49-F238E27FC236}">
-                <a16:creationId xmlns:a16="http://schemas.microsoft.com/office/drawing/2014/main" id="{85E30C8B-9143-4470-8ACD-CED0DD60BACB}"/>
+                <a16:creationId xmlns:a16="http://schemas.microsoft.com/office/drawing/2014/main" id="{CC941FDD-62A6-44DB-BBDA-A6080A4105B5}"/>
               </a:ext>
             </a:extLst>
           </p:cNvPr>
@@ -6091,14 +6047,14 @@
         </p:xfrm>
         <a:graphic xmlns:a="http://schemas.openxmlformats.org/drawingml/2006/main">
           <a:graphicData uri="http://schemas.openxmlformats.org/drawingml/2006/chart">
-            <c:chart xmlns:r="http://schemas.openxmlformats.org/officeDocument/2006/relationships" xmlns:c="http://schemas.openxmlformats.org/drawingml/2006/chart" r:id="R37ceb5f49c104b76"/>
+            <c:chart xmlns:r="http://schemas.openxmlformats.org/officeDocument/2006/relationships" xmlns:c="http://schemas.openxmlformats.org/drawingml/2006/chart" r:id="R437b7772241a48de"/>
           </a:graphicData>
         </a:graphic>
       </p:graphicFrame>
     </p:spTree>
     <p:extLst>
       <p:ext uri="{BB962C8B-B14F-4D97-AF65-F5344CB8AC3E}">
-        <p14:creationId xmlns:p14="http://schemas.microsoft.com/office/powerpoint/2010/main" val="1338848109"/>
+        <p14:creationId xmlns:p14="http://schemas.microsoft.com/office/powerpoint/2010/main" val="2061989515"/>
       </p:ext>
     </p:extLst>
   </p:cSld>
@@ -6129,7 +6085,7 @@
           <p:cNvPr id="12" name="">
             <a:extLst xmlns:a="http://schemas.openxmlformats.org/drawingml/2006/main">
               <a:ext uri="{FF2B5EF4-FFF2-40B4-BE49-F238E27FC236}">
-                <a16:creationId xmlns:a16="http://schemas.microsoft.com/office/drawing/2014/main" id="{F3A8DEED-BD12-4C9A-8745-F7B640625638}"/>
+                <a16:creationId xmlns:a16="http://schemas.microsoft.com/office/drawing/2014/main" id="{79B901D0-453F-46CB-9B15-DCA6100DCEF9}"/>
               </a:ext>
             </a:extLst>
           </p:cNvPr>
@@ -6186,7 +6142,7 @@
           <p:cNvPr id="2" name="">
             <a:extLst xmlns:a="http://schemas.openxmlformats.org/drawingml/2006/main">
               <a:ext uri="{FF2B5EF4-FFF2-40B4-BE49-F238E27FC236}">
-                <a16:creationId xmlns:a16="http://schemas.microsoft.com/office/drawing/2014/main" id="{C025F403-E545-4914-BA45-A2A4A08FB5BC}"/>
+                <a16:creationId xmlns:a16="http://schemas.microsoft.com/office/drawing/2014/main" id="{DFBB052E-26FB-4C39-9C62-0C6EA74AA046}"/>
               </a:ext>
             </a:extLst>
           </p:cNvPr>
@@ -6243,7 +6199,7 @@
           <p:cNvPr id="3" name="">
             <a:extLst xmlns:a="http://schemas.openxmlformats.org/drawingml/2006/main">
               <a:ext uri="{FF2B5EF4-FFF2-40B4-BE49-F238E27FC236}">
-                <a16:creationId xmlns:a16="http://schemas.microsoft.com/office/drawing/2014/main" id="{77D1DC8C-80C6-4639-A913-E792D04FF421}"/>
+                <a16:creationId xmlns:a16="http://schemas.microsoft.com/office/drawing/2014/main" id="{E1E5148F-40B9-46A4-9C57-953EE7F7D57C}"/>
               </a:ext>
             </a:extLst>
           </p:cNvPr>
@@ -6300,7 +6256,7 @@
           <p:cNvPr id="4" name="">
             <a:extLst xmlns:a="http://schemas.openxmlformats.org/drawingml/2006/main">
               <a:ext uri="{FF2B5EF4-FFF2-40B4-BE49-F238E27FC236}">
-                <a16:creationId xmlns:a16="http://schemas.microsoft.com/office/drawing/2014/main" id="{A2358405-3FBA-4F6B-BC89-4D3368CB1C94}"/>
+                <a16:creationId xmlns:a16="http://schemas.microsoft.com/office/drawing/2014/main" id="{ED03F71F-EA84-4EC6-B679-57B5E31888C8}"/>
               </a:ext>
             </a:extLst>
           </p:cNvPr>
@@ -6357,7 +6313,7 @@
           <p:cNvPr id="5" name="">
             <a:extLst xmlns:a="http://schemas.openxmlformats.org/drawingml/2006/main">
               <a:ext uri="{FF2B5EF4-FFF2-40B4-BE49-F238E27FC236}">
-                <a16:creationId xmlns:a16="http://schemas.microsoft.com/office/drawing/2014/main" id="{62CD501F-A748-4B34-9A8E-E34BE76B98CD}"/>
+                <a16:creationId xmlns:a16="http://schemas.microsoft.com/office/drawing/2014/main" id="{B36ECCA4-1B06-40E2-9D3D-564DC794497A}"/>
               </a:ext>
             </a:extLst>
           </p:cNvPr>
@@ -6414,7 +6370,7 @@
           <p:cNvPr id="6" name="">
             <a:extLst xmlns:a="http://schemas.openxmlformats.org/drawingml/2006/main">
               <a:ext uri="{FF2B5EF4-FFF2-40B4-BE49-F238E27FC236}">
-                <a16:creationId xmlns:a16="http://schemas.microsoft.com/office/drawing/2014/main" id="{039BD591-5AF6-41CC-8BA8-63EBA0FFD545}"/>
+                <a16:creationId xmlns:a16="http://schemas.microsoft.com/office/drawing/2014/main" id="{CEA38183-64BA-4FD2-A22B-F26D39F483BA}"/>
               </a:ext>
             </a:extLst>
           </p:cNvPr>
@@ -6471,7 +6427,7 @@
           <p:cNvPr id="7" name="">
             <a:extLst xmlns:a="http://schemas.openxmlformats.org/drawingml/2006/main">
               <a:ext uri="{FF2B5EF4-FFF2-40B4-BE49-F238E27FC236}">
-                <a16:creationId xmlns:a16="http://schemas.microsoft.com/office/drawing/2014/main" id="{2A721B98-7ECB-4503-AD38-6AC2E89BC33D}"/>
+                <a16:creationId xmlns:a16="http://schemas.microsoft.com/office/drawing/2014/main" id="{9246E134-75B8-4215-9C33-89111C0E685E}"/>
               </a:ext>
             </a:extLst>
           </p:cNvPr>
@@ -6528,7 +6484,7 @@
           <p:cNvPr id="8" name="">
             <a:extLst xmlns:a="http://schemas.openxmlformats.org/drawingml/2006/main">
               <a:ext uri="{FF2B5EF4-FFF2-40B4-BE49-F238E27FC236}">
-                <a16:creationId xmlns:a16="http://schemas.microsoft.com/office/drawing/2014/main" id="{65BAEF5F-CC52-4C98-9B50-F7658228EFF5}"/>
+                <a16:creationId xmlns:a16="http://schemas.microsoft.com/office/drawing/2014/main" id="{E13069B7-CB06-4EB7-B3FC-2A395E6B5ED5}"/>
               </a:ext>
             </a:extLst>
           </p:cNvPr>
@@ -6585,7 +6541,7 @@
           <p:cNvPr id="9" name="">
             <a:extLst xmlns:a="http://schemas.openxmlformats.org/drawingml/2006/main">
               <a:ext uri="{FF2B5EF4-FFF2-40B4-BE49-F238E27FC236}">
-                <a16:creationId xmlns:a16="http://schemas.microsoft.com/office/drawing/2014/main" id="{07CFE872-A7E2-4836-851F-86448F32B4FF}"/>
+                <a16:creationId xmlns:a16="http://schemas.microsoft.com/office/drawing/2014/main" id="{83933070-E104-49E7-A1B4-5276BAC2B2BE}"/>
               </a:ext>
             </a:extLst>
           </p:cNvPr>
@@ -6642,7 +6598,7 @@
           <p:cNvPr id="10" name="">
             <a:extLst xmlns:a="http://schemas.openxmlformats.org/drawingml/2006/main">
               <a:ext uri="{FF2B5EF4-FFF2-40B4-BE49-F238E27FC236}">
-                <a16:creationId xmlns:a16="http://schemas.microsoft.com/office/drawing/2014/main" id="{40471AAE-E2FC-4854-8585-AAD4C2E5E2E1}"/>
+                <a16:creationId xmlns:a16="http://schemas.microsoft.com/office/drawing/2014/main" id="{4A1B3915-2040-4C81-BDB2-6EA919897D4E}"/>
               </a:ext>
             </a:extLst>
           </p:cNvPr>
@@ -6706,14 +6662,14 @@
         </p:xfrm>
         <a:graphic xmlns:a="http://schemas.openxmlformats.org/drawingml/2006/main">
           <a:graphicData uri="http://schemas.openxmlformats.org/drawingml/2006/chart">
-            <c:chart xmlns:r="http://schemas.openxmlformats.org/officeDocument/2006/relationships" xmlns:c="http://schemas.openxmlformats.org/drawingml/2006/chart" r:id="R1a69f635333746d9"/>
+            <c:chart xmlns:r="http://schemas.openxmlformats.org/officeDocument/2006/relationships" xmlns:c="http://schemas.openxmlformats.org/drawingml/2006/chart" r:id="R134249e8bd05490e"/>
           </a:graphicData>
         </a:graphic>
       </p:graphicFrame>
     </p:spTree>
     <p:extLst>
       <p:ext uri="{BB962C8B-B14F-4D97-AF65-F5344CB8AC3E}">
-        <p14:creationId xmlns:p14="http://schemas.microsoft.com/office/powerpoint/2010/main" val="1309713473"/>
+        <p14:creationId xmlns:p14="http://schemas.microsoft.com/office/powerpoint/2010/main" val="1305999608"/>
       </p:ext>
     </p:extLst>
   </p:cSld>
@@ -6744,7 +6700,7 @@
           <p:cNvPr id="16" name="">
             <a:extLst xmlns:a="http://schemas.openxmlformats.org/drawingml/2006/main">
               <a:ext uri="{FF2B5EF4-FFF2-40B4-BE49-F238E27FC236}">
-                <a16:creationId xmlns:a16="http://schemas.microsoft.com/office/drawing/2014/main" id="{8AA00A01-01BB-4829-A1AB-B18B33FB007B}"/>
+                <a16:creationId xmlns:a16="http://schemas.microsoft.com/office/drawing/2014/main" id="{2715EF15-8AF5-429A-BFC6-4B6E399CA98D}"/>
               </a:ext>
             </a:extLst>
           </p:cNvPr>
@@ -6801,7 +6757,7 @@
           <p:cNvPr id="2" name="">
             <a:extLst xmlns:a="http://schemas.openxmlformats.org/drawingml/2006/main">
               <a:ext uri="{FF2B5EF4-FFF2-40B4-BE49-F238E27FC236}">
-                <a16:creationId xmlns:a16="http://schemas.microsoft.com/office/drawing/2014/main" id="{DCC5465B-B220-4565-8EA4-D6709802153A}"/>
+                <a16:creationId xmlns:a16="http://schemas.microsoft.com/office/drawing/2014/main" id="{1BC9751C-C47E-4D50-A7A5-8A021C87E94B}"/>
               </a:ext>
             </a:extLst>
           </p:cNvPr>
@@ -6858,7 +6814,7 @@
           <p:cNvPr id="3" name="">
             <a:extLst xmlns:a="http://schemas.openxmlformats.org/drawingml/2006/main">
               <a:ext uri="{FF2B5EF4-FFF2-40B4-BE49-F238E27FC236}">
-                <a16:creationId xmlns:a16="http://schemas.microsoft.com/office/drawing/2014/main" id="{661E1955-CBE0-4F0A-BF75-110CAE92A6CC}"/>
+                <a16:creationId xmlns:a16="http://schemas.microsoft.com/office/drawing/2014/main" id="{86A0AB2F-8214-4403-B119-F0ADCDCDC726}"/>
               </a:ext>
             </a:extLst>
           </p:cNvPr>
@@ -6915,7 +6871,7 @@
           <p:cNvPr id="4" name="">
             <a:extLst xmlns:a="http://schemas.openxmlformats.org/drawingml/2006/main">
               <a:ext uri="{FF2B5EF4-FFF2-40B4-BE49-F238E27FC236}">
-                <a16:creationId xmlns:a16="http://schemas.microsoft.com/office/drawing/2014/main" id="{802CCF00-D97A-42A6-B763-009F83BCB6D5}"/>
+                <a16:creationId xmlns:a16="http://schemas.microsoft.com/office/drawing/2014/main" id="{0D8E42B8-93D5-4585-BAEA-3F5804FFFA89}"/>
               </a:ext>
             </a:extLst>
           </p:cNvPr>
@@ -6979,7 +6935,7 @@
         </p:xfrm>
         <a:graphic xmlns:a="http://schemas.openxmlformats.org/drawingml/2006/main">
           <a:graphicData uri="http://schemas.openxmlformats.org/drawingml/2006/chart">
-            <c:chart xmlns:r="http://schemas.openxmlformats.org/officeDocument/2006/relationships" xmlns:c="http://schemas.openxmlformats.org/drawingml/2006/chart" r:id="Rba1b6b0ada254076"/>
+            <c:chart xmlns:r="http://schemas.openxmlformats.org/officeDocument/2006/relationships" xmlns:c="http://schemas.openxmlformats.org/drawingml/2006/chart" r:id="R6472b465f9f6477e"/>
           </a:graphicData>
         </a:graphic>
       </p:graphicFrame>
@@ -6988,7 +6944,7 @@
           <p:cNvPr id="6" name="">
             <a:extLst xmlns:a="http://schemas.openxmlformats.org/drawingml/2006/main">
               <a:ext uri="{FF2B5EF4-FFF2-40B4-BE49-F238E27FC236}">
-                <a16:creationId xmlns:a16="http://schemas.microsoft.com/office/drawing/2014/main" id="{8B1A41CA-3497-40EB-BFE5-729A17CDF9D5}"/>
+                <a16:creationId xmlns:a16="http://schemas.microsoft.com/office/drawing/2014/main" id="{CBC414AD-BCEB-47E3-931A-9A16882594C3}"/>
               </a:ext>
             </a:extLst>
           </p:cNvPr>
@@ -7045,7 +7001,7 @@
           <p:cNvPr id="7" name="">
             <a:extLst xmlns:a="http://schemas.openxmlformats.org/drawingml/2006/main">
               <a:ext uri="{FF2B5EF4-FFF2-40B4-BE49-F238E27FC236}">
-                <a16:creationId xmlns:a16="http://schemas.microsoft.com/office/drawing/2014/main" id="{3BC524F4-1BE3-4EF0-904C-17DECEFFCFEF}"/>
+                <a16:creationId xmlns:a16="http://schemas.microsoft.com/office/drawing/2014/main" id="{489E4962-ED85-4F57-A46D-D2FDE1B49CBD}"/>
               </a:ext>
             </a:extLst>
           </p:cNvPr>
@@ -7102,7 +7058,7 @@
           <p:cNvPr id="8" name="">
             <a:extLst xmlns:a="http://schemas.openxmlformats.org/drawingml/2006/main">
               <a:ext uri="{FF2B5EF4-FFF2-40B4-BE49-F238E27FC236}">
-                <a16:creationId xmlns:a16="http://schemas.microsoft.com/office/drawing/2014/main" id="{64F535BE-4C01-4C9C-BEE9-A822DE1331AB}"/>
+                <a16:creationId xmlns:a16="http://schemas.microsoft.com/office/drawing/2014/main" id="{72D9EDEF-3A51-46C3-9047-911C03779591}"/>
               </a:ext>
             </a:extLst>
           </p:cNvPr>
@@ -7166,7 +7122,7 @@
         </p:xfrm>
         <a:graphic xmlns:a="http://schemas.openxmlformats.org/drawingml/2006/main">
           <a:graphicData uri="http://schemas.openxmlformats.org/drawingml/2006/chart">
-            <c:chart xmlns:r="http://schemas.openxmlformats.org/officeDocument/2006/relationships" xmlns:c="http://schemas.openxmlformats.org/drawingml/2006/chart" r:id="Rce54a3b770a94dfa"/>
+            <c:chart xmlns:r="http://schemas.openxmlformats.org/officeDocument/2006/relationships" xmlns:c="http://schemas.openxmlformats.org/drawingml/2006/chart" r:id="R7186cbb7785b4111"/>
           </a:graphicData>
         </a:graphic>
       </p:graphicFrame>
@@ -7175,7 +7131,7 @@
           <p:cNvPr id="10" name="">
             <a:extLst xmlns:a="http://schemas.openxmlformats.org/drawingml/2006/main">
               <a:ext uri="{FF2B5EF4-FFF2-40B4-BE49-F238E27FC236}">
-                <a16:creationId xmlns:a16="http://schemas.microsoft.com/office/drawing/2014/main" id="{CFC993D7-4513-4B2B-BAA5-78F21B0BCAF5}"/>
+                <a16:creationId xmlns:a16="http://schemas.microsoft.com/office/drawing/2014/main" id="{AC480601-5E95-4B25-94AA-F79AC7ACF7CE}"/>
               </a:ext>
             </a:extLst>
           </p:cNvPr>
@@ -7232,7 +7188,7 @@
           <p:cNvPr id="11" name="">
             <a:extLst xmlns:a="http://schemas.openxmlformats.org/drawingml/2006/main">
               <a:ext uri="{FF2B5EF4-FFF2-40B4-BE49-F238E27FC236}">
-                <a16:creationId xmlns:a16="http://schemas.microsoft.com/office/drawing/2014/main" id="{397478C6-FE63-434A-A36A-0694948005F7}"/>
+                <a16:creationId xmlns:a16="http://schemas.microsoft.com/office/drawing/2014/main" id="{0D2F9024-44A6-44DE-B045-EA1E9EF2699C}"/>
               </a:ext>
             </a:extLst>
           </p:cNvPr>
@@ -7289,7 +7245,7 @@
           <p:cNvPr id="12" name="">
             <a:extLst xmlns:a="http://schemas.openxmlformats.org/drawingml/2006/main">
               <a:ext uri="{FF2B5EF4-FFF2-40B4-BE49-F238E27FC236}">
-                <a16:creationId xmlns:a16="http://schemas.microsoft.com/office/drawing/2014/main" id="{4367C293-1732-43BA-B7FA-08893BEA8E7B}"/>
+                <a16:creationId xmlns:a16="http://schemas.microsoft.com/office/drawing/2014/main" id="{FB8C8DCE-7A0C-4D88-957B-1C1F46AF783B}"/>
               </a:ext>
             </a:extLst>
           </p:cNvPr>
@@ -7353,7 +7309,7 @@
         </p:xfrm>
         <a:graphic xmlns:a="http://schemas.openxmlformats.org/drawingml/2006/main">
           <a:graphicData uri="http://schemas.openxmlformats.org/drawingml/2006/chart">
-            <c:chart xmlns:r="http://schemas.openxmlformats.org/officeDocument/2006/relationships" xmlns:c="http://schemas.openxmlformats.org/drawingml/2006/chart" r:id="R3c1be84effc64bb8"/>
+            <c:chart xmlns:r="http://schemas.openxmlformats.org/officeDocument/2006/relationships" xmlns:c="http://schemas.openxmlformats.org/drawingml/2006/chart" r:id="R6590931fbe294bbf"/>
           </a:graphicData>
         </a:graphic>
       </p:graphicFrame>
@@ -7362,7 +7318,7 @@
           <p:cNvPr id="14" name="">
             <a:extLst xmlns:a="http://schemas.openxmlformats.org/drawingml/2006/main">
               <a:ext uri="{FF2B5EF4-FFF2-40B4-BE49-F238E27FC236}">
-                <a16:creationId xmlns:a16="http://schemas.microsoft.com/office/drawing/2014/main" id="{E0A0C67E-867C-4C40-B52B-F9B9B5A0F2AA}"/>
+                <a16:creationId xmlns:a16="http://schemas.microsoft.com/office/drawing/2014/main" id="{AADCA33A-5A1B-4308-853D-EB534128E707}"/>
               </a:ext>
             </a:extLst>
           </p:cNvPr>
@@ -7419,7 +7375,7 @@
           <p:cNvPr id="15" name="">
             <a:extLst xmlns:a="http://schemas.openxmlformats.org/drawingml/2006/main">
               <a:ext uri="{FF2B5EF4-FFF2-40B4-BE49-F238E27FC236}">
-                <a16:creationId xmlns:a16="http://schemas.microsoft.com/office/drawing/2014/main" id="{C4E4A3B4-0329-42A8-A90C-7B0E46943853}"/>
+                <a16:creationId xmlns:a16="http://schemas.microsoft.com/office/drawing/2014/main" id="{B9ED2293-2579-4927-B369-8EE3086F1D13}"/>
               </a:ext>
             </a:extLst>
           </p:cNvPr>
@@ -7474,7 +7430,7 @@
     </p:spTree>
     <p:extLst>
       <p:ext uri="{BB962C8B-B14F-4D97-AF65-F5344CB8AC3E}">
-        <p14:creationId xmlns:p14="http://schemas.microsoft.com/office/powerpoint/2010/main" val="311173158"/>
+        <p14:creationId xmlns:p14="http://schemas.microsoft.com/office/powerpoint/2010/main" val="694792508"/>
       </p:ext>
     </p:extLst>
   </p:cSld>
@@ -7505,7 +7461,7 @@
           <p:cNvPr id="12" name="">
             <a:extLst xmlns:a="http://schemas.openxmlformats.org/drawingml/2006/main">
               <a:ext uri="{FF2B5EF4-FFF2-40B4-BE49-F238E27FC236}">
-                <a16:creationId xmlns:a16="http://schemas.microsoft.com/office/drawing/2014/main" id="{1D10444A-FCDC-4490-9E45-4D02A59F77FF}"/>
+                <a16:creationId xmlns:a16="http://schemas.microsoft.com/office/drawing/2014/main" id="{494BCED3-D681-4BED-8A39-6B09021DA280}"/>
               </a:ext>
             </a:extLst>
           </p:cNvPr>
@@ -7562,7 +7518,7 @@
           <p:cNvPr id="2" name="">
             <a:extLst xmlns:a="http://schemas.openxmlformats.org/drawingml/2006/main">
               <a:ext uri="{FF2B5EF4-FFF2-40B4-BE49-F238E27FC236}">
-                <a16:creationId xmlns:a16="http://schemas.microsoft.com/office/drawing/2014/main" id="{5EEF78F9-D106-42D9-93E4-065C870AF465}"/>
+                <a16:creationId xmlns:a16="http://schemas.microsoft.com/office/drawing/2014/main" id="{AEEC5D00-9FD1-419F-9069-97FF9C5A2C18}"/>
               </a:ext>
             </a:extLst>
           </p:cNvPr>
@@ -7619,7 +7575,7 @@
           <p:cNvPr id="3" name="">
             <a:extLst xmlns:a="http://schemas.openxmlformats.org/drawingml/2006/main">
               <a:ext uri="{FF2B5EF4-FFF2-40B4-BE49-F238E27FC236}">
-                <a16:creationId xmlns:a16="http://schemas.microsoft.com/office/drawing/2014/main" id="{8DAE67E9-8816-4CA8-9F51-7CD253831067}"/>
+                <a16:creationId xmlns:a16="http://schemas.microsoft.com/office/drawing/2014/main" id="{E7C11BBE-8B67-453A-A2D5-2C032F4D6EEB}"/>
               </a:ext>
             </a:extLst>
           </p:cNvPr>
@@ -7683,7 +7639,7 @@
         </p:xfrm>
         <a:graphic xmlns:a="http://schemas.openxmlformats.org/drawingml/2006/main">
           <a:graphicData uri="http://schemas.openxmlformats.org/drawingml/2006/chart">
-            <c:chart xmlns:r="http://schemas.openxmlformats.org/officeDocument/2006/relationships" xmlns:c="http://schemas.openxmlformats.org/drawingml/2006/chart" r:id="Rdfa5f142fa994233"/>
+            <c:chart xmlns:r="http://schemas.openxmlformats.org/officeDocument/2006/relationships" xmlns:c="http://schemas.openxmlformats.org/drawingml/2006/chart" r:id="R9c86b687b451473a"/>
           </a:graphicData>
         </a:graphic>
       </p:graphicFrame>
@@ -7692,7 +7648,7 @@
           <p:cNvPr id="5" name="">
             <a:extLst xmlns:a="http://schemas.openxmlformats.org/drawingml/2006/main">
               <a:ext uri="{FF2B5EF4-FFF2-40B4-BE49-F238E27FC236}">
-                <a16:creationId xmlns:a16="http://schemas.microsoft.com/office/drawing/2014/main" id="{7EBF0986-7C0F-4062-A581-38068E7BB87F}"/>
+                <a16:creationId xmlns:a16="http://schemas.microsoft.com/office/drawing/2014/main" id="{2FC8F212-160C-4897-A606-C25CA2A0304E}"/>
               </a:ext>
             </a:extLst>
           </p:cNvPr>
@@ -7749,7 +7705,7 @@
           <p:cNvPr id="6" name="">
             <a:extLst xmlns:a="http://schemas.openxmlformats.org/drawingml/2006/main">
               <a:ext uri="{FF2B5EF4-FFF2-40B4-BE49-F238E27FC236}">
-                <a16:creationId xmlns:a16="http://schemas.microsoft.com/office/drawing/2014/main" id="{F08832E8-BB97-464D-8CBC-084758FDA159}"/>
+                <a16:creationId xmlns:a16="http://schemas.microsoft.com/office/drawing/2014/main" id="{AB2EDD67-0EFD-4E9B-9A83-CFBD53429DA0}"/>
               </a:ext>
             </a:extLst>
           </p:cNvPr>
@@ -7806,7 +7762,7 @@
           <p:cNvPr id="7" name="">
             <a:extLst xmlns:a="http://schemas.openxmlformats.org/drawingml/2006/main">
               <a:ext uri="{FF2B5EF4-FFF2-40B4-BE49-F238E27FC236}">
-                <a16:creationId xmlns:a16="http://schemas.microsoft.com/office/drawing/2014/main" id="{D3A20DA5-4F7A-4CA2-BD13-30D8431DA87B}"/>
+                <a16:creationId xmlns:a16="http://schemas.microsoft.com/office/drawing/2014/main" id="{9DCBCD52-0FA7-4BC2-B640-77923F319CE9}"/>
               </a:ext>
             </a:extLst>
           </p:cNvPr>
@@ -7863,7 +7819,7 @@
           <p:cNvPr id="8" name="">
             <a:extLst xmlns:a="http://schemas.openxmlformats.org/drawingml/2006/main">
               <a:ext uri="{FF2B5EF4-FFF2-40B4-BE49-F238E27FC236}">
-                <a16:creationId xmlns:a16="http://schemas.microsoft.com/office/drawing/2014/main" id="{3462A3D3-D76E-4CE3-B2B9-C14F9DA7B8F6}"/>
+                <a16:creationId xmlns:a16="http://schemas.microsoft.com/office/drawing/2014/main" id="{EC49F744-1635-4C28-95DE-1FE20D7A47D4}"/>
               </a:ext>
             </a:extLst>
           </p:cNvPr>
@@ -7920,7 +7876,7 @@
           <p:cNvPr id="9" name="">
             <a:extLst xmlns:a="http://schemas.openxmlformats.org/drawingml/2006/main">
               <a:ext uri="{FF2B5EF4-FFF2-40B4-BE49-F238E27FC236}">
-                <a16:creationId xmlns:a16="http://schemas.microsoft.com/office/drawing/2014/main" id="{BB74431D-2E7D-45FC-875E-9FCC23A13D98}"/>
+                <a16:creationId xmlns:a16="http://schemas.microsoft.com/office/drawing/2014/main" id="{689E6B8B-5568-497F-B656-FE72114E698E}"/>
               </a:ext>
             </a:extLst>
           </p:cNvPr>
@@ -7977,7 +7933,7 @@
           <p:cNvPr id="10" name="">
             <a:extLst xmlns:a="http://schemas.openxmlformats.org/drawingml/2006/main">
               <a:ext uri="{FF2B5EF4-FFF2-40B4-BE49-F238E27FC236}">
-                <a16:creationId xmlns:a16="http://schemas.microsoft.com/office/drawing/2014/main" id="{46F60C17-5AA2-49B7-A6A5-600E14C9E470}"/>
+                <a16:creationId xmlns:a16="http://schemas.microsoft.com/office/drawing/2014/main" id="{17B3394E-EF69-484F-8C8C-7B8D427754A9}"/>
               </a:ext>
             </a:extLst>
           </p:cNvPr>
@@ -8034,7 +7990,7 @@
           <p:cNvPr id="11" name="">
             <a:extLst xmlns:a="http://schemas.openxmlformats.org/drawingml/2006/main">
               <a:ext uri="{FF2B5EF4-FFF2-40B4-BE49-F238E27FC236}">
-                <a16:creationId xmlns:a16="http://schemas.microsoft.com/office/drawing/2014/main" id="{74657DF4-DE1F-465B-BF64-97E25D329F6E}"/>
+                <a16:creationId xmlns:a16="http://schemas.microsoft.com/office/drawing/2014/main" id="{9251C5AC-F279-4D30-8606-40DC5845BA76}"/>
               </a:ext>
             </a:extLst>
           </p:cNvPr>
@@ -8089,7 +8045,7 @@
     </p:spTree>
     <p:extLst>
       <p:ext uri="{BB962C8B-B14F-4D97-AF65-F5344CB8AC3E}">
-        <p14:creationId xmlns:p14="http://schemas.microsoft.com/office/powerpoint/2010/main" val="1928617563"/>
+        <p14:creationId xmlns:p14="http://schemas.microsoft.com/office/powerpoint/2010/main" val="381958116"/>
       </p:ext>
     </p:extLst>
   </p:cSld>
@@ -8120,7 +8076,7 @@
           <p:cNvPr id="12" name="">
             <a:extLst xmlns:a="http://schemas.openxmlformats.org/drawingml/2006/main">
               <a:ext uri="{FF2B5EF4-FFF2-40B4-BE49-F238E27FC236}">
-                <a16:creationId xmlns:a16="http://schemas.microsoft.com/office/drawing/2014/main" id="{09CB534B-B04E-4C3A-8CE1-EAF6D298660E}"/>
+                <a16:creationId xmlns:a16="http://schemas.microsoft.com/office/drawing/2014/main" id="{2B9F5760-190A-4F51-801A-E141CE63A029}"/>
               </a:ext>
             </a:extLst>
           </p:cNvPr>
@@ -8177,7 +8133,7 @@
           <p:cNvPr id="2" name="">
             <a:extLst xmlns:a="http://schemas.openxmlformats.org/drawingml/2006/main">
               <a:ext uri="{FF2B5EF4-FFF2-40B4-BE49-F238E27FC236}">
-                <a16:creationId xmlns:a16="http://schemas.microsoft.com/office/drawing/2014/main" id="{2039C4E4-D058-4F3E-B985-30FF2C385E0D}"/>
+                <a16:creationId xmlns:a16="http://schemas.microsoft.com/office/drawing/2014/main" id="{8B0ED192-1DF8-4A8C-9832-453450C97CAC}"/>
               </a:ext>
             </a:extLst>
           </p:cNvPr>
@@ -8234,7 +8190,7 @@
           <p:cNvPr id="3" name="">
             <a:extLst xmlns:a="http://schemas.openxmlformats.org/drawingml/2006/main">
               <a:ext uri="{FF2B5EF4-FFF2-40B4-BE49-F238E27FC236}">
-                <a16:creationId xmlns:a16="http://schemas.microsoft.com/office/drawing/2014/main" id="{EC522A75-81C8-4284-BFA8-4253945E9A8A}"/>
+                <a16:creationId xmlns:a16="http://schemas.microsoft.com/office/drawing/2014/main" id="{9D62B75F-037B-4C87-8A70-E18AC69E2DC7}"/>
               </a:ext>
             </a:extLst>
           </p:cNvPr>
@@ -8298,7 +8254,7 @@
         </p:xfrm>
         <a:graphic xmlns:a="http://schemas.openxmlformats.org/drawingml/2006/main">
           <a:graphicData uri="http://schemas.openxmlformats.org/drawingml/2006/chart">
-            <c:chart xmlns:r="http://schemas.openxmlformats.org/officeDocument/2006/relationships" xmlns:c="http://schemas.openxmlformats.org/drawingml/2006/chart" r:id="Re37d6a3b5b31485d"/>
+            <c:chart xmlns:r="http://schemas.openxmlformats.org/officeDocument/2006/relationships" xmlns:c="http://schemas.openxmlformats.org/drawingml/2006/chart" r:id="Rfbde1cea682f4647"/>
           </a:graphicData>
         </a:graphic>
       </p:graphicFrame>
@@ -8307,7 +8263,7 @@
           <p:cNvPr id="5" name="">
             <a:extLst xmlns:a="http://schemas.openxmlformats.org/drawingml/2006/main">
               <a:ext uri="{FF2B5EF4-FFF2-40B4-BE49-F238E27FC236}">
-                <a16:creationId xmlns:a16="http://schemas.microsoft.com/office/drawing/2014/main" id="{F23B7E77-5D6F-47CF-AAA6-ECB89B916FFF}"/>
+                <a16:creationId xmlns:a16="http://schemas.microsoft.com/office/drawing/2014/main" id="{BED7697F-9506-45C2-9AF4-E7BB376F23E7}"/>
               </a:ext>
             </a:extLst>
           </p:cNvPr>
@@ -8364,7 +8320,7 @@
           <p:cNvPr id="6" name="">
             <a:extLst xmlns:a="http://schemas.openxmlformats.org/drawingml/2006/main">
               <a:ext uri="{FF2B5EF4-FFF2-40B4-BE49-F238E27FC236}">
-                <a16:creationId xmlns:a16="http://schemas.microsoft.com/office/drawing/2014/main" id="{60E0167C-C886-4177-B9E8-784E31C6A382}"/>
+                <a16:creationId xmlns:a16="http://schemas.microsoft.com/office/drawing/2014/main" id="{AD82D457-EE91-4AD5-B1F9-727DB0B40E65}"/>
               </a:ext>
             </a:extLst>
           </p:cNvPr>
@@ -8421,7 +8377,7 @@
           <p:cNvPr id="7" name="">
             <a:extLst xmlns:a="http://schemas.openxmlformats.org/drawingml/2006/main">
               <a:ext uri="{FF2B5EF4-FFF2-40B4-BE49-F238E27FC236}">
-                <a16:creationId xmlns:a16="http://schemas.microsoft.com/office/drawing/2014/main" id="{FB300BD5-2618-4F72-ADCF-CF950685B097}"/>
+                <a16:creationId xmlns:a16="http://schemas.microsoft.com/office/drawing/2014/main" id="{DB49A7D1-0429-4BD5-84BF-B6C2033148D2}"/>
               </a:ext>
             </a:extLst>
           </p:cNvPr>
@@ -8478,7 +8434,7 @@
           <p:cNvPr id="8" name="">
             <a:extLst xmlns:a="http://schemas.openxmlformats.org/drawingml/2006/main">
               <a:ext uri="{FF2B5EF4-FFF2-40B4-BE49-F238E27FC236}">
-                <a16:creationId xmlns:a16="http://schemas.microsoft.com/office/drawing/2014/main" id="{58C6CC3D-F150-4B05-B98E-884D0BB091F9}"/>
+                <a16:creationId xmlns:a16="http://schemas.microsoft.com/office/drawing/2014/main" id="{4A6978EC-9EAE-49D4-899D-73DE7B4453EA}"/>
               </a:ext>
             </a:extLst>
           </p:cNvPr>
@@ -8535,7 +8491,7 @@
           <p:cNvPr id="9" name="">
             <a:extLst xmlns:a="http://schemas.openxmlformats.org/drawingml/2006/main">
               <a:ext uri="{FF2B5EF4-FFF2-40B4-BE49-F238E27FC236}">
-                <a16:creationId xmlns:a16="http://schemas.microsoft.com/office/drawing/2014/main" id="{3A7434D4-FAB2-4531-ABDF-1698020366B1}"/>
+                <a16:creationId xmlns:a16="http://schemas.microsoft.com/office/drawing/2014/main" id="{15208FB1-BFD1-4396-AE3C-BE8A9E409963}"/>
               </a:ext>
             </a:extLst>
           </p:cNvPr>
@@ -8592,7 +8548,7 @@
           <p:cNvPr id="10" name="">
             <a:extLst xmlns:a="http://schemas.openxmlformats.org/drawingml/2006/main">
               <a:ext uri="{FF2B5EF4-FFF2-40B4-BE49-F238E27FC236}">
-                <a16:creationId xmlns:a16="http://schemas.microsoft.com/office/drawing/2014/main" id="{7ACC8045-5496-463C-9771-0FF24E8BBE98}"/>
+                <a16:creationId xmlns:a16="http://schemas.microsoft.com/office/drawing/2014/main" id="{913A8237-D9C7-4E64-A93C-9E40DC2797FE}"/>
               </a:ext>
             </a:extLst>
           </p:cNvPr>
@@ -8649,7 +8605,7 @@
           <p:cNvPr id="11" name="">
             <a:extLst xmlns:a="http://schemas.openxmlformats.org/drawingml/2006/main">
               <a:ext uri="{FF2B5EF4-FFF2-40B4-BE49-F238E27FC236}">
-                <a16:creationId xmlns:a16="http://schemas.microsoft.com/office/drawing/2014/main" id="{650D2CB8-DCD5-4766-A5CA-3F13902918C0}"/>
+                <a16:creationId xmlns:a16="http://schemas.microsoft.com/office/drawing/2014/main" id="{CC30512D-7C01-4554-A240-A5DA83B5B266}"/>
               </a:ext>
             </a:extLst>
           </p:cNvPr>
@@ -8704,7 +8660,7 @@
     </p:spTree>
     <p:extLst>
       <p:ext uri="{BB962C8B-B14F-4D97-AF65-F5344CB8AC3E}">
-        <p14:creationId xmlns:p14="http://schemas.microsoft.com/office/powerpoint/2010/main" val="925143214"/>
+        <p14:creationId xmlns:p14="http://schemas.microsoft.com/office/powerpoint/2010/main" val="2014950798"/>
       </p:ext>
     </p:extLst>
   </p:cSld>
@@ -8735,7 +8691,7 @@
           <p:cNvPr id="12" name="">
             <a:extLst xmlns:a="http://schemas.openxmlformats.org/drawingml/2006/main">
               <a:ext uri="{FF2B5EF4-FFF2-40B4-BE49-F238E27FC236}">
-                <a16:creationId xmlns:a16="http://schemas.microsoft.com/office/drawing/2014/main" id="{199939C6-976C-4A06-B8CE-665C990443CC}"/>
+                <a16:creationId xmlns:a16="http://schemas.microsoft.com/office/drawing/2014/main" id="{F746C1DB-A860-4F1C-B806-E756D4CF959C}"/>
               </a:ext>
             </a:extLst>
           </p:cNvPr>
@@ -8792,7 +8748,7 @@
           <p:cNvPr id="2" name="">
             <a:extLst xmlns:a="http://schemas.openxmlformats.org/drawingml/2006/main">
               <a:ext uri="{FF2B5EF4-FFF2-40B4-BE49-F238E27FC236}">
-                <a16:creationId xmlns:a16="http://schemas.microsoft.com/office/drawing/2014/main" id="{A1E91328-0CCA-4531-B19A-D146F9FE46F2}"/>
+                <a16:creationId xmlns:a16="http://schemas.microsoft.com/office/drawing/2014/main" id="{C3BC3C8C-4E9E-49D6-8707-44A3A4CBF6B5}"/>
               </a:ext>
             </a:extLst>
           </p:cNvPr>
@@ -8849,7 +8805,7 @@
           <p:cNvPr id="3" name="">
             <a:extLst xmlns:a="http://schemas.openxmlformats.org/drawingml/2006/main">
               <a:ext uri="{FF2B5EF4-FFF2-40B4-BE49-F238E27FC236}">
-                <a16:creationId xmlns:a16="http://schemas.microsoft.com/office/drawing/2014/main" id="{FFE5467F-A551-4803-9CDE-18E447549B96}"/>
+                <a16:creationId xmlns:a16="http://schemas.microsoft.com/office/drawing/2014/main" id="{B5DA83A7-A25B-494D-9C72-EF8DD4D0F0D1}"/>
               </a:ext>
             </a:extLst>
           </p:cNvPr>
@@ -8906,7 +8862,7 @@
           <p:cNvPr id="4" name="">
             <a:extLst xmlns:a="http://schemas.openxmlformats.org/drawingml/2006/main">
               <a:ext uri="{FF2B5EF4-FFF2-40B4-BE49-F238E27FC236}">
-                <a16:creationId xmlns:a16="http://schemas.microsoft.com/office/drawing/2014/main" id="{A8691F85-6EE9-4E10-BCBC-144DC48D932C}"/>
+                <a16:creationId xmlns:a16="http://schemas.microsoft.com/office/drawing/2014/main" id="{608F5465-E9C3-453B-B7B0-4A874BAB7B31}"/>
               </a:ext>
             </a:extLst>
           </p:cNvPr>
@@ -8963,7 +8919,7 @@
           <p:cNvPr id="5" name="">
             <a:extLst xmlns:a="http://schemas.openxmlformats.org/drawingml/2006/main">
               <a:ext uri="{FF2B5EF4-FFF2-40B4-BE49-F238E27FC236}">
-                <a16:creationId xmlns:a16="http://schemas.microsoft.com/office/drawing/2014/main" id="{45C2439B-E3D5-4A0A-BD94-26C40AA8AE69}"/>
+                <a16:creationId xmlns:a16="http://schemas.microsoft.com/office/drawing/2014/main" id="{14F06F07-3B8C-456B-81C2-43B8D24EDF69}"/>
               </a:ext>
             </a:extLst>
           </p:cNvPr>
@@ -9020,7 +8976,7 @@
           <p:cNvPr id="6" name="">
             <a:extLst xmlns:a="http://schemas.openxmlformats.org/drawingml/2006/main">
               <a:ext uri="{FF2B5EF4-FFF2-40B4-BE49-F238E27FC236}">
-                <a16:creationId xmlns:a16="http://schemas.microsoft.com/office/drawing/2014/main" id="{8E6207BE-9F7E-4561-842F-6BBEE06F0966}"/>
+                <a16:creationId xmlns:a16="http://schemas.microsoft.com/office/drawing/2014/main" id="{CC11CDEA-95B9-4285-B2B9-35FF31383D15}"/>
               </a:ext>
             </a:extLst>
           </p:cNvPr>
@@ -9077,7 +9033,7 @@
           <p:cNvPr id="7" name="">
             <a:extLst xmlns:a="http://schemas.openxmlformats.org/drawingml/2006/main">
               <a:ext uri="{FF2B5EF4-FFF2-40B4-BE49-F238E27FC236}">
-                <a16:creationId xmlns:a16="http://schemas.microsoft.com/office/drawing/2014/main" id="{A015BF3B-F485-4E40-AA5E-50E2E129BE29}"/>
+                <a16:creationId xmlns:a16="http://schemas.microsoft.com/office/drawing/2014/main" id="{BE64A215-8BE4-4C82-9850-C96E333D0388}"/>
               </a:ext>
             </a:extLst>
           </p:cNvPr>
@@ -9134,7 +9090,7 @@
           <p:cNvPr id="8" name="">
             <a:extLst xmlns:a="http://schemas.openxmlformats.org/drawingml/2006/main">
               <a:ext uri="{FF2B5EF4-FFF2-40B4-BE49-F238E27FC236}">
-                <a16:creationId xmlns:a16="http://schemas.microsoft.com/office/drawing/2014/main" id="{70B1AF5B-FB9A-45A1-917E-AD8C91EC51E5}"/>
+                <a16:creationId xmlns:a16="http://schemas.microsoft.com/office/drawing/2014/main" id="{4FC67AF8-95C9-482C-9EE0-DA4A3E422E4E}"/>
               </a:ext>
             </a:extLst>
           </p:cNvPr>
@@ -9191,7 +9147,7 @@
           <p:cNvPr id="9" name="">
             <a:extLst xmlns:a="http://schemas.openxmlformats.org/drawingml/2006/main">
               <a:ext uri="{FF2B5EF4-FFF2-40B4-BE49-F238E27FC236}">
-                <a16:creationId xmlns:a16="http://schemas.microsoft.com/office/drawing/2014/main" id="{055A1E31-DF30-45F6-B041-A7D035DE03DD}"/>
+                <a16:creationId xmlns:a16="http://schemas.microsoft.com/office/drawing/2014/main" id="{04883810-44AF-4DFF-839F-5E48389E9655}"/>
               </a:ext>
             </a:extLst>
           </p:cNvPr>
@@ -9248,7 +9204,7 @@
           <p:cNvPr id="10" name="">
             <a:extLst xmlns:a="http://schemas.openxmlformats.org/drawingml/2006/main">
               <a:ext uri="{FF2B5EF4-FFF2-40B4-BE49-F238E27FC236}">
-                <a16:creationId xmlns:a16="http://schemas.microsoft.com/office/drawing/2014/main" id="{E31F10DE-C9A2-48CF-88D0-3530E83C9136}"/>
+                <a16:creationId xmlns:a16="http://schemas.microsoft.com/office/drawing/2014/main" id="{8676299C-58AC-4437-9629-2F2D39A0DB01}"/>
               </a:ext>
             </a:extLst>
           </p:cNvPr>
@@ -9305,7 +9261,7 @@
           <p:cNvPr id="11" name="">
             <a:extLst xmlns:a="http://schemas.openxmlformats.org/drawingml/2006/main">
               <a:ext uri="{FF2B5EF4-FFF2-40B4-BE49-F238E27FC236}">
-                <a16:creationId xmlns:a16="http://schemas.microsoft.com/office/drawing/2014/main" id="{2D792161-6C08-49B1-91DD-369FC13504DC}"/>
+                <a16:creationId xmlns:a16="http://schemas.microsoft.com/office/drawing/2014/main" id="{3A2641F9-5C3E-48A4-9CA5-610CC995A2EE}"/>
               </a:ext>
             </a:extLst>
           </p:cNvPr>
@@ -9360,7 +9316,7 @@
     </p:spTree>
     <p:extLst>
       <p:ext uri="{BB962C8B-B14F-4D97-AF65-F5344CB8AC3E}">
-        <p14:creationId xmlns:p14="http://schemas.microsoft.com/office/powerpoint/2010/main" val="2102989168"/>
+        <p14:creationId xmlns:p14="http://schemas.microsoft.com/office/powerpoint/2010/main" val="732136842"/>
       </p:ext>
     </p:extLst>
   </p:cSld>
@@ -9391,7 +9347,7 @@
           <p:cNvPr id="12" name="">
             <a:extLst xmlns:a="http://schemas.openxmlformats.org/drawingml/2006/main">
               <a:ext uri="{FF2B5EF4-FFF2-40B4-BE49-F238E27FC236}">
-                <a16:creationId xmlns:a16="http://schemas.microsoft.com/office/drawing/2014/main" id="{78342080-21FB-43A9-8A1F-74A2D608A3F5}"/>
+                <a16:creationId xmlns:a16="http://schemas.microsoft.com/office/drawing/2014/main" id="{28E9C03A-0120-42B7-B529-DDEDCAC7787C}"/>
               </a:ext>
             </a:extLst>
           </p:cNvPr>
@@ -9448,7 +9404,7 @@
           <p:cNvPr id="2" name="">
             <a:extLst xmlns:a="http://schemas.openxmlformats.org/drawingml/2006/main">
               <a:ext uri="{FF2B5EF4-FFF2-40B4-BE49-F238E27FC236}">
-                <a16:creationId xmlns:a16="http://schemas.microsoft.com/office/drawing/2014/main" id="{7D9BEAE6-BBC5-4819-8000-EDC45149B177}"/>
+                <a16:creationId xmlns:a16="http://schemas.microsoft.com/office/drawing/2014/main" id="{A6F75D8A-0F00-456B-A0AB-187188A281FA}"/>
               </a:ext>
             </a:extLst>
           </p:cNvPr>
@@ -9505,7 +9461,7 @@
           <p:cNvPr id="3" name="">
             <a:extLst xmlns:a="http://schemas.openxmlformats.org/drawingml/2006/main">
               <a:ext uri="{FF2B5EF4-FFF2-40B4-BE49-F238E27FC236}">
-                <a16:creationId xmlns:a16="http://schemas.microsoft.com/office/drawing/2014/main" id="{C22A5DB5-B7FD-4025-9EDB-E4F3544EAEEC}"/>
+                <a16:creationId xmlns:a16="http://schemas.microsoft.com/office/drawing/2014/main" id="{5A77516B-4500-4592-AA24-EAE64B182087}"/>
               </a:ext>
             </a:extLst>
           </p:cNvPr>
@@ -9569,7 +9525,7 @@
         </p:xfrm>
         <a:graphic xmlns:a="http://schemas.openxmlformats.org/drawingml/2006/main">
           <a:graphicData uri="http://schemas.openxmlformats.org/drawingml/2006/chart">
-            <c:chart xmlns:r="http://schemas.openxmlformats.org/officeDocument/2006/relationships" xmlns:c="http://schemas.openxmlformats.org/drawingml/2006/chart" r:id="R21a1f1b88a6843b5"/>
+            <c:chart xmlns:r="http://schemas.openxmlformats.org/officeDocument/2006/relationships" xmlns:c="http://schemas.openxmlformats.org/drawingml/2006/chart" r:id="R4b9cf690c3614ac5"/>
           </a:graphicData>
         </a:graphic>
       </p:graphicFrame>
@@ -9578,7 +9534,7 @@
           <p:cNvPr id="5" name="">
             <a:extLst xmlns:a="http://schemas.openxmlformats.org/drawingml/2006/main">
               <a:ext uri="{FF2B5EF4-FFF2-40B4-BE49-F238E27FC236}">
-                <a16:creationId xmlns:a16="http://schemas.microsoft.com/office/drawing/2014/main" id="{5F4C934A-EAC4-4364-9386-ADB095732954}"/>
+                <a16:creationId xmlns:a16="http://schemas.microsoft.com/office/drawing/2014/main" id="{FCE16414-0839-4592-8BD2-2F293B27E67B}"/>
               </a:ext>
             </a:extLst>
           </p:cNvPr>
@@ -9635,7 +9591,7 @@
           <p:cNvPr id="6" name="">
             <a:extLst xmlns:a="http://schemas.openxmlformats.org/drawingml/2006/main">
               <a:ext uri="{FF2B5EF4-FFF2-40B4-BE49-F238E27FC236}">
-                <a16:creationId xmlns:a16="http://schemas.microsoft.com/office/drawing/2014/main" id="{E09EC24C-1D60-4F65-9F84-73D376F8DC98}"/>
+                <a16:creationId xmlns:a16="http://schemas.microsoft.com/office/drawing/2014/main" id="{1189F653-61E1-4AB6-9859-C423299EDE05}"/>
               </a:ext>
             </a:extLst>
           </p:cNvPr>
@@ -9692,7 +9648,7 @@
           <p:cNvPr id="7" name="">
             <a:extLst xmlns:a="http://schemas.openxmlformats.org/drawingml/2006/main">
               <a:ext uri="{FF2B5EF4-FFF2-40B4-BE49-F238E27FC236}">
-                <a16:creationId xmlns:a16="http://schemas.microsoft.com/office/drawing/2014/main" id="{0D8C0AF0-54B0-44F3-A8F7-CBF64DD3EDC9}"/>
+                <a16:creationId xmlns:a16="http://schemas.microsoft.com/office/drawing/2014/main" id="{0A1D711A-1D59-47D5-B1C2-9FFD9B7EC15A}"/>
               </a:ext>
             </a:extLst>
           </p:cNvPr>
@@ -9739,7 +9695,7 @@
                 <a:ea typeface="Heiti TC"/>
                 <a:cs typeface="Heiti TC"/>
               </a:rPr>
-              <a:t>先估計，再檢查網頁</a:t>
+              <a:t>先畫直線，再估計</a:t>
             </a:r>
           </a:p>
         </p:txBody>
@@ -9749,7 +9705,7 @@
           <p:cNvPr id="8" name="">
             <a:extLst xmlns:a="http://schemas.openxmlformats.org/drawingml/2006/main">
               <a:ext uri="{FF2B5EF4-FFF2-40B4-BE49-F238E27FC236}">
-                <a16:creationId xmlns:a16="http://schemas.microsoft.com/office/drawing/2014/main" id="{CAD22AD1-1F71-48F3-8473-0C6000D11DCC}"/>
+                <a16:creationId xmlns:a16="http://schemas.microsoft.com/office/drawing/2014/main" id="{A8262DF9-6BBF-4981-BCC1-7B38FF546E18}"/>
               </a:ext>
             </a:extLst>
           </p:cNvPr>
@@ -9796,7 +9752,7 @@
                 <a:ea typeface="Arial"/>
                 <a:cs typeface="Arial"/>
               </a:rPr>
-              <a:t>Estimate first, then check the page</a:t>
+              <a:t>Draw your line, then estimate</a:t>
             </a:r>
           </a:p>
         </p:txBody>
@@ -9806,7 +9762,7 @@
           <p:cNvPr id="9" name="">
             <a:extLst xmlns:a="http://schemas.openxmlformats.org/drawingml/2006/main">
               <a:ext uri="{FF2B5EF4-FFF2-40B4-BE49-F238E27FC236}">
-                <a16:creationId xmlns:a16="http://schemas.microsoft.com/office/drawing/2014/main" id="{26CA0E76-B698-4722-8C21-41ABC9ADBFEF}"/>
+                <a16:creationId xmlns:a16="http://schemas.microsoft.com/office/drawing/2014/main" id="{AF57AAAD-F41D-48C4-A37C-BDDF2F52E58B}"/>
               </a:ext>
             </a:extLst>
           </p:cNvPr>
@@ -9863,7 +9819,7 @@
           <p:cNvPr id="10" name="">
             <a:extLst xmlns:a="http://schemas.openxmlformats.org/drawingml/2006/main">
               <a:ext uri="{FF2B5EF4-FFF2-40B4-BE49-F238E27FC236}">
-                <a16:creationId xmlns:a16="http://schemas.microsoft.com/office/drawing/2014/main" id="{D091F5C5-9138-45AF-B3D0-03DFDF19B829}"/>
+                <a16:creationId xmlns:a16="http://schemas.microsoft.com/office/drawing/2014/main" id="{CFC929E6-E84B-4CFE-A44B-1BAB7F8BCABC}"/>
               </a:ext>
             </a:extLst>
           </p:cNvPr>
@@ -9920,7 +9876,7 @@
           <p:cNvPr id="11" name="">
             <a:extLst xmlns:a="http://schemas.openxmlformats.org/drawingml/2006/main">
               <a:ext uri="{FF2B5EF4-FFF2-40B4-BE49-F238E27FC236}">
-                <a16:creationId xmlns:a16="http://schemas.microsoft.com/office/drawing/2014/main" id="{A8F22401-AD61-4293-A1AF-731B7861115B}"/>
+                <a16:creationId xmlns:a16="http://schemas.microsoft.com/office/drawing/2014/main" id="{A2D69B9D-0595-4AAA-AFEB-E79FF880EE3F}"/>
               </a:ext>
             </a:extLst>
           </p:cNvPr>
@@ -9975,7 +9931,7 @@
     </p:spTree>
     <p:extLst>
       <p:ext uri="{BB962C8B-B14F-4D97-AF65-F5344CB8AC3E}">
-        <p14:creationId xmlns:p14="http://schemas.microsoft.com/office/powerpoint/2010/main" val="788462280"/>
+        <p14:creationId xmlns:p14="http://schemas.microsoft.com/office/powerpoint/2010/main" val="651977194"/>
       </p:ext>
     </p:extLst>
   </p:cSld>
@@ -10006,7 +9962,7 @@
           <p:cNvPr id="15" name="">
             <a:extLst xmlns:a="http://schemas.openxmlformats.org/drawingml/2006/main">
               <a:ext uri="{FF2B5EF4-FFF2-40B4-BE49-F238E27FC236}">
-                <a16:creationId xmlns:a16="http://schemas.microsoft.com/office/drawing/2014/main" id="{3EAC87F3-17A3-4262-9139-25574F8740D5}"/>
+                <a16:creationId xmlns:a16="http://schemas.microsoft.com/office/drawing/2014/main" id="{64CA3DA0-0AB8-4C20-894E-CB8ACF3FDD5F}"/>
               </a:ext>
             </a:extLst>
           </p:cNvPr>
@@ -10063,7 +10019,7 @@
           <p:cNvPr id="2" name="">
             <a:extLst xmlns:a="http://schemas.openxmlformats.org/drawingml/2006/main">
               <a:ext uri="{FF2B5EF4-FFF2-40B4-BE49-F238E27FC236}">
-                <a16:creationId xmlns:a16="http://schemas.microsoft.com/office/drawing/2014/main" id="{EC32A996-F461-467C-A6F9-EDE92BD6DC8E}"/>
+                <a16:creationId xmlns:a16="http://schemas.microsoft.com/office/drawing/2014/main" id="{F1F425B4-B1B6-43BF-B2C2-0FE7A094373E}"/>
               </a:ext>
             </a:extLst>
           </p:cNvPr>
@@ -10120,7 +10076,7 @@
           <p:cNvPr id="3" name="">
             <a:extLst xmlns:a="http://schemas.openxmlformats.org/drawingml/2006/main">
               <a:ext uri="{FF2B5EF4-FFF2-40B4-BE49-F238E27FC236}">
-                <a16:creationId xmlns:a16="http://schemas.microsoft.com/office/drawing/2014/main" id="{829C64E5-4611-4FA7-A7E4-4B5B7FCE8E40}"/>
+                <a16:creationId xmlns:a16="http://schemas.microsoft.com/office/drawing/2014/main" id="{7E31F2CB-3208-4CAB-B2D4-CD47C3034365}"/>
               </a:ext>
             </a:extLst>
           </p:cNvPr>
@@ -10177,7 +10133,7 @@
           <p:cNvPr id="4" name="">
             <a:extLst xmlns:a="http://schemas.openxmlformats.org/drawingml/2006/main">
               <a:ext uri="{FF2B5EF4-FFF2-40B4-BE49-F238E27FC236}">
-                <a16:creationId xmlns:a16="http://schemas.microsoft.com/office/drawing/2014/main" id="{D10E744C-606C-4AD8-8CBA-C0DEF5CE21E1}"/>
+                <a16:creationId xmlns:a16="http://schemas.microsoft.com/office/drawing/2014/main" id="{D533A1DA-B729-4A76-ADCF-561AFEE81438}"/>
               </a:ext>
             </a:extLst>
           </p:cNvPr>
@@ -10234,7 +10190,7 @@
           <p:cNvPr id="5" name="">
             <a:extLst xmlns:a="http://schemas.openxmlformats.org/drawingml/2006/main">
               <a:ext uri="{FF2B5EF4-FFF2-40B4-BE49-F238E27FC236}">
-                <a16:creationId xmlns:a16="http://schemas.microsoft.com/office/drawing/2014/main" id="{92D368E6-2882-498C-A42F-C339875D4070}"/>
+                <a16:creationId xmlns:a16="http://schemas.microsoft.com/office/drawing/2014/main" id="{32C3DB2E-CEA0-42C8-8F16-F000C677E385}"/>
               </a:ext>
             </a:extLst>
           </p:cNvPr>
@@ -10291,7 +10247,7 @@
           <p:cNvPr id="6" name="">
             <a:extLst xmlns:a="http://schemas.openxmlformats.org/drawingml/2006/main">
               <a:ext uri="{FF2B5EF4-FFF2-40B4-BE49-F238E27FC236}">
-                <a16:creationId xmlns:a16="http://schemas.microsoft.com/office/drawing/2014/main" id="{FCE77090-F89A-44D0-8EA8-A5C95401D16A}"/>
+                <a16:creationId xmlns:a16="http://schemas.microsoft.com/office/drawing/2014/main" id="{3C20D341-4874-4483-87B8-FF506CB515D7}"/>
               </a:ext>
             </a:extLst>
           </p:cNvPr>
@@ -10348,7 +10304,7 @@
           <p:cNvPr id="7" name="">
             <a:extLst xmlns:a="http://schemas.openxmlformats.org/drawingml/2006/main">
               <a:ext uri="{FF2B5EF4-FFF2-40B4-BE49-F238E27FC236}">
-                <a16:creationId xmlns:a16="http://schemas.microsoft.com/office/drawing/2014/main" id="{6884F604-4620-484D-9A6C-D395BE784B65}"/>
+                <a16:creationId xmlns:a16="http://schemas.microsoft.com/office/drawing/2014/main" id="{3F801363-A6FC-408E-81C0-9E781EEA3E3E}"/>
               </a:ext>
             </a:extLst>
           </p:cNvPr>
@@ -10405,7 +10361,7 @@
           <p:cNvPr id="8" name="">
             <a:extLst xmlns:a="http://schemas.openxmlformats.org/drawingml/2006/main">
               <a:ext uri="{FF2B5EF4-FFF2-40B4-BE49-F238E27FC236}">
-                <a16:creationId xmlns:a16="http://schemas.microsoft.com/office/drawing/2014/main" id="{E8D4BB63-C1C4-42C3-A555-9055BBE5EB2B}"/>
+                <a16:creationId xmlns:a16="http://schemas.microsoft.com/office/drawing/2014/main" id="{A4E8B400-2D01-419B-90C2-E61D8F9DCB65}"/>
               </a:ext>
             </a:extLst>
           </p:cNvPr>
@@ -10462,7 +10418,7 @@
           <p:cNvPr id="9" name="">
             <a:extLst xmlns:a="http://schemas.openxmlformats.org/drawingml/2006/main">
               <a:ext uri="{FF2B5EF4-FFF2-40B4-BE49-F238E27FC236}">
-                <a16:creationId xmlns:a16="http://schemas.microsoft.com/office/drawing/2014/main" id="{F60ED57F-3969-4A7F-AF86-1AAC6C86DB68}"/>
+                <a16:creationId xmlns:a16="http://schemas.microsoft.com/office/drawing/2014/main" id="{8AB9928E-161E-4ECB-AF9B-14A602AAB5C1}"/>
               </a:ext>
             </a:extLst>
           </p:cNvPr>
@@ -10519,7 +10475,7 @@
           <p:cNvPr id="10" name="">
             <a:extLst xmlns:a="http://schemas.openxmlformats.org/drawingml/2006/main">
               <a:ext uri="{FF2B5EF4-FFF2-40B4-BE49-F238E27FC236}">
-                <a16:creationId xmlns:a16="http://schemas.microsoft.com/office/drawing/2014/main" id="{99CC448C-A01C-4A27-B434-BBFAF8DF3880}"/>
+                <a16:creationId xmlns:a16="http://schemas.microsoft.com/office/drawing/2014/main" id="{BDF9EB15-F4CF-4A0E-9199-03D2F20615D8}"/>
               </a:ext>
             </a:extLst>
           </p:cNvPr>
@@ -10576,7 +10532,7 @@
           <p:cNvPr id="11" name="">
             <a:extLst xmlns:a="http://schemas.openxmlformats.org/drawingml/2006/main">
               <a:ext uri="{FF2B5EF4-FFF2-40B4-BE49-F238E27FC236}">
-                <a16:creationId xmlns:a16="http://schemas.microsoft.com/office/drawing/2014/main" id="{21CA48EA-F921-4D0B-9E4C-5F55BC7230BC}"/>
+                <a16:creationId xmlns:a16="http://schemas.microsoft.com/office/drawing/2014/main" id="{AB530495-445B-4D96-8619-FD319876366B}"/>
               </a:ext>
             </a:extLst>
           </p:cNvPr>
@@ -10633,7 +10589,7 @@
           <p:cNvPr id="12" name="">
             <a:extLst xmlns:a="http://schemas.openxmlformats.org/drawingml/2006/main">
               <a:ext uri="{FF2B5EF4-FFF2-40B4-BE49-F238E27FC236}">
-                <a16:creationId xmlns:a16="http://schemas.microsoft.com/office/drawing/2014/main" id="{4EAF6218-D012-4B1E-B65E-637C2BBD9849}"/>
+                <a16:creationId xmlns:a16="http://schemas.microsoft.com/office/drawing/2014/main" id="{4F2D89CE-A2B4-4D33-84D2-9B6C4B8B612A}"/>
               </a:ext>
             </a:extLst>
           </p:cNvPr>
@@ -10690,7 +10646,7 @@
           <p:cNvPr id="13" name="">
             <a:extLst xmlns:a="http://schemas.openxmlformats.org/drawingml/2006/main">
               <a:ext uri="{FF2B5EF4-FFF2-40B4-BE49-F238E27FC236}">
-                <a16:creationId xmlns:a16="http://schemas.microsoft.com/office/drawing/2014/main" id="{7801DF10-1C05-4565-B505-8E5FD391D854}"/>
+                <a16:creationId xmlns:a16="http://schemas.microsoft.com/office/drawing/2014/main" id="{CE10EDA2-02C3-46F2-BCA7-323BC18C4610}"/>
               </a:ext>
             </a:extLst>
           </p:cNvPr>
@@ -10747,7 +10703,7 @@
           <p:cNvPr id="14" name="">
             <a:extLst xmlns:a="http://schemas.openxmlformats.org/drawingml/2006/main">
               <a:ext uri="{FF2B5EF4-FFF2-40B4-BE49-F238E27FC236}">
-                <a16:creationId xmlns:a16="http://schemas.microsoft.com/office/drawing/2014/main" id="{EED38E19-6F88-49C3-966F-A216BAE232F5}"/>
+                <a16:creationId xmlns:a16="http://schemas.microsoft.com/office/drawing/2014/main" id="{E40AFA05-865F-4C9D-A46A-228C271CEF62}"/>
               </a:ext>
             </a:extLst>
           </p:cNvPr>
@@ -10802,7 +10758,7 @@
     </p:spTree>
     <p:extLst>
       <p:ext uri="{BB962C8B-B14F-4D97-AF65-F5344CB8AC3E}">
-        <p14:creationId xmlns:p14="http://schemas.microsoft.com/office/powerpoint/2010/main" val="1855809145"/>
+        <p14:creationId xmlns:p14="http://schemas.microsoft.com/office/powerpoint/2010/main" val="1655985118"/>
       </p:ext>
     </p:extLst>
   </p:cSld>

</xml_diff>

<commit_message>
Apply Astra pedagogical review and reveal model after student prediction
</commit_message>
<xml_diff>
--- a/teacher-slides.pptx
+++ b/teacher-slides.pptx
@@ -2,22 +2,22 @@
 <file path=ppt/presentation.xml><?xml version="1.0" encoding="utf-8"?>
 <p:presentation xmlns:p="http://schemas.openxmlformats.org/presentationml/2006/main">
   <p:sldMasterIdLst>
-    <p:sldMasterId xmlns:r="http://schemas.openxmlformats.org/officeDocument/2006/relationships" id="2147483648" r:id="Rb87840c133ba45a1"/>
+    <p:sldMasterId xmlns:r="http://schemas.openxmlformats.org/officeDocument/2006/relationships" id="2147483648" r:id="Rb55f726044294dd2"/>
   </p:sldMasterIdLst>
   <p:notesMasterIdLst>
-    <p:notesMasterId xmlns:r="http://schemas.openxmlformats.org/officeDocument/2006/relationships" r:id="R37cede2ce28f43a5"/>
+    <p:notesMasterId xmlns:r="http://schemas.openxmlformats.org/officeDocument/2006/relationships" r:id="R43d2231ef32b4834"/>
   </p:notesMasterIdLst>
   <p:sldIdLst>
-    <p:sldId xmlns:r="http://schemas.openxmlformats.org/officeDocument/2006/relationships" id="256" r:id="R599e0dd3894f4f37"/>
-    <p:sldId xmlns:r="http://schemas.openxmlformats.org/officeDocument/2006/relationships" id="257" r:id="R7203345ec06f410c"/>
-    <p:sldId xmlns:r="http://schemas.openxmlformats.org/officeDocument/2006/relationships" id="258" r:id="R037bb063dc234d8b"/>
-    <p:sldId xmlns:r="http://schemas.openxmlformats.org/officeDocument/2006/relationships" id="259" r:id="R215a9184593740b0"/>
-    <p:sldId xmlns:r="http://schemas.openxmlformats.org/officeDocument/2006/relationships" id="260" r:id="Rdfe5fd761c4d4fa1"/>
-    <p:sldId xmlns:r="http://schemas.openxmlformats.org/officeDocument/2006/relationships" id="261" r:id="R27224f16267c404b"/>
-    <p:sldId xmlns:r="http://schemas.openxmlformats.org/officeDocument/2006/relationships" id="262" r:id="R92b5fbdef10b4215"/>
-    <p:sldId xmlns:r="http://schemas.openxmlformats.org/officeDocument/2006/relationships" id="263" r:id="Rbcc7a505791d4fda"/>
-    <p:sldId xmlns:r="http://schemas.openxmlformats.org/officeDocument/2006/relationships" id="264" r:id="Rb253c47e278c44cf"/>
-    <p:sldId xmlns:r="http://schemas.openxmlformats.org/officeDocument/2006/relationships" id="265" r:id="Rea90da2126d24bfd"/>
+    <p:sldId xmlns:r="http://schemas.openxmlformats.org/officeDocument/2006/relationships" id="256" r:id="R9eeb596dd618401f"/>
+    <p:sldId xmlns:r="http://schemas.openxmlformats.org/officeDocument/2006/relationships" id="257" r:id="R6b17db8c0c084bd6"/>
+    <p:sldId xmlns:r="http://schemas.openxmlformats.org/officeDocument/2006/relationships" id="258" r:id="R5cc6cd62321b49eb"/>
+    <p:sldId xmlns:r="http://schemas.openxmlformats.org/officeDocument/2006/relationships" id="259" r:id="Rceaea2d0ddc84b88"/>
+    <p:sldId xmlns:r="http://schemas.openxmlformats.org/officeDocument/2006/relationships" id="260" r:id="Rf40f9121cd854655"/>
+    <p:sldId xmlns:r="http://schemas.openxmlformats.org/officeDocument/2006/relationships" id="261" r:id="R0fdc9f88cfe6451f"/>
+    <p:sldId xmlns:r="http://schemas.openxmlformats.org/officeDocument/2006/relationships" id="262" r:id="Rc503c2a19276432c"/>
+    <p:sldId xmlns:r="http://schemas.openxmlformats.org/officeDocument/2006/relationships" id="263" r:id="Rf7e0003446c8413d"/>
+    <p:sldId xmlns:r="http://schemas.openxmlformats.org/officeDocument/2006/relationships" id="264" r:id="Re5782a9b40f24c0c"/>
+    <p:sldId xmlns:r="http://schemas.openxmlformats.org/officeDocument/2006/relationships" id="265" r:id="R8a382e59d5fa4da3"/>
   </p:sldIdLst>
   <p:sldSz cx="12192000" cy="6858000"/>
   <p:notesSz cx="6858000" cy="9144000"/>
@@ -941,7 +941,7 @@
           <a:lstStyle xmlns:a="http://schemas.openxmlformats.org/drawingml/2006/main"/>
           <a:p xmlns:a="http://schemas.openxmlformats.org/drawingml/2006/main">
             <a:r>
-              <a:t>Start Step 2. Students keep their selected dataset and click or tap the graph. Ask them to predict first, compare m and c, and use Undo or Reset between experiments. No coordinate-entry controls appear on the page.</a:t>
+              <a:t>Start Step 2. Students keep their selected dataset and click or tap the graph. Ask them to predict first, compare m and c, and use Undo or Reset between experiments. Have students undo after each trial before comparing a different new point.</a:t>
             </a:r>
           </a:p>
         </p:txBody>
@@ -1081,7 +1081,7 @@
           <a:lstStyle xmlns:a="http://schemas.openxmlformats.org/drawingml/2006/main"/>
           <a:p xmlns:a="http://schemas.openxmlformats.org/drawingml/2006/main">
             <a:r>
-              <a:t>After written predictions. The fitted line is y=2x+50. m is about 2 marks per extra study hour in this model. c is the estimated score at zero hours. 3.5 hours is within the observed 0–6-hour range. 10 hours is outside. At 24 hours the model gives 98 marks, but this remains far outside the observed range and cannot guarantee a result. Discuss how other factors influence scores.</a:t>
+              <a:t>After written predictions. The fitted line is y=2x+50. m is about 2 marks per extra study hour in this model. c is the estimated score at zero hours. 3.5 hours is within the observed 0–6-hour range. 10 hours is outside. At 24 hours the model gives 98 marks, but this remains far outside the observed range and cannot guarantee a result. Discuss how other factors influence scores. Say: 這些數據不能證明，多溫習一小時就會令成績增加兩分。 These data do not show that an extra study hour causes a two-mark increase.</a:t>
             </a:r>
           </a:p>
         </p:txBody>
@@ -1149,7 +1149,7 @@
   </p:cSld>
   <p:clrMap bg1="lt1" tx1="dk1" bg2="lt2" tx2="dk2" accent1="accent1" accent2="accent2" accent3="accent3" accent4="accent4" accent5="accent5" accent6="accent6" hlink="hlink" folHlink="folHlink"/>
   <p:sldLayoutIdLst>
-    <p:sldLayoutId xmlns:r="http://schemas.openxmlformats.org/officeDocument/2006/relationships" id="2147483649" r:id="R2f9807e8ffac4deb"/>
+    <p:sldLayoutId xmlns:r="http://schemas.openxmlformats.org/officeDocument/2006/relationships" id="2147483649" r:id="Rf63da96829ba4fa7"/>
   </p:sldLayoutIdLst>
   <p:txStyles>
     <p:titleStyle>
@@ -4158,7 +4158,7 @@
           <p:cNvPr id="13" name="">
             <a:extLst xmlns:a="http://schemas.openxmlformats.org/drawingml/2006/main">
               <a:ext uri="{FF2B5EF4-FFF2-40B4-BE49-F238E27FC236}">
-                <a16:creationId xmlns:a16="http://schemas.microsoft.com/office/drawing/2014/main" id="{5897EECA-374A-4A31-97DF-AF32DC266E8D}"/>
+                <a16:creationId xmlns:a16="http://schemas.microsoft.com/office/drawing/2014/main" id="{FBC4E45C-020A-4461-96AC-B78784899A1E}"/>
               </a:ext>
             </a:extLst>
           </p:cNvPr>
@@ -4215,7 +4215,7 @@
           <p:cNvPr id="2" name="">
             <a:extLst xmlns:a="http://schemas.openxmlformats.org/drawingml/2006/main">
               <a:ext uri="{FF2B5EF4-FFF2-40B4-BE49-F238E27FC236}">
-                <a16:creationId xmlns:a16="http://schemas.microsoft.com/office/drawing/2014/main" id="{06CDE012-56F7-4434-8E15-4E32392C9FE3}"/>
+                <a16:creationId xmlns:a16="http://schemas.microsoft.com/office/drawing/2014/main" id="{74E28F95-1A3A-4579-B32D-E67465FE6A00}"/>
               </a:ext>
             </a:extLst>
           </p:cNvPr>
@@ -4272,7 +4272,7 @@
           <p:cNvPr id="3" name="">
             <a:extLst xmlns:a="http://schemas.openxmlformats.org/drawingml/2006/main">
               <a:ext uri="{FF2B5EF4-FFF2-40B4-BE49-F238E27FC236}">
-                <a16:creationId xmlns:a16="http://schemas.microsoft.com/office/drawing/2014/main" id="{C21323CE-8927-4D86-91C9-4764C7BC7608}"/>
+                <a16:creationId xmlns:a16="http://schemas.microsoft.com/office/drawing/2014/main" id="{D4371079-CB6A-4559-88A0-C3818DC65A87}"/>
               </a:ext>
             </a:extLst>
           </p:cNvPr>
@@ -4329,7 +4329,7 @@
           <p:cNvPr id="4" name="">
             <a:extLst xmlns:a="http://schemas.openxmlformats.org/drawingml/2006/main">
               <a:ext uri="{FF2B5EF4-FFF2-40B4-BE49-F238E27FC236}">
-                <a16:creationId xmlns:a16="http://schemas.microsoft.com/office/drawing/2014/main" id="{518065A3-512F-4F87-9BEF-FB50E7D5D714}"/>
+                <a16:creationId xmlns:a16="http://schemas.microsoft.com/office/drawing/2014/main" id="{9EA19486-F92C-4D38-A76D-8281F4348645}"/>
               </a:ext>
             </a:extLst>
           </p:cNvPr>
@@ -4386,7 +4386,7 @@
           <p:cNvPr id="5" name="">
             <a:extLst xmlns:a="http://schemas.openxmlformats.org/drawingml/2006/main">
               <a:ext uri="{FF2B5EF4-FFF2-40B4-BE49-F238E27FC236}">
-                <a16:creationId xmlns:a16="http://schemas.microsoft.com/office/drawing/2014/main" id="{760AF1C8-CCC0-4F68-A13A-0D87F42B82A8}"/>
+                <a16:creationId xmlns:a16="http://schemas.microsoft.com/office/drawing/2014/main" id="{8AA4C5CF-955B-4C20-A6E1-1AB382E864A3}"/>
               </a:ext>
             </a:extLst>
           </p:cNvPr>
@@ -4443,7 +4443,7 @@
           <p:cNvPr id="6" name="">
             <a:extLst xmlns:a="http://schemas.openxmlformats.org/drawingml/2006/main">
               <a:ext uri="{FF2B5EF4-FFF2-40B4-BE49-F238E27FC236}">
-                <a16:creationId xmlns:a16="http://schemas.microsoft.com/office/drawing/2014/main" id="{CBE5DE0A-14CF-4FFA-AA41-10FD3131BEC4}"/>
+                <a16:creationId xmlns:a16="http://schemas.microsoft.com/office/drawing/2014/main" id="{434EEE81-537A-4A8B-A208-FF508DA1A767}"/>
               </a:ext>
             </a:extLst>
           </p:cNvPr>
@@ -4500,7 +4500,7 @@
           <p:cNvPr id="7" name="">
             <a:extLst xmlns:a="http://schemas.openxmlformats.org/drawingml/2006/main">
               <a:ext uri="{FF2B5EF4-FFF2-40B4-BE49-F238E27FC236}">
-                <a16:creationId xmlns:a16="http://schemas.microsoft.com/office/drawing/2014/main" id="{AFE7DF78-4739-4D51-B4AE-B1C94D25A009}"/>
+                <a16:creationId xmlns:a16="http://schemas.microsoft.com/office/drawing/2014/main" id="{1A9E2CB2-3A05-4051-93E2-27F2E5128AB3}"/>
               </a:ext>
             </a:extLst>
           </p:cNvPr>
@@ -4557,7 +4557,7 @@
           <p:cNvPr id="8" name="">
             <a:extLst xmlns:a="http://schemas.openxmlformats.org/drawingml/2006/main">
               <a:ext uri="{FF2B5EF4-FFF2-40B4-BE49-F238E27FC236}">
-                <a16:creationId xmlns:a16="http://schemas.microsoft.com/office/drawing/2014/main" id="{7B617BEF-41DA-4182-BB61-56C0770B6029}"/>
+                <a16:creationId xmlns:a16="http://schemas.microsoft.com/office/drawing/2014/main" id="{E8A90252-DBEB-4D11-8130-8E9C850931B6}"/>
               </a:ext>
             </a:extLst>
           </p:cNvPr>
@@ -4614,7 +4614,7 @@
           <p:cNvPr id="9" name="">
             <a:extLst xmlns:a="http://schemas.openxmlformats.org/drawingml/2006/main">
               <a:ext uri="{FF2B5EF4-FFF2-40B4-BE49-F238E27FC236}">
-                <a16:creationId xmlns:a16="http://schemas.microsoft.com/office/drawing/2014/main" id="{F16C0329-8039-4434-AA27-DBBA3BEC7C43}"/>
+                <a16:creationId xmlns:a16="http://schemas.microsoft.com/office/drawing/2014/main" id="{F6E015F5-A9A5-45BB-98D4-A4B9057772C4}"/>
               </a:ext>
             </a:extLst>
           </p:cNvPr>
@@ -4671,7 +4671,7 @@
           <p:cNvPr id="10" name="">
             <a:extLst xmlns:a="http://schemas.openxmlformats.org/drawingml/2006/main">
               <a:ext uri="{FF2B5EF4-FFF2-40B4-BE49-F238E27FC236}">
-                <a16:creationId xmlns:a16="http://schemas.microsoft.com/office/drawing/2014/main" id="{FBDC2F93-ECDB-419C-B1F6-99ADF33B6E51}"/>
+                <a16:creationId xmlns:a16="http://schemas.microsoft.com/office/drawing/2014/main" id="{F8BA13E2-F6FE-4C65-B6AC-5F6FFCC1BED1}"/>
               </a:ext>
             </a:extLst>
           </p:cNvPr>
@@ -4728,7 +4728,7 @@
           <p:cNvPr id="11" name="">
             <a:extLst xmlns:a="http://schemas.openxmlformats.org/drawingml/2006/main">
               <a:ext uri="{FF2B5EF4-FFF2-40B4-BE49-F238E27FC236}">
-                <a16:creationId xmlns:a16="http://schemas.microsoft.com/office/drawing/2014/main" id="{C1DD1E23-A2F6-48BE-94BF-C841C23FA752}"/>
+                <a16:creationId xmlns:a16="http://schemas.microsoft.com/office/drawing/2014/main" id="{4CD84A27-CAED-43B5-9E5E-A1171C1E7785}"/>
               </a:ext>
             </a:extLst>
           </p:cNvPr>
@@ -4785,7 +4785,7 @@
           <p:cNvPr id="12" name="">
             <a:extLst xmlns:a="http://schemas.openxmlformats.org/drawingml/2006/main">
               <a:ext uri="{FF2B5EF4-FFF2-40B4-BE49-F238E27FC236}">
-                <a16:creationId xmlns:a16="http://schemas.microsoft.com/office/drawing/2014/main" id="{3FBAC7DF-4AF5-4CED-A840-3BC99036F2D0}"/>
+                <a16:creationId xmlns:a16="http://schemas.microsoft.com/office/drawing/2014/main" id="{80540ADD-05D3-4818-925B-7ECD4EA372A6}"/>
               </a:ext>
             </a:extLst>
           </p:cNvPr>
@@ -4840,7 +4840,7 @@
     </p:spTree>
     <p:extLst>
       <p:ext uri="{BB962C8B-B14F-4D97-AF65-F5344CB8AC3E}">
-        <p14:creationId xmlns:p14="http://schemas.microsoft.com/office/powerpoint/2010/main" val="1269116003"/>
+        <p14:creationId xmlns:p14="http://schemas.microsoft.com/office/powerpoint/2010/main" val="970504407"/>
       </p:ext>
     </p:extLst>
   </p:cSld>
@@ -4871,7 +4871,7 @@
           <p:cNvPr id="11" name="">
             <a:extLst xmlns:a="http://schemas.openxmlformats.org/drawingml/2006/main">
               <a:ext uri="{FF2B5EF4-FFF2-40B4-BE49-F238E27FC236}">
-                <a16:creationId xmlns:a16="http://schemas.microsoft.com/office/drawing/2014/main" id="{A2996034-6E87-4A92-980D-D429D9BE7741}"/>
+                <a16:creationId xmlns:a16="http://schemas.microsoft.com/office/drawing/2014/main" id="{F42AF76C-948D-4064-9F0B-9F70E4B71AE0}"/>
               </a:ext>
             </a:extLst>
           </p:cNvPr>
@@ -4928,7 +4928,7 @@
           <p:cNvPr id="2" name="">
             <a:extLst xmlns:a="http://schemas.openxmlformats.org/drawingml/2006/main">
               <a:ext uri="{FF2B5EF4-FFF2-40B4-BE49-F238E27FC236}">
-                <a16:creationId xmlns:a16="http://schemas.microsoft.com/office/drawing/2014/main" id="{E7E86C5B-48A0-4C63-857B-8C6016F741F5}"/>
+                <a16:creationId xmlns:a16="http://schemas.microsoft.com/office/drawing/2014/main" id="{112E62E0-6B13-4A48-AA7E-66B362168E3B}"/>
               </a:ext>
             </a:extLst>
           </p:cNvPr>
@@ -4985,7 +4985,7 @@
           <p:cNvPr id="3" name="">
             <a:extLst xmlns:a="http://schemas.openxmlformats.org/drawingml/2006/main">
               <a:ext uri="{FF2B5EF4-FFF2-40B4-BE49-F238E27FC236}">
-                <a16:creationId xmlns:a16="http://schemas.microsoft.com/office/drawing/2014/main" id="{61FFC652-1DD2-4426-B9A9-8722389E8576}"/>
+                <a16:creationId xmlns:a16="http://schemas.microsoft.com/office/drawing/2014/main" id="{63AA8F74-4054-4A2E-AFD9-DC4DEE193903}"/>
               </a:ext>
             </a:extLst>
           </p:cNvPr>
@@ -5042,7 +5042,7 @@
           <p:cNvPr id="4" name="">
             <a:extLst xmlns:a="http://schemas.openxmlformats.org/drawingml/2006/main">
               <a:ext uri="{FF2B5EF4-FFF2-40B4-BE49-F238E27FC236}">
-                <a16:creationId xmlns:a16="http://schemas.microsoft.com/office/drawing/2014/main" id="{3D404ADD-F5B9-4E4C-8C1F-E4B019DD2B1C}"/>
+                <a16:creationId xmlns:a16="http://schemas.microsoft.com/office/drawing/2014/main" id="{9E47C040-B861-4AF3-8A96-DD3D13A76116}"/>
               </a:ext>
             </a:extLst>
           </p:cNvPr>
@@ -5099,7 +5099,7 @@
           <p:cNvPr id="5" name="">
             <a:extLst xmlns:a="http://schemas.openxmlformats.org/drawingml/2006/main">
               <a:ext uri="{FF2B5EF4-FFF2-40B4-BE49-F238E27FC236}">
-                <a16:creationId xmlns:a16="http://schemas.microsoft.com/office/drawing/2014/main" id="{8A8690FC-1806-4FB4-9154-CADC0AC16765}"/>
+                <a16:creationId xmlns:a16="http://schemas.microsoft.com/office/drawing/2014/main" id="{FFFC84D4-7520-41A9-84AD-73492F0291A6}"/>
               </a:ext>
             </a:extLst>
           </p:cNvPr>
@@ -5156,7 +5156,7 @@
           <p:cNvPr id="6" name="">
             <a:extLst xmlns:a="http://schemas.openxmlformats.org/drawingml/2006/main">
               <a:ext uri="{FF2B5EF4-FFF2-40B4-BE49-F238E27FC236}">
-                <a16:creationId xmlns:a16="http://schemas.microsoft.com/office/drawing/2014/main" id="{CD6A190E-3374-4EC6-895F-5EA0FC2773B3}"/>
+                <a16:creationId xmlns:a16="http://schemas.microsoft.com/office/drawing/2014/main" id="{048CA853-7080-4F2F-836C-2FD1F0E135F5}"/>
               </a:ext>
             </a:extLst>
           </p:cNvPr>
@@ -5213,7 +5213,7 @@
           <p:cNvPr id="7" name="">
             <a:extLst xmlns:a="http://schemas.openxmlformats.org/drawingml/2006/main">
               <a:ext uri="{FF2B5EF4-FFF2-40B4-BE49-F238E27FC236}">
-                <a16:creationId xmlns:a16="http://schemas.microsoft.com/office/drawing/2014/main" id="{EEDB9BF3-8760-4993-804A-2A115DB43883}"/>
+                <a16:creationId xmlns:a16="http://schemas.microsoft.com/office/drawing/2014/main" id="{B510A1B2-650F-483A-8F5D-242B02334DD6}"/>
               </a:ext>
             </a:extLst>
           </p:cNvPr>
@@ -5270,7 +5270,7 @@
           <p:cNvPr id="8" name="">
             <a:extLst xmlns:a="http://schemas.openxmlformats.org/drawingml/2006/main">
               <a:ext uri="{FF2B5EF4-FFF2-40B4-BE49-F238E27FC236}">
-                <a16:creationId xmlns:a16="http://schemas.microsoft.com/office/drawing/2014/main" id="{0864FC08-762C-4452-BB39-1E9AEF436EB7}"/>
+                <a16:creationId xmlns:a16="http://schemas.microsoft.com/office/drawing/2014/main" id="{A1FACA54-38B6-4A99-9760-AF8FC0D3EB1F}"/>
               </a:ext>
             </a:extLst>
           </p:cNvPr>
@@ -5327,7 +5327,7 @@
           <p:cNvPr id="9" name="">
             <a:extLst xmlns:a="http://schemas.openxmlformats.org/drawingml/2006/main">
               <a:ext uri="{FF2B5EF4-FFF2-40B4-BE49-F238E27FC236}">
-                <a16:creationId xmlns:a16="http://schemas.microsoft.com/office/drawing/2014/main" id="{22B05EFB-B38B-4851-97C4-264A4914485A}"/>
+                <a16:creationId xmlns:a16="http://schemas.microsoft.com/office/drawing/2014/main" id="{397AA35F-16E8-4434-A539-58ED4DE5724D}"/>
               </a:ext>
             </a:extLst>
           </p:cNvPr>
@@ -5384,7 +5384,7 @@
           <p:cNvPr id="10" name="">
             <a:extLst xmlns:a="http://schemas.openxmlformats.org/drawingml/2006/main">
               <a:ext uri="{FF2B5EF4-FFF2-40B4-BE49-F238E27FC236}">
-                <a16:creationId xmlns:a16="http://schemas.microsoft.com/office/drawing/2014/main" id="{D3558A86-051B-4B28-B8FA-9C5F58C1CE10}"/>
+                <a16:creationId xmlns:a16="http://schemas.microsoft.com/office/drawing/2014/main" id="{8059C805-D4A2-4204-8179-26B758D77970}"/>
               </a:ext>
             </a:extLst>
           </p:cNvPr>
@@ -5439,7 +5439,7 @@
     </p:spTree>
     <p:extLst>
       <p:ext uri="{BB962C8B-B14F-4D97-AF65-F5344CB8AC3E}">
-        <p14:creationId xmlns:p14="http://schemas.microsoft.com/office/powerpoint/2010/main" val="1376900396"/>
+        <p14:creationId xmlns:p14="http://schemas.microsoft.com/office/powerpoint/2010/main" val="1974640751"/>
       </p:ext>
     </p:extLst>
   </p:cSld>
@@ -5470,7 +5470,7 @@
           <p:cNvPr id="12" name="">
             <a:extLst xmlns:a="http://schemas.openxmlformats.org/drawingml/2006/main">
               <a:ext uri="{FF2B5EF4-FFF2-40B4-BE49-F238E27FC236}">
-                <a16:creationId xmlns:a16="http://schemas.microsoft.com/office/drawing/2014/main" id="{A17A74F3-8C44-419A-B833-B8BEF9101349}"/>
+                <a16:creationId xmlns:a16="http://schemas.microsoft.com/office/drawing/2014/main" id="{D1524F16-BA38-46E3-BD74-0403C2648D01}"/>
               </a:ext>
             </a:extLst>
           </p:cNvPr>
@@ -5527,7 +5527,7 @@
           <p:cNvPr id="2" name="">
             <a:extLst xmlns:a="http://schemas.openxmlformats.org/drawingml/2006/main">
               <a:ext uri="{FF2B5EF4-FFF2-40B4-BE49-F238E27FC236}">
-                <a16:creationId xmlns:a16="http://schemas.microsoft.com/office/drawing/2014/main" id="{C46085C3-9D0D-40DE-ACF0-3F9D713BD4C7}"/>
+                <a16:creationId xmlns:a16="http://schemas.microsoft.com/office/drawing/2014/main" id="{D44CE3A9-DE42-4107-B67C-BAA709FBD139}"/>
               </a:ext>
             </a:extLst>
           </p:cNvPr>
@@ -5584,7 +5584,7 @@
           <p:cNvPr id="3" name="">
             <a:extLst xmlns:a="http://schemas.openxmlformats.org/drawingml/2006/main">
               <a:ext uri="{FF2B5EF4-FFF2-40B4-BE49-F238E27FC236}">
-                <a16:creationId xmlns:a16="http://schemas.microsoft.com/office/drawing/2014/main" id="{E9FFF018-8215-45BD-A19B-1C20A94BC78C}"/>
+                <a16:creationId xmlns:a16="http://schemas.microsoft.com/office/drawing/2014/main" id="{9CE0D380-CEC8-4A10-B3A6-EF7C0AEAC6FB}"/>
               </a:ext>
             </a:extLst>
           </p:cNvPr>
@@ -5641,7 +5641,7 @@
           <p:cNvPr id="4" name="">
             <a:extLst xmlns:a="http://schemas.openxmlformats.org/drawingml/2006/main">
               <a:ext uri="{FF2B5EF4-FFF2-40B4-BE49-F238E27FC236}">
-                <a16:creationId xmlns:a16="http://schemas.microsoft.com/office/drawing/2014/main" id="{EAF490FD-8705-429C-97B7-400D92F26008}"/>
+                <a16:creationId xmlns:a16="http://schemas.microsoft.com/office/drawing/2014/main" id="{0E67F8C8-3FEE-4A9B-A0B2-2A80D6B29C93}"/>
               </a:ext>
             </a:extLst>
           </p:cNvPr>
@@ -5698,7 +5698,7 @@
           <p:cNvPr id="5" name="">
             <a:extLst xmlns:a="http://schemas.openxmlformats.org/drawingml/2006/main">
               <a:ext uri="{FF2B5EF4-FFF2-40B4-BE49-F238E27FC236}">
-                <a16:creationId xmlns:a16="http://schemas.microsoft.com/office/drawing/2014/main" id="{898B3100-EDE1-4804-9E96-D905D48D8B9F}"/>
+                <a16:creationId xmlns:a16="http://schemas.microsoft.com/office/drawing/2014/main" id="{BCF90E76-0CE9-450C-A68E-ABFAECFFB6A8}"/>
               </a:ext>
             </a:extLst>
           </p:cNvPr>
@@ -5755,7 +5755,7 @@
           <p:cNvPr id="6" name="">
             <a:extLst xmlns:a="http://schemas.openxmlformats.org/drawingml/2006/main">
               <a:ext uri="{FF2B5EF4-FFF2-40B4-BE49-F238E27FC236}">
-                <a16:creationId xmlns:a16="http://schemas.microsoft.com/office/drawing/2014/main" id="{6DF407AB-CF66-4656-B07C-D787F33E22B9}"/>
+                <a16:creationId xmlns:a16="http://schemas.microsoft.com/office/drawing/2014/main" id="{E0DBE46D-D35C-4AA4-B265-96AAA4D92730}"/>
               </a:ext>
             </a:extLst>
           </p:cNvPr>
@@ -5812,7 +5812,7 @@
           <p:cNvPr id="7" name="">
             <a:extLst xmlns:a="http://schemas.openxmlformats.org/drawingml/2006/main">
               <a:ext uri="{FF2B5EF4-FFF2-40B4-BE49-F238E27FC236}">
-                <a16:creationId xmlns:a16="http://schemas.microsoft.com/office/drawing/2014/main" id="{299F87C8-E620-4313-9A19-9C3B37562809}"/>
+                <a16:creationId xmlns:a16="http://schemas.microsoft.com/office/drawing/2014/main" id="{ADCA5E8C-6F7B-4DC0-95DC-7194A380B171}"/>
               </a:ext>
             </a:extLst>
           </p:cNvPr>
@@ -5869,7 +5869,7 @@
           <p:cNvPr id="8" name="">
             <a:extLst xmlns:a="http://schemas.openxmlformats.org/drawingml/2006/main">
               <a:ext uri="{FF2B5EF4-FFF2-40B4-BE49-F238E27FC236}">
-                <a16:creationId xmlns:a16="http://schemas.microsoft.com/office/drawing/2014/main" id="{25A0AA19-0E47-4968-9656-0D23ADB8885A}"/>
+                <a16:creationId xmlns:a16="http://schemas.microsoft.com/office/drawing/2014/main" id="{1F754ABE-5062-4486-9465-88BD46185AB6}"/>
               </a:ext>
             </a:extLst>
           </p:cNvPr>
@@ -5926,7 +5926,7 @@
           <p:cNvPr id="9" name="">
             <a:extLst xmlns:a="http://schemas.openxmlformats.org/drawingml/2006/main">
               <a:ext uri="{FF2B5EF4-FFF2-40B4-BE49-F238E27FC236}">
-                <a16:creationId xmlns:a16="http://schemas.microsoft.com/office/drawing/2014/main" id="{99C40FA6-432B-406D-BDD5-DFFB74E64694}"/>
+                <a16:creationId xmlns:a16="http://schemas.microsoft.com/office/drawing/2014/main" id="{65183C44-CC26-43EB-AFDA-974E7A5A484C}"/>
               </a:ext>
             </a:extLst>
           </p:cNvPr>
@@ -5983,7 +5983,7 @@
           <p:cNvPr id="10" name="">
             <a:extLst xmlns:a="http://schemas.openxmlformats.org/drawingml/2006/main">
               <a:ext uri="{FF2B5EF4-FFF2-40B4-BE49-F238E27FC236}">
-                <a16:creationId xmlns:a16="http://schemas.microsoft.com/office/drawing/2014/main" id="{CC941FDD-62A6-44DB-BBDA-A6080A4105B5}"/>
+                <a16:creationId xmlns:a16="http://schemas.microsoft.com/office/drawing/2014/main" id="{97DDCEE0-6601-43D8-8B0D-985D2166ABC5}"/>
               </a:ext>
             </a:extLst>
           </p:cNvPr>
@@ -6047,14 +6047,14 @@
         </p:xfrm>
         <a:graphic xmlns:a="http://schemas.openxmlformats.org/drawingml/2006/main">
           <a:graphicData uri="http://schemas.openxmlformats.org/drawingml/2006/chart">
-            <c:chart xmlns:r="http://schemas.openxmlformats.org/officeDocument/2006/relationships" xmlns:c="http://schemas.openxmlformats.org/drawingml/2006/chart" r:id="R437b7772241a48de"/>
+            <c:chart xmlns:r="http://schemas.openxmlformats.org/officeDocument/2006/relationships" xmlns:c="http://schemas.openxmlformats.org/drawingml/2006/chart" r:id="Rd081612c49e146ad"/>
           </a:graphicData>
         </a:graphic>
       </p:graphicFrame>
     </p:spTree>
     <p:extLst>
       <p:ext uri="{BB962C8B-B14F-4D97-AF65-F5344CB8AC3E}">
-        <p14:creationId xmlns:p14="http://schemas.microsoft.com/office/powerpoint/2010/main" val="2061989515"/>
+        <p14:creationId xmlns:p14="http://schemas.microsoft.com/office/powerpoint/2010/main" val="756316432"/>
       </p:ext>
     </p:extLst>
   </p:cSld>
@@ -6085,7 +6085,7 @@
           <p:cNvPr id="12" name="">
             <a:extLst xmlns:a="http://schemas.openxmlformats.org/drawingml/2006/main">
               <a:ext uri="{FF2B5EF4-FFF2-40B4-BE49-F238E27FC236}">
-                <a16:creationId xmlns:a16="http://schemas.microsoft.com/office/drawing/2014/main" id="{79B901D0-453F-46CB-9B15-DCA6100DCEF9}"/>
+                <a16:creationId xmlns:a16="http://schemas.microsoft.com/office/drawing/2014/main" id="{1FBD8026-2590-4828-8CAA-E5DA4C88BE03}"/>
               </a:ext>
             </a:extLst>
           </p:cNvPr>
@@ -6142,7 +6142,7 @@
           <p:cNvPr id="2" name="">
             <a:extLst xmlns:a="http://schemas.openxmlformats.org/drawingml/2006/main">
               <a:ext uri="{FF2B5EF4-FFF2-40B4-BE49-F238E27FC236}">
-                <a16:creationId xmlns:a16="http://schemas.microsoft.com/office/drawing/2014/main" id="{DFBB052E-26FB-4C39-9C62-0C6EA74AA046}"/>
+                <a16:creationId xmlns:a16="http://schemas.microsoft.com/office/drawing/2014/main" id="{EC8AA16F-55D6-49F6-A9B7-ED1443655EA5}"/>
               </a:ext>
             </a:extLst>
           </p:cNvPr>
@@ -6199,7 +6199,7 @@
           <p:cNvPr id="3" name="">
             <a:extLst xmlns:a="http://schemas.openxmlformats.org/drawingml/2006/main">
               <a:ext uri="{FF2B5EF4-FFF2-40B4-BE49-F238E27FC236}">
-                <a16:creationId xmlns:a16="http://schemas.microsoft.com/office/drawing/2014/main" id="{E1E5148F-40B9-46A4-9C57-953EE7F7D57C}"/>
+                <a16:creationId xmlns:a16="http://schemas.microsoft.com/office/drawing/2014/main" id="{BD81314F-28EC-480C-B0BF-9DF681C13870}"/>
               </a:ext>
             </a:extLst>
           </p:cNvPr>
@@ -6256,7 +6256,7 @@
           <p:cNvPr id="4" name="">
             <a:extLst xmlns:a="http://schemas.openxmlformats.org/drawingml/2006/main">
               <a:ext uri="{FF2B5EF4-FFF2-40B4-BE49-F238E27FC236}">
-                <a16:creationId xmlns:a16="http://schemas.microsoft.com/office/drawing/2014/main" id="{ED03F71F-EA84-4EC6-B679-57B5E31888C8}"/>
+                <a16:creationId xmlns:a16="http://schemas.microsoft.com/office/drawing/2014/main" id="{45A90282-230E-448D-85D6-211AEFF61C1D}"/>
               </a:ext>
             </a:extLst>
           </p:cNvPr>
@@ -6313,7 +6313,7 @@
           <p:cNvPr id="5" name="">
             <a:extLst xmlns:a="http://schemas.openxmlformats.org/drawingml/2006/main">
               <a:ext uri="{FF2B5EF4-FFF2-40B4-BE49-F238E27FC236}">
-                <a16:creationId xmlns:a16="http://schemas.microsoft.com/office/drawing/2014/main" id="{B36ECCA4-1B06-40E2-9D3D-564DC794497A}"/>
+                <a16:creationId xmlns:a16="http://schemas.microsoft.com/office/drawing/2014/main" id="{E2FA75E4-E97A-473C-A133-D5D69993A43A}"/>
               </a:ext>
             </a:extLst>
           </p:cNvPr>
@@ -6370,7 +6370,7 @@
           <p:cNvPr id="6" name="">
             <a:extLst xmlns:a="http://schemas.openxmlformats.org/drawingml/2006/main">
               <a:ext uri="{FF2B5EF4-FFF2-40B4-BE49-F238E27FC236}">
-                <a16:creationId xmlns:a16="http://schemas.microsoft.com/office/drawing/2014/main" id="{CEA38183-64BA-4FD2-A22B-F26D39F483BA}"/>
+                <a16:creationId xmlns:a16="http://schemas.microsoft.com/office/drawing/2014/main" id="{C0E548CB-7761-4BA4-A6E0-8E2C84CCEA48}"/>
               </a:ext>
             </a:extLst>
           </p:cNvPr>
@@ -6427,7 +6427,7 @@
           <p:cNvPr id="7" name="">
             <a:extLst xmlns:a="http://schemas.openxmlformats.org/drawingml/2006/main">
               <a:ext uri="{FF2B5EF4-FFF2-40B4-BE49-F238E27FC236}">
-                <a16:creationId xmlns:a16="http://schemas.microsoft.com/office/drawing/2014/main" id="{9246E134-75B8-4215-9C33-89111C0E685E}"/>
+                <a16:creationId xmlns:a16="http://schemas.microsoft.com/office/drawing/2014/main" id="{BC2F1513-900F-4FD3-813D-7414882D6098}"/>
               </a:ext>
             </a:extLst>
           </p:cNvPr>
@@ -6484,7 +6484,7 @@
           <p:cNvPr id="8" name="">
             <a:extLst xmlns:a="http://schemas.openxmlformats.org/drawingml/2006/main">
               <a:ext uri="{FF2B5EF4-FFF2-40B4-BE49-F238E27FC236}">
-                <a16:creationId xmlns:a16="http://schemas.microsoft.com/office/drawing/2014/main" id="{E13069B7-CB06-4EB7-B3FC-2A395E6B5ED5}"/>
+                <a16:creationId xmlns:a16="http://schemas.microsoft.com/office/drawing/2014/main" id="{2B667EB9-CCA1-4F60-A705-A484C0F3BFD0}"/>
               </a:ext>
             </a:extLst>
           </p:cNvPr>
@@ -6541,7 +6541,7 @@
           <p:cNvPr id="9" name="">
             <a:extLst xmlns:a="http://schemas.openxmlformats.org/drawingml/2006/main">
               <a:ext uri="{FF2B5EF4-FFF2-40B4-BE49-F238E27FC236}">
-                <a16:creationId xmlns:a16="http://schemas.microsoft.com/office/drawing/2014/main" id="{83933070-E104-49E7-A1B4-5276BAC2B2BE}"/>
+                <a16:creationId xmlns:a16="http://schemas.microsoft.com/office/drawing/2014/main" id="{6EFE1752-D90B-46FD-9401-D7155DBF55B5}"/>
               </a:ext>
             </a:extLst>
           </p:cNvPr>
@@ -6598,7 +6598,7 @@
           <p:cNvPr id="10" name="">
             <a:extLst xmlns:a="http://schemas.openxmlformats.org/drawingml/2006/main">
               <a:ext uri="{FF2B5EF4-FFF2-40B4-BE49-F238E27FC236}">
-                <a16:creationId xmlns:a16="http://schemas.microsoft.com/office/drawing/2014/main" id="{4A1B3915-2040-4C81-BDB2-6EA919897D4E}"/>
+                <a16:creationId xmlns:a16="http://schemas.microsoft.com/office/drawing/2014/main" id="{03517748-4B63-453C-A15A-A7B8C8729DBA}"/>
               </a:ext>
             </a:extLst>
           </p:cNvPr>
@@ -6662,14 +6662,14 @@
         </p:xfrm>
         <a:graphic xmlns:a="http://schemas.openxmlformats.org/drawingml/2006/main">
           <a:graphicData uri="http://schemas.openxmlformats.org/drawingml/2006/chart">
-            <c:chart xmlns:r="http://schemas.openxmlformats.org/officeDocument/2006/relationships" xmlns:c="http://schemas.openxmlformats.org/drawingml/2006/chart" r:id="R134249e8bd05490e"/>
+            <c:chart xmlns:r="http://schemas.openxmlformats.org/officeDocument/2006/relationships" xmlns:c="http://schemas.openxmlformats.org/drawingml/2006/chart" r:id="Rdf89ecd57f694c0a"/>
           </a:graphicData>
         </a:graphic>
       </p:graphicFrame>
     </p:spTree>
     <p:extLst>
       <p:ext uri="{BB962C8B-B14F-4D97-AF65-F5344CB8AC3E}">
-        <p14:creationId xmlns:p14="http://schemas.microsoft.com/office/powerpoint/2010/main" val="1305999608"/>
+        <p14:creationId xmlns:p14="http://schemas.microsoft.com/office/powerpoint/2010/main" val="1559652239"/>
       </p:ext>
     </p:extLst>
   </p:cSld>
@@ -6700,7 +6700,7 @@
           <p:cNvPr id="16" name="">
             <a:extLst xmlns:a="http://schemas.openxmlformats.org/drawingml/2006/main">
               <a:ext uri="{FF2B5EF4-FFF2-40B4-BE49-F238E27FC236}">
-                <a16:creationId xmlns:a16="http://schemas.microsoft.com/office/drawing/2014/main" id="{2715EF15-8AF5-429A-BFC6-4B6E399CA98D}"/>
+                <a16:creationId xmlns:a16="http://schemas.microsoft.com/office/drawing/2014/main" id="{F465F83B-EFBD-4A92-A9DE-650B1EB43C60}"/>
               </a:ext>
             </a:extLst>
           </p:cNvPr>
@@ -6757,7 +6757,7 @@
           <p:cNvPr id="2" name="">
             <a:extLst xmlns:a="http://schemas.openxmlformats.org/drawingml/2006/main">
               <a:ext uri="{FF2B5EF4-FFF2-40B4-BE49-F238E27FC236}">
-                <a16:creationId xmlns:a16="http://schemas.microsoft.com/office/drawing/2014/main" id="{1BC9751C-C47E-4D50-A7A5-8A021C87E94B}"/>
+                <a16:creationId xmlns:a16="http://schemas.microsoft.com/office/drawing/2014/main" id="{59933248-A45A-42A0-A48E-7F316CF9AA2C}"/>
               </a:ext>
             </a:extLst>
           </p:cNvPr>
@@ -6814,7 +6814,7 @@
           <p:cNvPr id="3" name="">
             <a:extLst xmlns:a="http://schemas.openxmlformats.org/drawingml/2006/main">
               <a:ext uri="{FF2B5EF4-FFF2-40B4-BE49-F238E27FC236}">
-                <a16:creationId xmlns:a16="http://schemas.microsoft.com/office/drawing/2014/main" id="{86A0AB2F-8214-4403-B119-F0ADCDCDC726}"/>
+                <a16:creationId xmlns:a16="http://schemas.microsoft.com/office/drawing/2014/main" id="{D8CEEC41-09CE-4FD7-BD7F-F504081C604A}"/>
               </a:ext>
             </a:extLst>
           </p:cNvPr>
@@ -6871,7 +6871,7 @@
           <p:cNvPr id="4" name="">
             <a:extLst xmlns:a="http://schemas.openxmlformats.org/drawingml/2006/main">
               <a:ext uri="{FF2B5EF4-FFF2-40B4-BE49-F238E27FC236}">
-                <a16:creationId xmlns:a16="http://schemas.microsoft.com/office/drawing/2014/main" id="{0D8E42B8-93D5-4585-BAEA-3F5804FFFA89}"/>
+                <a16:creationId xmlns:a16="http://schemas.microsoft.com/office/drawing/2014/main" id="{E8D9E126-B578-4BEC-9AE7-F0BF6423B5E6}"/>
               </a:ext>
             </a:extLst>
           </p:cNvPr>
@@ -6935,7 +6935,7 @@
         </p:xfrm>
         <a:graphic xmlns:a="http://schemas.openxmlformats.org/drawingml/2006/main">
           <a:graphicData uri="http://schemas.openxmlformats.org/drawingml/2006/chart">
-            <c:chart xmlns:r="http://schemas.openxmlformats.org/officeDocument/2006/relationships" xmlns:c="http://schemas.openxmlformats.org/drawingml/2006/chart" r:id="R6472b465f9f6477e"/>
+            <c:chart xmlns:r="http://schemas.openxmlformats.org/officeDocument/2006/relationships" xmlns:c="http://schemas.openxmlformats.org/drawingml/2006/chart" r:id="Rbce2f6d43e9a4704"/>
           </a:graphicData>
         </a:graphic>
       </p:graphicFrame>
@@ -6944,7 +6944,7 @@
           <p:cNvPr id="6" name="">
             <a:extLst xmlns:a="http://schemas.openxmlformats.org/drawingml/2006/main">
               <a:ext uri="{FF2B5EF4-FFF2-40B4-BE49-F238E27FC236}">
-                <a16:creationId xmlns:a16="http://schemas.microsoft.com/office/drawing/2014/main" id="{CBC414AD-BCEB-47E3-931A-9A16882594C3}"/>
+                <a16:creationId xmlns:a16="http://schemas.microsoft.com/office/drawing/2014/main" id="{1EE9FEC8-4275-4B1D-BCCB-B31445495DFD}"/>
               </a:ext>
             </a:extLst>
           </p:cNvPr>
@@ -6991,7 +6991,7 @@
                 <a:ea typeface="Heiti TC"/>
                 <a:cs typeface="Heiti TC"/>
               </a:rPr>
-              <a:t>y 隨 x 增加</a:t>
+              <a:t>x 增加時，y 增加</a:t>
             </a:r>
           </a:p>
         </p:txBody>
@@ -7001,7 +7001,7 @@
           <p:cNvPr id="7" name="">
             <a:extLst xmlns:a="http://schemas.openxmlformats.org/drawingml/2006/main">
               <a:ext uri="{FF2B5EF4-FFF2-40B4-BE49-F238E27FC236}">
-                <a16:creationId xmlns:a16="http://schemas.microsoft.com/office/drawing/2014/main" id="{489E4962-ED85-4F57-A46D-D2FDE1B49CBD}"/>
+                <a16:creationId xmlns:a16="http://schemas.microsoft.com/office/drawing/2014/main" id="{956C7538-5DEE-481E-A07B-7CF38096474C}"/>
               </a:ext>
             </a:extLst>
           </p:cNvPr>
@@ -7058,7 +7058,7 @@
           <p:cNvPr id="8" name="">
             <a:extLst xmlns:a="http://schemas.openxmlformats.org/drawingml/2006/main">
               <a:ext uri="{FF2B5EF4-FFF2-40B4-BE49-F238E27FC236}">
-                <a16:creationId xmlns:a16="http://schemas.microsoft.com/office/drawing/2014/main" id="{72D9EDEF-3A51-46C3-9047-911C03779591}"/>
+                <a16:creationId xmlns:a16="http://schemas.microsoft.com/office/drawing/2014/main" id="{70598DEF-051A-46DB-BB14-9D792D23B36F}"/>
               </a:ext>
             </a:extLst>
           </p:cNvPr>
@@ -7122,7 +7122,7 @@
         </p:xfrm>
         <a:graphic xmlns:a="http://schemas.openxmlformats.org/drawingml/2006/main">
           <a:graphicData uri="http://schemas.openxmlformats.org/drawingml/2006/chart">
-            <c:chart xmlns:r="http://schemas.openxmlformats.org/officeDocument/2006/relationships" xmlns:c="http://schemas.openxmlformats.org/drawingml/2006/chart" r:id="R7186cbb7785b4111"/>
+            <c:chart xmlns:r="http://schemas.openxmlformats.org/officeDocument/2006/relationships" xmlns:c="http://schemas.openxmlformats.org/drawingml/2006/chart" r:id="Rbb77ad60d249471d"/>
           </a:graphicData>
         </a:graphic>
       </p:graphicFrame>
@@ -7131,7 +7131,7 @@
           <p:cNvPr id="10" name="">
             <a:extLst xmlns:a="http://schemas.openxmlformats.org/drawingml/2006/main">
               <a:ext uri="{FF2B5EF4-FFF2-40B4-BE49-F238E27FC236}">
-                <a16:creationId xmlns:a16="http://schemas.microsoft.com/office/drawing/2014/main" id="{AC480601-5E95-4B25-94AA-F79AC7ACF7CE}"/>
+                <a16:creationId xmlns:a16="http://schemas.microsoft.com/office/drawing/2014/main" id="{EBBF604D-0FD6-4B0F-B2E0-08EB13570835}"/>
               </a:ext>
             </a:extLst>
           </p:cNvPr>
@@ -7178,7 +7178,7 @@
                 <a:ea typeface="Heiti TC"/>
                 <a:cs typeface="Heiti TC"/>
               </a:rPr>
-              <a:t>y 隨 x 減少</a:t>
+              <a:t>x 增加時，y 減少</a:t>
             </a:r>
           </a:p>
         </p:txBody>
@@ -7188,7 +7188,7 @@
           <p:cNvPr id="11" name="">
             <a:extLst xmlns:a="http://schemas.openxmlformats.org/drawingml/2006/main">
               <a:ext uri="{FF2B5EF4-FFF2-40B4-BE49-F238E27FC236}">
-                <a16:creationId xmlns:a16="http://schemas.microsoft.com/office/drawing/2014/main" id="{0D2F9024-44A6-44DE-B045-EA1E9EF2699C}"/>
+                <a16:creationId xmlns:a16="http://schemas.microsoft.com/office/drawing/2014/main" id="{0D89643F-837E-4DF0-9B40-7CC4B8A56866}"/>
               </a:ext>
             </a:extLst>
           </p:cNvPr>
@@ -7245,7 +7245,7 @@
           <p:cNvPr id="12" name="">
             <a:extLst xmlns:a="http://schemas.openxmlformats.org/drawingml/2006/main">
               <a:ext uri="{FF2B5EF4-FFF2-40B4-BE49-F238E27FC236}">
-                <a16:creationId xmlns:a16="http://schemas.microsoft.com/office/drawing/2014/main" id="{FB8C8DCE-7A0C-4D88-957B-1C1F46AF783B}"/>
+                <a16:creationId xmlns:a16="http://schemas.microsoft.com/office/drawing/2014/main" id="{AF3D9E7A-CB7F-4FFC-BD68-6EC1F1A3A7AB}"/>
               </a:ext>
             </a:extLst>
           </p:cNvPr>
@@ -7309,7 +7309,7 @@
         </p:xfrm>
         <a:graphic xmlns:a="http://schemas.openxmlformats.org/drawingml/2006/main">
           <a:graphicData uri="http://schemas.openxmlformats.org/drawingml/2006/chart">
-            <c:chart xmlns:r="http://schemas.openxmlformats.org/officeDocument/2006/relationships" xmlns:c="http://schemas.openxmlformats.org/drawingml/2006/chart" r:id="R6590931fbe294bbf"/>
+            <c:chart xmlns:r="http://schemas.openxmlformats.org/officeDocument/2006/relationships" xmlns:c="http://schemas.openxmlformats.org/drawingml/2006/chart" r:id="R7d4bd9560a0d45af"/>
           </a:graphicData>
         </a:graphic>
       </p:graphicFrame>
@@ -7318,7 +7318,7 @@
           <p:cNvPr id="14" name="">
             <a:extLst xmlns:a="http://schemas.openxmlformats.org/drawingml/2006/main">
               <a:ext uri="{FF2B5EF4-FFF2-40B4-BE49-F238E27FC236}">
-                <a16:creationId xmlns:a16="http://schemas.microsoft.com/office/drawing/2014/main" id="{AADCA33A-5A1B-4308-853D-EB534128E707}"/>
+                <a16:creationId xmlns:a16="http://schemas.microsoft.com/office/drawing/2014/main" id="{227DB007-0E19-42E1-8EE7-C87D59CB99AD}"/>
               </a:ext>
             </a:extLst>
           </p:cNvPr>
@@ -7375,7 +7375,7 @@
           <p:cNvPr id="15" name="">
             <a:extLst xmlns:a="http://schemas.openxmlformats.org/drawingml/2006/main">
               <a:ext uri="{FF2B5EF4-FFF2-40B4-BE49-F238E27FC236}">
-                <a16:creationId xmlns:a16="http://schemas.microsoft.com/office/drawing/2014/main" id="{B9ED2293-2579-4927-B369-8EE3086F1D13}"/>
+                <a16:creationId xmlns:a16="http://schemas.microsoft.com/office/drawing/2014/main" id="{384F2C32-5D8B-4F69-8B78-98A50D26A40B}"/>
               </a:ext>
             </a:extLst>
           </p:cNvPr>
@@ -7430,7 +7430,7 @@
     </p:spTree>
     <p:extLst>
       <p:ext uri="{BB962C8B-B14F-4D97-AF65-F5344CB8AC3E}">
-        <p14:creationId xmlns:p14="http://schemas.microsoft.com/office/powerpoint/2010/main" val="694792508"/>
+        <p14:creationId xmlns:p14="http://schemas.microsoft.com/office/powerpoint/2010/main" val="729908660"/>
       </p:ext>
     </p:extLst>
   </p:cSld>
@@ -7461,7 +7461,7 @@
           <p:cNvPr id="12" name="">
             <a:extLst xmlns:a="http://schemas.openxmlformats.org/drawingml/2006/main">
               <a:ext uri="{FF2B5EF4-FFF2-40B4-BE49-F238E27FC236}">
-                <a16:creationId xmlns:a16="http://schemas.microsoft.com/office/drawing/2014/main" id="{494BCED3-D681-4BED-8A39-6B09021DA280}"/>
+                <a16:creationId xmlns:a16="http://schemas.microsoft.com/office/drawing/2014/main" id="{CB91964F-02C5-42B7-BE1A-6C967C8ABB41}"/>
               </a:ext>
             </a:extLst>
           </p:cNvPr>
@@ -7518,7 +7518,7 @@
           <p:cNvPr id="2" name="">
             <a:extLst xmlns:a="http://schemas.openxmlformats.org/drawingml/2006/main">
               <a:ext uri="{FF2B5EF4-FFF2-40B4-BE49-F238E27FC236}">
-                <a16:creationId xmlns:a16="http://schemas.microsoft.com/office/drawing/2014/main" id="{AEEC5D00-9FD1-419F-9069-97FF9C5A2C18}"/>
+                <a16:creationId xmlns:a16="http://schemas.microsoft.com/office/drawing/2014/main" id="{86885D8E-934A-4A1F-AFB6-4AC0880D8649}"/>
               </a:ext>
             </a:extLst>
           </p:cNvPr>
@@ -7575,7 +7575,7 @@
           <p:cNvPr id="3" name="">
             <a:extLst xmlns:a="http://schemas.openxmlformats.org/drawingml/2006/main">
               <a:ext uri="{FF2B5EF4-FFF2-40B4-BE49-F238E27FC236}">
-                <a16:creationId xmlns:a16="http://schemas.microsoft.com/office/drawing/2014/main" id="{E7C11BBE-8B67-453A-A2D5-2C032F4D6EEB}"/>
+                <a16:creationId xmlns:a16="http://schemas.microsoft.com/office/drawing/2014/main" id="{9BAAE1AA-B8F1-4E16-8D7F-2EC02F971551}"/>
               </a:ext>
             </a:extLst>
           </p:cNvPr>
@@ -7639,7 +7639,7 @@
         </p:xfrm>
         <a:graphic xmlns:a="http://schemas.openxmlformats.org/drawingml/2006/main">
           <a:graphicData uri="http://schemas.openxmlformats.org/drawingml/2006/chart">
-            <c:chart xmlns:r="http://schemas.openxmlformats.org/officeDocument/2006/relationships" xmlns:c="http://schemas.openxmlformats.org/drawingml/2006/chart" r:id="R9c86b687b451473a"/>
+            <c:chart xmlns:r="http://schemas.openxmlformats.org/officeDocument/2006/relationships" xmlns:c="http://schemas.openxmlformats.org/drawingml/2006/chart" r:id="Rd69588eb4c88401e"/>
           </a:graphicData>
         </a:graphic>
       </p:graphicFrame>
@@ -7648,7 +7648,7 @@
           <p:cNvPr id="5" name="">
             <a:extLst xmlns:a="http://schemas.openxmlformats.org/drawingml/2006/main">
               <a:ext uri="{FF2B5EF4-FFF2-40B4-BE49-F238E27FC236}">
-                <a16:creationId xmlns:a16="http://schemas.microsoft.com/office/drawing/2014/main" id="{2FC8F212-160C-4897-A606-C25CA2A0304E}"/>
+                <a16:creationId xmlns:a16="http://schemas.microsoft.com/office/drawing/2014/main" id="{65664E81-3162-40DD-A3C3-47ABF521D70F}"/>
               </a:ext>
             </a:extLst>
           </p:cNvPr>
@@ -7705,7 +7705,7 @@
           <p:cNvPr id="6" name="">
             <a:extLst xmlns:a="http://schemas.openxmlformats.org/drawingml/2006/main">
               <a:ext uri="{FF2B5EF4-FFF2-40B4-BE49-F238E27FC236}">
-                <a16:creationId xmlns:a16="http://schemas.microsoft.com/office/drawing/2014/main" id="{AB2EDD67-0EFD-4E9B-9A83-CFBD53429DA0}"/>
+                <a16:creationId xmlns:a16="http://schemas.microsoft.com/office/drawing/2014/main" id="{C90463C8-3725-46CB-A8DA-49C485E8837F}"/>
               </a:ext>
             </a:extLst>
           </p:cNvPr>
@@ -7762,7 +7762,7 @@
           <p:cNvPr id="7" name="">
             <a:extLst xmlns:a="http://schemas.openxmlformats.org/drawingml/2006/main">
               <a:ext uri="{FF2B5EF4-FFF2-40B4-BE49-F238E27FC236}">
-                <a16:creationId xmlns:a16="http://schemas.microsoft.com/office/drawing/2014/main" id="{9DCBCD52-0FA7-4BC2-B640-77923F319CE9}"/>
+                <a16:creationId xmlns:a16="http://schemas.microsoft.com/office/drawing/2014/main" id="{3FF0F457-850C-4828-8181-ED7360A645E4}"/>
               </a:ext>
             </a:extLst>
           </p:cNvPr>
@@ -7819,7 +7819,7 @@
           <p:cNvPr id="8" name="">
             <a:extLst xmlns:a="http://schemas.openxmlformats.org/drawingml/2006/main">
               <a:ext uri="{FF2B5EF4-FFF2-40B4-BE49-F238E27FC236}">
-                <a16:creationId xmlns:a16="http://schemas.microsoft.com/office/drawing/2014/main" id="{EC49F744-1635-4C28-95DE-1FE20D7A47D4}"/>
+                <a16:creationId xmlns:a16="http://schemas.microsoft.com/office/drawing/2014/main" id="{F0777A6C-D779-4C3C-BB50-15390E3C9FA1}"/>
               </a:ext>
             </a:extLst>
           </p:cNvPr>
@@ -7876,7 +7876,7 @@
           <p:cNvPr id="9" name="">
             <a:extLst xmlns:a="http://schemas.openxmlformats.org/drawingml/2006/main">
               <a:ext uri="{FF2B5EF4-FFF2-40B4-BE49-F238E27FC236}">
-                <a16:creationId xmlns:a16="http://schemas.microsoft.com/office/drawing/2014/main" id="{689E6B8B-5568-497F-B656-FE72114E698E}"/>
+                <a16:creationId xmlns:a16="http://schemas.microsoft.com/office/drawing/2014/main" id="{642A0C54-7040-47D8-B62E-09F89A8025A6}"/>
               </a:ext>
             </a:extLst>
           </p:cNvPr>
@@ -7933,7 +7933,7 @@
           <p:cNvPr id="10" name="">
             <a:extLst xmlns:a="http://schemas.openxmlformats.org/drawingml/2006/main">
               <a:ext uri="{FF2B5EF4-FFF2-40B4-BE49-F238E27FC236}">
-                <a16:creationId xmlns:a16="http://schemas.microsoft.com/office/drawing/2014/main" id="{17B3394E-EF69-484F-8C8C-7B8D427754A9}"/>
+                <a16:creationId xmlns:a16="http://schemas.microsoft.com/office/drawing/2014/main" id="{875F9C19-9EDA-4D70-A973-63A84E4C7F16}"/>
               </a:ext>
             </a:extLst>
           </p:cNvPr>
@@ -7990,7 +7990,7 @@
           <p:cNvPr id="11" name="">
             <a:extLst xmlns:a="http://schemas.openxmlformats.org/drawingml/2006/main">
               <a:ext uri="{FF2B5EF4-FFF2-40B4-BE49-F238E27FC236}">
-                <a16:creationId xmlns:a16="http://schemas.microsoft.com/office/drawing/2014/main" id="{9251C5AC-F279-4D30-8606-40DC5845BA76}"/>
+                <a16:creationId xmlns:a16="http://schemas.microsoft.com/office/drawing/2014/main" id="{A99C36B5-84DE-45AA-BA2A-BFEDB090A1E7}"/>
               </a:ext>
             </a:extLst>
           </p:cNvPr>
@@ -8045,7 +8045,7 @@
     </p:spTree>
     <p:extLst>
       <p:ext uri="{BB962C8B-B14F-4D97-AF65-F5344CB8AC3E}">
-        <p14:creationId xmlns:p14="http://schemas.microsoft.com/office/powerpoint/2010/main" val="381958116"/>
+        <p14:creationId xmlns:p14="http://schemas.microsoft.com/office/powerpoint/2010/main" val="622732196"/>
       </p:ext>
     </p:extLst>
   </p:cSld>
@@ -8076,7 +8076,7 @@
           <p:cNvPr id="12" name="">
             <a:extLst xmlns:a="http://schemas.openxmlformats.org/drawingml/2006/main">
               <a:ext uri="{FF2B5EF4-FFF2-40B4-BE49-F238E27FC236}">
-                <a16:creationId xmlns:a16="http://schemas.microsoft.com/office/drawing/2014/main" id="{2B9F5760-190A-4F51-801A-E141CE63A029}"/>
+                <a16:creationId xmlns:a16="http://schemas.microsoft.com/office/drawing/2014/main" id="{F33AAA4C-A100-47B1-85D6-9B8473B69219}"/>
               </a:ext>
             </a:extLst>
           </p:cNvPr>
@@ -8133,7 +8133,7 @@
           <p:cNvPr id="2" name="">
             <a:extLst xmlns:a="http://schemas.openxmlformats.org/drawingml/2006/main">
               <a:ext uri="{FF2B5EF4-FFF2-40B4-BE49-F238E27FC236}">
-                <a16:creationId xmlns:a16="http://schemas.microsoft.com/office/drawing/2014/main" id="{8B0ED192-1DF8-4A8C-9832-453450C97CAC}"/>
+                <a16:creationId xmlns:a16="http://schemas.microsoft.com/office/drawing/2014/main" id="{5E45DDA1-4D1F-4AEF-8A75-3332A7B10E41}"/>
               </a:ext>
             </a:extLst>
           </p:cNvPr>
@@ -8190,7 +8190,7 @@
           <p:cNvPr id="3" name="">
             <a:extLst xmlns:a="http://schemas.openxmlformats.org/drawingml/2006/main">
               <a:ext uri="{FF2B5EF4-FFF2-40B4-BE49-F238E27FC236}">
-                <a16:creationId xmlns:a16="http://schemas.microsoft.com/office/drawing/2014/main" id="{9D62B75F-037B-4C87-8A70-E18AC69E2DC7}"/>
+                <a16:creationId xmlns:a16="http://schemas.microsoft.com/office/drawing/2014/main" id="{8E9A4095-87C2-46A0-8D24-92AB69478C5F}"/>
               </a:ext>
             </a:extLst>
           </p:cNvPr>
@@ -8254,7 +8254,7 @@
         </p:xfrm>
         <a:graphic xmlns:a="http://schemas.openxmlformats.org/drawingml/2006/main">
           <a:graphicData uri="http://schemas.openxmlformats.org/drawingml/2006/chart">
-            <c:chart xmlns:r="http://schemas.openxmlformats.org/officeDocument/2006/relationships" xmlns:c="http://schemas.openxmlformats.org/drawingml/2006/chart" r:id="Rfbde1cea682f4647"/>
+            <c:chart xmlns:r="http://schemas.openxmlformats.org/officeDocument/2006/relationships" xmlns:c="http://schemas.openxmlformats.org/drawingml/2006/chart" r:id="R374444d5c20b4b55"/>
           </a:graphicData>
         </a:graphic>
       </p:graphicFrame>
@@ -8263,7 +8263,7 @@
           <p:cNvPr id="5" name="">
             <a:extLst xmlns:a="http://schemas.openxmlformats.org/drawingml/2006/main">
               <a:ext uri="{FF2B5EF4-FFF2-40B4-BE49-F238E27FC236}">
-                <a16:creationId xmlns:a16="http://schemas.microsoft.com/office/drawing/2014/main" id="{BED7697F-9506-45C2-9AF4-E7BB376F23E7}"/>
+                <a16:creationId xmlns:a16="http://schemas.microsoft.com/office/drawing/2014/main" id="{8A2FCB5D-F9D5-46DC-A09D-AD4F2E8630A0}"/>
               </a:ext>
             </a:extLst>
           </p:cNvPr>
@@ -8320,7 +8320,7 @@
           <p:cNvPr id="6" name="">
             <a:extLst xmlns:a="http://schemas.openxmlformats.org/drawingml/2006/main">
               <a:ext uri="{FF2B5EF4-FFF2-40B4-BE49-F238E27FC236}">
-                <a16:creationId xmlns:a16="http://schemas.microsoft.com/office/drawing/2014/main" id="{AD82D457-EE91-4AD5-B1F9-727DB0B40E65}"/>
+                <a16:creationId xmlns:a16="http://schemas.microsoft.com/office/drawing/2014/main" id="{49B12DA0-E639-48E3-A645-9AA68A765724}"/>
               </a:ext>
             </a:extLst>
           </p:cNvPr>
@@ -8377,7 +8377,7 @@
           <p:cNvPr id="7" name="">
             <a:extLst xmlns:a="http://schemas.openxmlformats.org/drawingml/2006/main">
               <a:ext uri="{FF2B5EF4-FFF2-40B4-BE49-F238E27FC236}">
-                <a16:creationId xmlns:a16="http://schemas.microsoft.com/office/drawing/2014/main" id="{DB49A7D1-0429-4BD5-84BF-B6C2033148D2}"/>
+                <a16:creationId xmlns:a16="http://schemas.microsoft.com/office/drawing/2014/main" id="{17270E97-A127-4D6A-A11A-9CDB4E0F8A2C}"/>
               </a:ext>
             </a:extLst>
           </p:cNvPr>
@@ -8434,7 +8434,7 @@
           <p:cNvPr id="8" name="">
             <a:extLst xmlns:a="http://schemas.openxmlformats.org/drawingml/2006/main">
               <a:ext uri="{FF2B5EF4-FFF2-40B4-BE49-F238E27FC236}">
-                <a16:creationId xmlns:a16="http://schemas.microsoft.com/office/drawing/2014/main" id="{4A6978EC-9EAE-49D4-899D-73DE7B4453EA}"/>
+                <a16:creationId xmlns:a16="http://schemas.microsoft.com/office/drawing/2014/main" id="{CB02927B-7217-4474-BE86-EF6D4B8FE737}"/>
               </a:ext>
             </a:extLst>
           </p:cNvPr>
@@ -8491,7 +8491,7 @@
           <p:cNvPr id="9" name="">
             <a:extLst xmlns:a="http://schemas.openxmlformats.org/drawingml/2006/main">
               <a:ext uri="{FF2B5EF4-FFF2-40B4-BE49-F238E27FC236}">
-                <a16:creationId xmlns:a16="http://schemas.microsoft.com/office/drawing/2014/main" id="{15208FB1-BFD1-4396-AE3C-BE8A9E409963}"/>
+                <a16:creationId xmlns:a16="http://schemas.microsoft.com/office/drawing/2014/main" id="{763A8ACE-651B-4614-9F1A-D420346B2993}"/>
               </a:ext>
             </a:extLst>
           </p:cNvPr>
@@ -8548,7 +8548,7 @@
           <p:cNvPr id="10" name="">
             <a:extLst xmlns:a="http://schemas.openxmlformats.org/drawingml/2006/main">
               <a:ext uri="{FF2B5EF4-FFF2-40B4-BE49-F238E27FC236}">
-                <a16:creationId xmlns:a16="http://schemas.microsoft.com/office/drawing/2014/main" id="{913A8237-D9C7-4E64-A93C-9E40DC2797FE}"/>
+                <a16:creationId xmlns:a16="http://schemas.microsoft.com/office/drawing/2014/main" id="{66585A27-06B2-452E-B43B-540BBCF6BDA8}"/>
               </a:ext>
             </a:extLst>
           </p:cNvPr>
@@ -8605,7 +8605,7 @@
           <p:cNvPr id="11" name="">
             <a:extLst xmlns:a="http://schemas.openxmlformats.org/drawingml/2006/main">
               <a:ext uri="{FF2B5EF4-FFF2-40B4-BE49-F238E27FC236}">
-                <a16:creationId xmlns:a16="http://schemas.microsoft.com/office/drawing/2014/main" id="{CC30512D-7C01-4554-A240-A5DA83B5B266}"/>
+                <a16:creationId xmlns:a16="http://schemas.microsoft.com/office/drawing/2014/main" id="{7243442C-F84B-411C-9AD4-D67E9180CBD8}"/>
               </a:ext>
             </a:extLst>
           </p:cNvPr>
@@ -8660,7 +8660,7 @@
     </p:spTree>
     <p:extLst>
       <p:ext uri="{BB962C8B-B14F-4D97-AF65-F5344CB8AC3E}">
-        <p14:creationId xmlns:p14="http://schemas.microsoft.com/office/powerpoint/2010/main" val="2014950798"/>
+        <p14:creationId xmlns:p14="http://schemas.microsoft.com/office/powerpoint/2010/main" val="1046792545"/>
       </p:ext>
     </p:extLst>
   </p:cSld>
@@ -8691,7 +8691,7 @@
           <p:cNvPr id="12" name="">
             <a:extLst xmlns:a="http://schemas.openxmlformats.org/drawingml/2006/main">
               <a:ext uri="{FF2B5EF4-FFF2-40B4-BE49-F238E27FC236}">
-                <a16:creationId xmlns:a16="http://schemas.microsoft.com/office/drawing/2014/main" id="{F746C1DB-A860-4F1C-B806-E756D4CF959C}"/>
+                <a16:creationId xmlns:a16="http://schemas.microsoft.com/office/drawing/2014/main" id="{E4853508-A120-43D2-AF14-48474E08D374}"/>
               </a:ext>
             </a:extLst>
           </p:cNvPr>
@@ -8748,7 +8748,7 @@
           <p:cNvPr id="2" name="">
             <a:extLst xmlns:a="http://schemas.openxmlformats.org/drawingml/2006/main">
               <a:ext uri="{FF2B5EF4-FFF2-40B4-BE49-F238E27FC236}">
-                <a16:creationId xmlns:a16="http://schemas.microsoft.com/office/drawing/2014/main" id="{C3BC3C8C-4E9E-49D6-8707-44A3A4CBF6B5}"/>
+                <a16:creationId xmlns:a16="http://schemas.microsoft.com/office/drawing/2014/main" id="{E26C3A5C-1EBA-41FC-9314-1C4A4E3E3F2C}"/>
               </a:ext>
             </a:extLst>
           </p:cNvPr>
@@ -8805,7 +8805,7 @@
           <p:cNvPr id="3" name="">
             <a:extLst xmlns:a="http://schemas.openxmlformats.org/drawingml/2006/main">
               <a:ext uri="{FF2B5EF4-FFF2-40B4-BE49-F238E27FC236}">
-                <a16:creationId xmlns:a16="http://schemas.microsoft.com/office/drawing/2014/main" id="{B5DA83A7-A25B-494D-9C72-EF8DD4D0F0D1}"/>
+                <a16:creationId xmlns:a16="http://schemas.microsoft.com/office/drawing/2014/main" id="{F7DAE845-2A9C-4824-80AE-8F7A1720FA7D}"/>
               </a:ext>
             </a:extLst>
           </p:cNvPr>
@@ -8862,7 +8862,7 @@
           <p:cNvPr id="4" name="">
             <a:extLst xmlns:a="http://schemas.openxmlformats.org/drawingml/2006/main">
               <a:ext uri="{FF2B5EF4-FFF2-40B4-BE49-F238E27FC236}">
-                <a16:creationId xmlns:a16="http://schemas.microsoft.com/office/drawing/2014/main" id="{608F5465-E9C3-453B-B7B0-4A874BAB7B31}"/>
+                <a16:creationId xmlns:a16="http://schemas.microsoft.com/office/drawing/2014/main" id="{ABEFDF6A-E65C-4A5A-9EE9-A88E6FA5EB09}"/>
               </a:ext>
             </a:extLst>
           </p:cNvPr>
@@ -8919,7 +8919,7 @@
           <p:cNvPr id="5" name="">
             <a:extLst xmlns:a="http://schemas.openxmlformats.org/drawingml/2006/main">
               <a:ext uri="{FF2B5EF4-FFF2-40B4-BE49-F238E27FC236}">
-                <a16:creationId xmlns:a16="http://schemas.microsoft.com/office/drawing/2014/main" id="{14F06F07-3B8C-456B-81C2-43B8D24EDF69}"/>
+                <a16:creationId xmlns:a16="http://schemas.microsoft.com/office/drawing/2014/main" id="{28EF7F48-78F2-48C5-970D-043087E2B5BA}"/>
               </a:ext>
             </a:extLst>
           </p:cNvPr>
@@ -8976,7 +8976,7 @@
           <p:cNvPr id="6" name="">
             <a:extLst xmlns:a="http://schemas.openxmlformats.org/drawingml/2006/main">
               <a:ext uri="{FF2B5EF4-FFF2-40B4-BE49-F238E27FC236}">
-                <a16:creationId xmlns:a16="http://schemas.microsoft.com/office/drawing/2014/main" id="{CC11CDEA-95B9-4285-B2B9-35FF31383D15}"/>
+                <a16:creationId xmlns:a16="http://schemas.microsoft.com/office/drawing/2014/main" id="{E5D47DF3-17CE-4E2C-8BA8-46E82836A202}"/>
               </a:ext>
             </a:extLst>
           </p:cNvPr>
@@ -9033,7 +9033,7 @@
           <p:cNvPr id="7" name="">
             <a:extLst xmlns:a="http://schemas.openxmlformats.org/drawingml/2006/main">
               <a:ext uri="{FF2B5EF4-FFF2-40B4-BE49-F238E27FC236}">
-                <a16:creationId xmlns:a16="http://schemas.microsoft.com/office/drawing/2014/main" id="{BE64A215-8BE4-4C82-9850-C96E333D0388}"/>
+                <a16:creationId xmlns:a16="http://schemas.microsoft.com/office/drawing/2014/main" id="{302424EB-8C6F-4F84-A111-7789F36B3626}"/>
               </a:ext>
             </a:extLst>
           </p:cNvPr>
@@ -9090,7 +9090,7 @@
           <p:cNvPr id="8" name="">
             <a:extLst xmlns:a="http://schemas.openxmlformats.org/drawingml/2006/main">
               <a:ext uri="{FF2B5EF4-FFF2-40B4-BE49-F238E27FC236}">
-                <a16:creationId xmlns:a16="http://schemas.microsoft.com/office/drawing/2014/main" id="{4FC67AF8-95C9-482C-9EE0-DA4A3E422E4E}"/>
+                <a16:creationId xmlns:a16="http://schemas.microsoft.com/office/drawing/2014/main" id="{A1AAF799-48C5-46CB-A509-D61D680FC6B9}"/>
               </a:ext>
             </a:extLst>
           </p:cNvPr>
@@ -9147,7 +9147,7 @@
           <p:cNvPr id="9" name="">
             <a:extLst xmlns:a="http://schemas.openxmlformats.org/drawingml/2006/main">
               <a:ext uri="{FF2B5EF4-FFF2-40B4-BE49-F238E27FC236}">
-                <a16:creationId xmlns:a16="http://schemas.microsoft.com/office/drawing/2014/main" id="{04883810-44AF-4DFF-839F-5E48389E9655}"/>
+                <a16:creationId xmlns:a16="http://schemas.microsoft.com/office/drawing/2014/main" id="{4D15F433-63C0-43C2-939C-8E5AE9199530}"/>
               </a:ext>
             </a:extLst>
           </p:cNvPr>
@@ -9204,7 +9204,7 @@
           <p:cNvPr id="10" name="">
             <a:extLst xmlns:a="http://schemas.openxmlformats.org/drawingml/2006/main">
               <a:ext uri="{FF2B5EF4-FFF2-40B4-BE49-F238E27FC236}">
-                <a16:creationId xmlns:a16="http://schemas.microsoft.com/office/drawing/2014/main" id="{8676299C-58AC-4437-9629-2F2D39A0DB01}"/>
+                <a16:creationId xmlns:a16="http://schemas.microsoft.com/office/drawing/2014/main" id="{1CFD6E0A-6949-44BA-B3F6-87FBC4FA7E7D}"/>
               </a:ext>
             </a:extLst>
           </p:cNvPr>
@@ -9261,7 +9261,7 @@
           <p:cNvPr id="11" name="">
             <a:extLst xmlns:a="http://schemas.openxmlformats.org/drawingml/2006/main">
               <a:ext uri="{FF2B5EF4-FFF2-40B4-BE49-F238E27FC236}">
-                <a16:creationId xmlns:a16="http://schemas.microsoft.com/office/drawing/2014/main" id="{3A2641F9-5C3E-48A4-9CA5-610CC995A2EE}"/>
+                <a16:creationId xmlns:a16="http://schemas.microsoft.com/office/drawing/2014/main" id="{BD3C3F9B-5BEA-42FB-8E89-C99D55DE7DE1}"/>
               </a:ext>
             </a:extLst>
           </p:cNvPr>
@@ -9316,7 +9316,7 @@
     </p:spTree>
     <p:extLst>
       <p:ext uri="{BB962C8B-B14F-4D97-AF65-F5344CB8AC3E}">
-        <p14:creationId xmlns:p14="http://schemas.microsoft.com/office/powerpoint/2010/main" val="732136842"/>
+        <p14:creationId xmlns:p14="http://schemas.microsoft.com/office/powerpoint/2010/main" val="1283191213"/>
       </p:ext>
     </p:extLst>
   </p:cSld>
@@ -9347,7 +9347,7 @@
           <p:cNvPr id="12" name="">
             <a:extLst xmlns:a="http://schemas.openxmlformats.org/drawingml/2006/main">
               <a:ext uri="{FF2B5EF4-FFF2-40B4-BE49-F238E27FC236}">
-                <a16:creationId xmlns:a16="http://schemas.microsoft.com/office/drawing/2014/main" id="{28E9C03A-0120-42B7-B529-DDEDCAC7787C}"/>
+                <a16:creationId xmlns:a16="http://schemas.microsoft.com/office/drawing/2014/main" id="{E3DC4E9F-9A0E-4BDA-9E7A-1DFCC7E60567}"/>
               </a:ext>
             </a:extLst>
           </p:cNvPr>
@@ -9404,7 +9404,7 @@
           <p:cNvPr id="2" name="">
             <a:extLst xmlns:a="http://schemas.openxmlformats.org/drawingml/2006/main">
               <a:ext uri="{FF2B5EF4-FFF2-40B4-BE49-F238E27FC236}">
-                <a16:creationId xmlns:a16="http://schemas.microsoft.com/office/drawing/2014/main" id="{A6F75D8A-0F00-456B-A0AB-187188A281FA}"/>
+                <a16:creationId xmlns:a16="http://schemas.microsoft.com/office/drawing/2014/main" id="{9956538E-8B20-4E90-8AD2-48945CFC0D18}"/>
               </a:ext>
             </a:extLst>
           </p:cNvPr>
@@ -9461,7 +9461,7 @@
           <p:cNvPr id="3" name="">
             <a:extLst xmlns:a="http://schemas.openxmlformats.org/drawingml/2006/main">
               <a:ext uri="{FF2B5EF4-FFF2-40B4-BE49-F238E27FC236}">
-                <a16:creationId xmlns:a16="http://schemas.microsoft.com/office/drawing/2014/main" id="{5A77516B-4500-4592-AA24-EAE64B182087}"/>
+                <a16:creationId xmlns:a16="http://schemas.microsoft.com/office/drawing/2014/main" id="{9CD6CA66-FACB-4E6D-B62A-8F73BEB12F4A}"/>
               </a:ext>
             </a:extLst>
           </p:cNvPr>
@@ -9525,7 +9525,7 @@
         </p:xfrm>
         <a:graphic xmlns:a="http://schemas.openxmlformats.org/drawingml/2006/main">
           <a:graphicData uri="http://schemas.openxmlformats.org/drawingml/2006/chart">
-            <c:chart xmlns:r="http://schemas.openxmlformats.org/officeDocument/2006/relationships" xmlns:c="http://schemas.openxmlformats.org/drawingml/2006/chart" r:id="R4b9cf690c3614ac5"/>
+            <c:chart xmlns:r="http://schemas.openxmlformats.org/officeDocument/2006/relationships" xmlns:c="http://schemas.openxmlformats.org/drawingml/2006/chart" r:id="Rd9c2f89c20144c5f"/>
           </a:graphicData>
         </a:graphic>
       </p:graphicFrame>
@@ -9534,7 +9534,7 @@
           <p:cNvPr id="5" name="">
             <a:extLst xmlns:a="http://schemas.openxmlformats.org/drawingml/2006/main">
               <a:ext uri="{FF2B5EF4-FFF2-40B4-BE49-F238E27FC236}">
-                <a16:creationId xmlns:a16="http://schemas.microsoft.com/office/drawing/2014/main" id="{FCE16414-0839-4592-8BD2-2F293B27E67B}"/>
+                <a16:creationId xmlns:a16="http://schemas.microsoft.com/office/drawing/2014/main" id="{65D0F19A-7038-4958-830E-32A1FDF829D8}"/>
               </a:ext>
             </a:extLst>
           </p:cNvPr>
@@ -9591,7 +9591,7 @@
           <p:cNvPr id="6" name="">
             <a:extLst xmlns:a="http://schemas.openxmlformats.org/drawingml/2006/main">
               <a:ext uri="{FF2B5EF4-FFF2-40B4-BE49-F238E27FC236}">
-                <a16:creationId xmlns:a16="http://schemas.microsoft.com/office/drawing/2014/main" id="{1189F653-61E1-4AB6-9859-C423299EDE05}"/>
+                <a16:creationId xmlns:a16="http://schemas.microsoft.com/office/drawing/2014/main" id="{8093FFD8-E1E5-469D-AAB9-C4CDD1B653D3}"/>
               </a:ext>
             </a:extLst>
           </p:cNvPr>
@@ -9648,7 +9648,7 @@
           <p:cNvPr id="7" name="">
             <a:extLst xmlns:a="http://schemas.openxmlformats.org/drawingml/2006/main">
               <a:ext uri="{FF2B5EF4-FFF2-40B4-BE49-F238E27FC236}">
-                <a16:creationId xmlns:a16="http://schemas.microsoft.com/office/drawing/2014/main" id="{0A1D711A-1D59-47D5-B1C2-9FFD9B7EC15A}"/>
+                <a16:creationId xmlns:a16="http://schemas.microsoft.com/office/drawing/2014/main" id="{955F88C6-3ED1-47E6-82AC-468FD32F3D0E}"/>
               </a:ext>
             </a:extLst>
           </p:cNvPr>
@@ -9705,7 +9705,7 @@
           <p:cNvPr id="8" name="">
             <a:extLst xmlns:a="http://schemas.openxmlformats.org/drawingml/2006/main">
               <a:ext uri="{FF2B5EF4-FFF2-40B4-BE49-F238E27FC236}">
-                <a16:creationId xmlns:a16="http://schemas.microsoft.com/office/drawing/2014/main" id="{A8262DF9-6BBF-4981-BCC1-7B38FF546E18}"/>
+                <a16:creationId xmlns:a16="http://schemas.microsoft.com/office/drawing/2014/main" id="{3C085E7E-8F6B-4EB9-8656-A9D8F18BEFE1}"/>
               </a:ext>
             </a:extLst>
           </p:cNvPr>
@@ -9762,7 +9762,7 @@
           <p:cNvPr id="9" name="">
             <a:extLst xmlns:a="http://schemas.openxmlformats.org/drawingml/2006/main">
               <a:ext uri="{FF2B5EF4-FFF2-40B4-BE49-F238E27FC236}">
-                <a16:creationId xmlns:a16="http://schemas.microsoft.com/office/drawing/2014/main" id="{AF57AAAD-F41D-48C4-A37C-BDDF2F52E58B}"/>
+                <a16:creationId xmlns:a16="http://schemas.microsoft.com/office/drawing/2014/main" id="{A9139329-BD56-4EEB-A92F-DD2749ACE916}"/>
               </a:ext>
             </a:extLst>
           </p:cNvPr>
@@ -9819,7 +9819,7 @@
           <p:cNvPr id="10" name="">
             <a:extLst xmlns:a="http://schemas.openxmlformats.org/drawingml/2006/main">
               <a:ext uri="{FF2B5EF4-FFF2-40B4-BE49-F238E27FC236}">
-                <a16:creationId xmlns:a16="http://schemas.microsoft.com/office/drawing/2014/main" id="{CFC929E6-E84B-4CFE-A44B-1BAB7F8BCABC}"/>
+                <a16:creationId xmlns:a16="http://schemas.microsoft.com/office/drawing/2014/main" id="{6B75D627-77C1-4C07-AE56-D44AF8245B22}"/>
               </a:ext>
             </a:extLst>
           </p:cNvPr>
@@ -9876,7 +9876,7 @@
           <p:cNvPr id="11" name="">
             <a:extLst xmlns:a="http://schemas.openxmlformats.org/drawingml/2006/main">
               <a:ext uri="{FF2B5EF4-FFF2-40B4-BE49-F238E27FC236}">
-                <a16:creationId xmlns:a16="http://schemas.microsoft.com/office/drawing/2014/main" id="{A2D69B9D-0595-4AAA-AFEB-E79FF880EE3F}"/>
+                <a16:creationId xmlns:a16="http://schemas.microsoft.com/office/drawing/2014/main" id="{59D5E5EC-9BB2-4809-A628-5F63DE53E813}"/>
               </a:ext>
             </a:extLst>
           </p:cNvPr>
@@ -9931,7 +9931,7 @@
     </p:spTree>
     <p:extLst>
       <p:ext uri="{BB962C8B-B14F-4D97-AF65-F5344CB8AC3E}">
-        <p14:creationId xmlns:p14="http://schemas.microsoft.com/office/powerpoint/2010/main" val="651977194"/>
+        <p14:creationId xmlns:p14="http://schemas.microsoft.com/office/powerpoint/2010/main" val="457913810"/>
       </p:ext>
     </p:extLst>
   </p:cSld>
@@ -9962,7 +9962,7 @@
           <p:cNvPr id="15" name="">
             <a:extLst xmlns:a="http://schemas.openxmlformats.org/drawingml/2006/main">
               <a:ext uri="{FF2B5EF4-FFF2-40B4-BE49-F238E27FC236}">
-                <a16:creationId xmlns:a16="http://schemas.microsoft.com/office/drawing/2014/main" id="{64CA3DA0-0AB8-4C20-894E-CB8ACF3FDD5F}"/>
+                <a16:creationId xmlns:a16="http://schemas.microsoft.com/office/drawing/2014/main" id="{4466BF2E-F1DE-45B8-BCDA-1556F6157594}"/>
               </a:ext>
             </a:extLst>
           </p:cNvPr>
@@ -10019,7 +10019,7 @@
           <p:cNvPr id="2" name="">
             <a:extLst xmlns:a="http://schemas.openxmlformats.org/drawingml/2006/main">
               <a:ext uri="{FF2B5EF4-FFF2-40B4-BE49-F238E27FC236}">
-                <a16:creationId xmlns:a16="http://schemas.microsoft.com/office/drawing/2014/main" id="{F1F425B4-B1B6-43BF-B2C2-0FE7A094373E}"/>
+                <a16:creationId xmlns:a16="http://schemas.microsoft.com/office/drawing/2014/main" id="{2EC9EC55-88AE-4A59-8FCF-763AC23842B1}"/>
               </a:ext>
             </a:extLst>
           </p:cNvPr>
@@ -10076,7 +10076,7 @@
           <p:cNvPr id="3" name="">
             <a:extLst xmlns:a="http://schemas.openxmlformats.org/drawingml/2006/main">
               <a:ext uri="{FF2B5EF4-FFF2-40B4-BE49-F238E27FC236}">
-                <a16:creationId xmlns:a16="http://schemas.microsoft.com/office/drawing/2014/main" id="{7E31F2CB-3208-4CAB-B2D4-CD47C3034365}"/>
+                <a16:creationId xmlns:a16="http://schemas.microsoft.com/office/drawing/2014/main" id="{1BC7F1E7-545A-452A-847F-944481C50AF0}"/>
               </a:ext>
             </a:extLst>
           </p:cNvPr>
@@ -10133,7 +10133,7 @@
           <p:cNvPr id="4" name="">
             <a:extLst xmlns:a="http://schemas.openxmlformats.org/drawingml/2006/main">
               <a:ext uri="{FF2B5EF4-FFF2-40B4-BE49-F238E27FC236}">
-                <a16:creationId xmlns:a16="http://schemas.microsoft.com/office/drawing/2014/main" id="{D533A1DA-B729-4A76-ADCF-561AFEE81438}"/>
+                <a16:creationId xmlns:a16="http://schemas.microsoft.com/office/drawing/2014/main" id="{26B7DFD3-B09F-4787-BCBB-2965A9A18B7C}"/>
               </a:ext>
             </a:extLst>
           </p:cNvPr>
@@ -10190,7 +10190,7 @@
           <p:cNvPr id="5" name="">
             <a:extLst xmlns:a="http://schemas.openxmlformats.org/drawingml/2006/main">
               <a:ext uri="{FF2B5EF4-FFF2-40B4-BE49-F238E27FC236}">
-                <a16:creationId xmlns:a16="http://schemas.microsoft.com/office/drawing/2014/main" id="{32C3DB2E-CEA0-42C8-8F16-F000C677E385}"/>
+                <a16:creationId xmlns:a16="http://schemas.microsoft.com/office/drawing/2014/main" id="{B4D096D1-C947-4F5C-A971-D646D4D9AE27}"/>
               </a:ext>
             </a:extLst>
           </p:cNvPr>
@@ -10247,7 +10247,7 @@
           <p:cNvPr id="6" name="">
             <a:extLst xmlns:a="http://schemas.openxmlformats.org/drawingml/2006/main">
               <a:ext uri="{FF2B5EF4-FFF2-40B4-BE49-F238E27FC236}">
-                <a16:creationId xmlns:a16="http://schemas.microsoft.com/office/drawing/2014/main" id="{3C20D341-4874-4483-87B8-FF506CB515D7}"/>
+                <a16:creationId xmlns:a16="http://schemas.microsoft.com/office/drawing/2014/main" id="{E6119A6D-F59E-4021-8013-EA53C0AA0324}"/>
               </a:ext>
             </a:extLst>
           </p:cNvPr>
@@ -10294,7 +10294,7 @@
                 <a:ea typeface="Arial"/>
                 <a:cs typeface="Arial"/>
               </a:rPr>
-              <a:t>m = 2: about 2 more marks per extra hour</a:t>
+              <a:t>In this model, m = 2 marks per extra hour</a:t>
             </a:r>
           </a:p>
         </p:txBody>
@@ -10304,7 +10304,7 @@
           <p:cNvPr id="7" name="">
             <a:extLst xmlns:a="http://schemas.openxmlformats.org/drawingml/2006/main">
               <a:ext uri="{FF2B5EF4-FFF2-40B4-BE49-F238E27FC236}">
-                <a16:creationId xmlns:a16="http://schemas.microsoft.com/office/drawing/2014/main" id="{3F801363-A6FC-408E-81C0-9E781EEA3E3E}"/>
+                <a16:creationId xmlns:a16="http://schemas.microsoft.com/office/drawing/2014/main" id="{2EA57632-2557-431D-BB76-A7E22B5768F3}"/>
               </a:ext>
             </a:extLst>
           </p:cNvPr>
@@ -10361,7 +10361,7 @@
           <p:cNvPr id="8" name="">
             <a:extLst xmlns:a="http://schemas.openxmlformats.org/drawingml/2006/main">
               <a:ext uri="{FF2B5EF4-FFF2-40B4-BE49-F238E27FC236}">
-                <a16:creationId xmlns:a16="http://schemas.microsoft.com/office/drawing/2014/main" id="{A4E8B400-2D01-419B-90C2-E61D8F9DCB65}"/>
+                <a16:creationId xmlns:a16="http://schemas.microsoft.com/office/drawing/2014/main" id="{B9BBF76A-A319-4292-B928-9C36DBA6E37E}"/>
               </a:ext>
             </a:extLst>
           </p:cNvPr>
@@ -10418,7 +10418,7 @@
           <p:cNvPr id="9" name="">
             <a:extLst xmlns:a="http://schemas.openxmlformats.org/drawingml/2006/main">
               <a:ext uri="{FF2B5EF4-FFF2-40B4-BE49-F238E27FC236}">
-                <a16:creationId xmlns:a16="http://schemas.microsoft.com/office/drawing/2014/main" id="{8AB9928E-161E-4ECB-AF9B-14A602AAB5C1}"/>
+                <a16:creationId xmlns:a16="http://schemas.microsoft.com/office/drawing/2014/main" id="{0C78E2DA-B396-4620-9212-A70439E84988}"/>
               </a:ext>
             </a:extLst>
           </p:cNvPr>
@@ -10475,7 +10475,7 @@
           <p:cNvPr id="10" name="">
             <a:extLst xmlns:a="http://schemas.openxmlformats.org/drawingml/2006/main">
               <a:ext uri="{FF2B5EF4-FFF2-40B4-BE49-F238E27FC236}">
-                <a16:creationId xmlns:a16="http://schemas.microsoft.com/office/drawing/2014/main" id="{BDF9EB15-F4CF-4A0E-9199-03D2F20615D8}"/>
+                <a16:creationId xmlns:a16="http://schemas.microsoft.com/office/drawing/2014/main" id="{CDEF4228-4D19-44C6-BD40-0FC5B01BB250}"/>
               </a:ext>
             </a:extLst>
           </p:cNvPr>
@@ -10532,7 +10532,7 @@
           <p:cNvPr id="11" name="">
             <a:extLst xmlns:a="http://schemas.openxmlformats.org/drawingml/2006/main">
               <a:ext uri="{FF2B5EF4-FFF2-40B4-BE49-F238E27FC236}">
-                <a16:creationId xmlns:a16="http://schemas.microsoft.com/office/drawing/2014/main" id="{AB530495-445B-4D96-8619-FD319876366B}"/>
+                <a16:creationId xmlns:a16="http://schemas.microsoft.com/office/drawing/2014/main" id="{5E8C01E5-19DC-4EF3-ADFA-BE57413C8AF1}"/>
               </a:ext>
             </a:extLst>
           </p:cNvPr>
@@ -10589,7 +10589,7 @@
           <p:cNvPr id="12" name="">
             <a:extLst xmlns:a="http://schemas.openxmlformats.org/drawingml/2006/main">
               <a:ext uri="{FF2B5EF4-FFF2-40B4-BE49-F238E27FC236}">
-                <a16:creationId xmlns:a16="http://schemas.microsoft.com/office/drawing/2014/main" id="{4F2D89CE-A2B4-4D33-84D2-9B6C4B8B612A}"/>
+                <a16:creationId xmlns:a16="http://schemas.microsoft.com/office/drawing/2014/main" id="{0978DFED-C6DE-461A-985D-E3A8D4B35599}"/>
               </a:ext>
             </a:extLst>
           </p:cNvPr>
@@ -10646,7 +10646,7 @@
           <p:cNvPr id="13" name="">
             <a:extLst xmlns:a="http://schemas.openxmlformats.org/drawingml/2006/main">
               <a:ext uri="{FF2B5EF4-FFF2-40B4-BE49-F238E27FC236}">
-                <a16:creationId xmlns:a16="http://schemas.microsoft.com/office/drawing/2014/main" id="{CE10EDA2-02C3-46F2-BCA7-323BC18C4610}"/>
+                <a16:creationId xmlns:a16="http://schemas.microsoft.com/office/drawing/2014/main" id="{62C250AA-E2EF-47D8-AAFD-303F5323C6A2}"/>
               </a:ext>
             </a:extLst>
           </p:cNvPr>
@@ -10693,7 +10693,7 @@
                 <a:ea typeface="Heiti TC"/>
                 <a:cs typeface="Heiti TC"/>
               </a:rPr>
-              <a:t>10 超出觀察範圍，可能較不可靠。趨勢不保證個別結果。</a:t>
+              <a:t>10 小時超出觀察範圍。這些數據也不能證明，溫習會令分數上升。</a:t>
             </a:r>
           </a:p>
         </p:txBody>
@@ -10703,7 +10703,7 @@
           <p:cNvPr id="14" name="">
             <a:extLst xmlns:a="http://schemas.openxmlformats.org/drawingml/2006/main">
               <a:ext uri="{FF2B5EF4-FFF2-40B4-BE49-F238E27FC236}">
-                <a16:creationId xmlns:a16="http://schemas.microsoft.com/office/drawing/2014/main" id="{E40AFA05-865F-4C9D-A46A-228C271CEF62}"/>
+                <a16:creationId xmlns:a16="http://schemas.microsoft.com/office/drawing/2014/main" id="{91827B3E-7CFF-4E03-A174-B2269AA00D03}"/>
               </a:ext>
             </a:extLst>
           </p:cNvPr>
@@ -10750,7 +10750,7 @@
                 <a:ea typeface="Arial"/>
                 <a:cs typeface="Arial"/>
               </a:rPr>
-              <a:t>10 is outside the observed range. The trend does not guarantee an individual result.</a:t>
+              <a:t>10 hours is outside the data range. The data does not prove cause and effect.</a:t>
             </a:r>
           </a:p>
         </p:txBody>
@@ -10758,7 +10758,7 @@
     </p:spTree>
     <p:extLst>
       <p:ext uri="{BB962C8B-B14F-4D97-AF65-F5344CB8AC3E}">
-        <p14:creationId xmlns:p14="http://schemas.microsoft.com/office/powerpoint/2010/main" val="1655985118"/>
+        <p14:creationId xmlns:p14="http://schemas.microsoft.com/office/powerpoint/2010/main" val="1458926338"/>
       </p:ext>
     </p:extLst>
   </p:cSld>

</xml_diff>